<commit_message>
docs(presentacion): mantiene unicamente presentacion_datathon_oficial.pptx eliminando copias duplicadas
</commit_message>
<xml_diff>
--- a/presentacion_datathon_oficial.pptx
+++ b/presentacion_datathon_oficial.pptx
@@ -6967,10 +6967,6 @@
           </a:solidFill>
           <a:ln/>
         </p:spPr>
-        <p:txBody>
-          <a:bodyPr/>
-          <a:p/>
-        </p:txBody>
       </p:sp>
       <p:sp>
         <p:nvSpPr>
@@ -7027,10 +7023,6 @@
           </a:solidFill>
           <a:ln/>
         </p:spPr>
-        <p:txBody>
-          <a:bodyPr/>
-          <a:p/>
-        </p:txBody>
       </p:sp>
       <p:pic>
         <p:nvPicPr>
@@ -7125,10 +7117,6 @@
           </a:solidFill>
           <a:ln/>
         </p:spPr>
-        <p:txBody>
-          <a:bodyPr/>
-          <a:p/>
-        </p:txBody>
       </p:sp>
       <p:pic>
         <p:nvPicPr>
@@ -7223,10 +7211,6 @@
           </a:solidFill>
           <a:ln/>
         </p:spPr>
-        <p:txBody>
-          <a:bodyPr/>
-          <a:p/>
-        </p:txBody>
       </p:sp>
       <p:pic>
         <p:nvPicPr>
@@ -7323,10 +7307,6 @@
           </a:solidFill>
           <a:ln/>
         </p:spPr>
-        <p:txBody>
-          <a:bodyPr/>
-          <a:p/>
-        </p:txBody>
       </p:sp>
       <p:sp>
         <p:nvSpPr>
@@ -7383,10 +7363,6 @@
           </a:solidFill>
           <a:ln/>
         </p:spPr>
-        <p:txBody>
-          <a:bodyPr/>
-          <a:p/>
-        </p:txBody>
       </p:sp>
       <p:pic>
         <p:nvPicPr>
@@ -7481,10 +7457,6 @@
           </a:solidFill>
           <a:ln/>
         </p:spPr>
-        <p:txBody>
-          <a:bodyPr/>
-          <a:p/>
-        </p:txBody>
       </p:sp>
       <p:pic>
         <p:nvPicPr>
@@ -7579,10 +7551,6 @@
           </a:solidFill>
           <a:ln/>
         </p:spPr>
-        <p:txBody>
-          <a:bodyPr/>
-          <a:p/>
-        </p:txBody>
       </p:sp>
       <p:pic>
         <p:nvPicPr>
@@ -7677,10 +7645,6 @@
           </a:solidFill>
           <a:ln/>
         </p:spPr>
-        <p:txBody>
-          <a:bodyPr/>
-          <a:p/>
-        </p:txBody>
       </p:sp>
       <p:pic>
         <p:nvPicPr>
@@ -7727,14 +7691,32 @@
           <a:bodyPr wrap="square" lIns="0" tIns="0" rIns="0" bIns="0" rtlCol="0" anchor="t"/>
           <a:lstStyle/>
           <a:p>
-            <a:r>
-              <a:t>73 tests unitarios y de integración</a:t>
-            </a:r>
-          </a:p>
-          <a:p>
-            <a:r>
+            <a:pPr indent="0" marL="0">
+              <a:buNone/>
+            </a:pPr>
+            <a:r>
+              <a:rPr lang="en-US" sz="1600" b="1" dirty="0">
+                <a:solidFill>
+                  <a:schemeClr val="bg1"/>
+                </a:solidFill>
+              </a:rPr>
+              <a:t>36 tests unitarios y de integración</a:t>
+            </a:r>
+            <a:endParaRPr lang="en-US" sz="1600" dirty="0"/>
+          </a:p>
+          <a:p>
+            <a:pPr indent="0" marL="0">
+              <a:buNone/>
+            </a:pPr>
+            <a:r>
+              <a:rPr lang="en-US" sz="1400" dirty="0">
+                <a:solidFill>
+                  <a:schemeClr val="bg2"/>
+                </a:solidFill>
+              </a:rPr>
               <a:t>Auditan las 7 fugas posibles (L1 a L7) con pytest.</a:t>
             </a:r>
+            <a:endParaRPr lang="en-US" sz="1600" dirty="0"/>
           </a:p>
         </p:txBody>
       </p:sp>
@@ -14149,10 +14131,6 @@
           </a:solidFill>
           <a:ln/>
         </p:spPr>
-        <p:txBody>
-          <a:bodyPr/>
-          <a:p/>
-        </p:txBody>
       </p:sp>
       <p:sp>
         <p:nvSpPr>
@@ -14261,10 +14239,6 @@
           </a:solidFill>
           <a:ln/>
         </p:spPr>
-        <p:txBody>
-          <a:bodyPr/>
-          <a:p/>
-        </p:txBody>
       </p:sp>
       <p:sp>
         <p:nvSpPr>
@@ -14373,10 +14347,6 @@
           </a:solidFill>
           <a:ln/>
         </p:spPr>
-        <p:txBody>
-          <a:bodyPr/>
-          <a:p/>
-        </p:txBody>
       </p:sp>
       <p:sp>
         <p:nvSpPr>
@@ -14485,10 +14455,6 @@
           </a:solidFill>
           <a:ln/>
         </p:spPr>
-        <p:txBody>
-          <a:bodyPr/>
-          <a:p/>
-        </p:txBody>
       </p:sp>
       <p:sp>
         <p:nvSpPr>
@@ -14680,10 +14646,6 @@
           </a:solidFill>
           <a:ln/>
         </p:spPr>
-        <p:txBody>
-          <a:bodyPr/>
-          <a:p/>
-        </p:txBody>
       </p:sp>
       <p:sp>
         <p:nvSpPr>
@@ -14781,10 +14743,6 @@
           </a:solidFill>
           <a:ln/>
         </p:spPr>
-        <p:txBody>
-          <a:bodyPr/>
-          <a:p/>
-        </p:txBody>
       </p:sp>
       <p:sp>
         <p:nvSpPr>
@@ -14882,10 +14840,6 @@
           </a:solidFill>
           <a:ln/>
         </p:spPr>
-        <p:txBody>
-          <a:bodyPr/>
-          <a:p/>
-        </p:txBody>
       </p:sp>
       <p:sp>
         <p:nvSpPr>
@@ -14983,10 +14937,6 @@
           </a:solidFill>
           <a:ln/>
         </p:spPr>
-        <p:txBody>
-          <a:bodyPr/>
-          <a:p/>
-        </p:txBody>
       </p:sp>
       <p:sp>
         <p:nvSpPr>
@@ -15009,9 +14959,21 @@
           <a:bodyPr wrap="square" lIns="0" tIns="0" rIns="0" bIns="0" rtlCol="0" anchor="t"/>
           <a:lstStyle/>
           <a:p>
-            <a:r>
-              <a:t>73</a:t>
-            </a:r>
+            <a:pPr indent="0" marL="0">
+              <a:buNone/>
+            </a:pPr>
+            <a:r>
+              <a:rPr lang="en-US" sz="3800" b="1" dirty="0">
+                <a:solidFill>
+                  <a:schemeClr val="accent1"/>
+                </a:solidFill>
+                <a:latin typeface="+mj-lt" pitchFamily="34" charset="0"/>
+                <a:ea typeface="+mj-lt" pitchFamily="34" charset="-122"/>
+                <a:cs typeface="+mj-lt" pitchFamily="34" charset="-120"/>
+              </a:rPr>
+              <a:t>36</a:t>
+            </a:r>
+            <a:endParaRPr lang="en-US" sz="3800" dirty="0"/>
           </a:p>
         </p:txBody>
       </p:sp>

</xml_diff>

<commit_message>
docs(presentacion): actualiza métrica a 73 tests y cabecera en presentacion_datathon_oficial.pptx
</commit_message>
<xml_diff>
--- a/presentacion_datathon_oficial.pptx
+++ b/presentacion_datathon_oficial.pptx
@@ -6967,6 +6967,10 @@
           </a:solidFill>
           <a:ln/>
         </p:spPr>
+        <p:txBody>
+          <a:bodyPr/>
+          <a:p/>
+        </p:txBody>
       </p:sp>
       <p:sp>
         <p:nvSpPr>
@@ -7023,6 +7027,10 @@
           </a:solidFill>
           <a:ln/>
         </p:spPr>
+        <p:txBody>
+          <a:bodyPr/>
+          <a:p/>
+        </p:txBody>
       </p:sp>
       <p:pic>
         <p:nvPicPr>
@@ -7117,6 +7125,10 @@
           </a:solidFill>
           <a:ln/>
         </p:spPr>
+        <p:txBody>
+          <a:bodyPr/>
+          <a:p/>
+        </p:txBody>
       </p:sp>
       <p:pic>
         <p:nvPicPr>
@@ -7211,6 +7223,10 @@
           </a:solidFill>
           <a:ln/>
         </p:spPr>
+        <p:txBody>
+          <a:bodyPr/>
+          <a:p/>
+        </p:txBody>
       </p:sp>
       <p:pic>
         <p:nvPicPr>
@@ -7307,6 +7323,10 @@
           </a:solidFill>
           <a:ln/>
         </p:spPr>
+        <p:txBody>
+          <a:bodyPr/>
+          <a:p/>
+        </p:txBody>
       </p:sp>
       <p:sp>
         <p:nvSpPr>
@@ -7363,6 +7383,10 @@
           </a:solidFill>
           <a:ln/>
         </p:spPr>
+        <p:txBody>
+          <a:bodyPr/>
+          <a:p/>
+        </p:txBody>
       </p:sp>
       <p:pic>
         <p:nvPicPr>
@@ -7457,6 +7481,10 @@
           </a:solidFill>
           <a:ln/>
         </p:spPr>
+        <p:txBody>
+          <a:bodyPr/>
+          <a:p/>
+        </p:txBody>
       </p:sp>
       <p:pic>
         <p:nvPicPr>
@@ -7551,6 +7579,10 @@
           </a:solidFill>
           <a:ln/>
         </p:spPr>
+        <p:txBody>
+          <a:bodyPr/>
+          <a:p/>
+        </p:txBody>
       </p:sp>
       <p:pic>
         <p:nvPicPr>
@@ -7645,6 +7677,10 @@
           </a:solidFill>
           <a:ln/>
         </p:spPr>
+        <p:txBody>
+          <a:bodyPr/>
+          <a:p/>
+        </p:txBody>
       </p:sp>
       <p:pic>
         <p:nvPicPr>
@@ -7691,32 +7727,14 @@
           <a:bodyPr wrap="square" lIns="0" tIns="0" rIns="0" bIns="0" rtlCol="0" anchor="t"/>
           <a:lstStyle/>
           <a:p>
-            <a:pPr indent="0" marL="0">
-              <a:buNone/>
-            </a:pPr>
-            <a:r>
-              <a:rPr lang="en-US" sz="1600" b="1" dirty="0">
-                <a:solidFill>
-                  <a:schemeClr val="bg1"/>
-                </a:solidFill>
-              </a:rPr>
-              <a:t>36 tests unitarios y de integración</a:t>
-            </a:r>
-            <a:endParaRPr lang="en-US" sz="1600" dirty="0"/>
-          </a:p>
-          <a:p>
-            <a:pPr indent="0" marL="0">
-              <a:buNone/>
-            </a:pPr>
-            <a:r>
-              <a:rPr lang="en-US" sz="1400" dirty="0">
-                <a:solidFill>
-                  <a:schemeClr val="bg2"/>
-                </a:solidFill>
-              </a:rPr>
+            <a:r>
+              <a:t>73 tests unitarios y de integración</a:t>
+            </a:r>
+          </a:p>
+          <a:p>
+            <a:r>
               <a:t>Auditan las 7 fugas posibles (L1 a L7) con pytest.</a:t>
             </a:r>
-            <a:endParaRPr lang="en-US" sz="1600" dirty="0"/>
           </a:p>
         </p:txBody>
       </p:sp>
@@ -9075,18 +9093,9 @@
           <a:bodyPr wrap="square" lIns="0" tIns="0" rIns="0" bIns="0" rtlCol="0" anchor="t"/>
           <a:lstStyle/>
           <a:p>
-            <a:pPr algn="l" indent="0" marL="0">
-              <a:buNone/>
-            </a:pPr>
-            <a:r>
-              <a:rPr lang="en-US" sz="1200" b="1" spc="300" kern="0" dirty="0">
-                <a:solidFill>
-                  <a:schemeClr val="accent1"/>
-                </a:solidFill>
-              </a:rPr>
-              <a:t>ANEXO METODOLÓGICO</a:t>
-            </a:r>
-            <a:endParaRPr lang="en-US" sz="1200" dirty="0"/>
+            <a:r>
+              <a:t>12  ·  ANEXO METODOLÓGICO</a:t>
+            </a:r>
           </a:p>
         </p:txBody>
       </p:sp>
@@ -14131,6 +14140,10 @@
           </a:solidFill>
           <a:ln/>
         </p:spPr>
+        <p:txBody>
+          <a:bodyPr/>
+          <a:p/>
+        </p:txBody>
       </p:sp>
       <p:sp>
         <p:nvSpPr>
@@ -14239,6 +14252,10 @@
           </a:solidFill>
           <a:ln/>
         </p:spPr>
+        <p:txBody>
+          <a:bodyPr/>
+          <a:p/>
+        </p:txBody>
       </p:sp>
       <p:sp>
         <p:nvSpPr>
@@ -14347,6 +14364,10 @@
           </a:solidFill>
           <a:ln/>
         </p:spPr>
+        <p:txBody>
+          <a:bodyPr/>
+          <a:p/>
+        </p:txBody>
       </p:sp>
       <p:sp>
         <p:nvSpPr>
@@ -14455,6 +14476,10 @@
           </a:solidFill>
           <a:ln/>
         </p:spPr>
+        <p:txBody>
+          <a:bodyPr/>
+          <a:p/>
+        </p:txBody>
       </p:sp>
       <p:sp>
         <p:nvSpPr>
@@ -14646,6 +14671,10 @@
           </a:solidFill>
           <a:ln/>
         </p:spPr>
+        <p:txBody>
+          <a:bodyPr/>
+          <a:p/>
+        </p:txBody>
       </p:sp>
       <p:sp>
         <p:nvSpPr>
@@ -14743,6 +14772,10 @@
           </a:solidFill>
           <a:ln/>
         </p:spPr>
+        <p:txBody>
+          <a:bodyPr/>
+          <a:p/>
+        </p:txBody>
       </p:sp>
       <p:sp>
         <p:nvSpPr>
@@ -14840,6 +14873,10 @@
           </a:solidFill>
           <a:ln/>
         </p:spPr>
+        <p:txBody>
+          <a:bodyPr/>
+          <a:p/>
+        </p:txBody>
       </p:sp>
       <p:sp>
         <p:nvSpPr>
@@ -14937,6 +14974,10 @@
           </a:solidFill>
           <a:ln/>
         </p:spPr>
+        <p:txBody>
+          <a:bodyPr/>
+          <a:p/>
+        </p:txBody>
       </p:sp>
       <p:sp>
         <p:nvSpPr>
@@ -14959,21 +15000,9 @@
           <a:bodyPr wrap="square" lIns="0" tIns="0" rIns="0" bIns="0" rtlCol="0" anchor="t"/>
           <a:lstStyle/>
           <a:p>
-            <a:pPr indent="0" marL="0">
-              <a:buNone/>
-            </a:pPr>
-            <a:r>
-              <a:rPr lang="en-US" sz="3800" b="1" dirty="0">
-                <a:solidFill>
-                  <a:schemeClr val="accent1"/>
-                </a:solidFill>
-                <a:latin typeface="+mj-lt" pitchFamily="34" charset="0"/>
-                <a:ea typeface="+mj-lt" pitchFamily="34" charset="-122"/>
-                <a:cs typeface="+mj-lt" pitchFamily="34" charset="-120"/>
-              </a:rPr>
-              <a:t>36</a:t>
-            </a:r>
-            <a:endParaRPr lang="en-US" sz="3800" dirty="0"/>
+            <a:r>
+              <a:t>73</a:t>
+            </a:r>
           </a:p>
         </p:txBody>
       </p:sp>

</xml_diff>

<commit_message>
docs(presentacion): anade diapositiva 7 de espacio para MVP y Dataset certificado
</commit_message>
<xml_diff>
--- a/presentacion_datathon_oficial.pptx
+++ b/presentacion_datathon_oficial.pptx
@@ -11,6 +11,7 @@
     <p:sldId id="259" r:id="rId5"/>
     <p:sldId id="260" r:id="rId6"/>
     <p:sldId id="261" r:id="rId7"/>
+    <p:sldId id="270" r:id="rId21"/>
     <p:sldId id="262" r:id="rId8"/>
     <p:sldId id="263" r:id="rId9"/>
     <p:sldId id="264" r:id="rId10"/>
@@ -7774,12 +7775,15 @@
             </a:lvl1pPr>
           </a:lstStyle>
           <a:p>
-            <a:pPr algn="r"/>
-            <a:fld id="{F7021451-1387-4CA6-816F-3879F97B5CBC}" type="slidenum">
-              <a:rPr b="0" lang="en-US"/>
-              <a:t>10</a:t>
-            </a:fld>
-            <a:endParaRPr lang="en-US"/>
+            <a:r>
+              <a:rPr sz="1000">
+                <a:solidFill>
+                  <a:srgbClr val="94A3B8"/>
+                </a:solidFill>
+                <a:latin typeface="Segoe UI"/>
+              </a:rPr>
+              <a:t>11</a:t>
+            </a:r>
           </a:p>
         </p:txBody>
       </p:sp>
@@ -7944,6 +7948,10 @@
           </a:solidFill>
           <a:ln/>
         </p:spPr>
+        <p:txBody>
+          <a:bodyPr/>
+          <a:p/>
+        </p:txBody>
       </p:sp>
       <p:sp>
         <p:nvSpPr>
@@ -8241,6 +8249,10 @@
           </a:solidFill>
           <a:ln/>
         </p:spPr>
+        <p:txBody>
+          <a:bodyPr/>
+          <a:p/>
+        </p:txBody>
       </p:sp>
       <p:sp>
         <p:nvSpPr>
@@ -8338,6 +8350,10 @@
           </a:solidFill>
           <a:ln/>
         </p:spPr>
+        <p:txBody>
+          <a:bodyPr/>
+          <a:p/>
+        </p:txBody>
       </p:sp>
       <p:sp>
         <p:nvSpPr>
@@ -8435,6 +8451,10 @@
           </a:solidFill>
           <a:ln/>
         </p:spPr>
+        <p:txBody>
+          <a:bodyPr/>
+          <a:p/>
+        </p:txBody>
       </p:sp>
       <p:sp>
         <p:nvSpPr>
@@ -8547,12 +8567,15 @@
             </a:lvl1pPr>
           </a:lstStyle>
           <a:p>
-            <a:pPr algn="r"/>
-            <a:fld id="{F7021451-1387-4CA6-816F-3879F97B5CBC}" type="slidenum">
-              <a:rPr b="0" lang="en-US"/>
-              <a:t>11</a:t>
-            </a:fld>
-            <a:endParaRPr lang="en-US"/>
+            <a:r>
+              <a:rPr sz="1000">
+                <a:solidFill>
+                  <a:srgbClr val="94A3B8"/>
+                </a:solidFill>
+                <a:latin typeface="Segoe UI"/>
+              </a:rPr>
+              <a:t>12</a:t>
+            </a:r>
           </a:p>
         </p:txBody>
       </p:sp>
@@ -8957,6 +8980,10 @@
           </a:solidFill>
           <a:ln/>
         </p:spPr>
+        <p:txBody>
+          <a:bodyPr/>
+          <a:p/>
+        </p:txBody>
       </p:sp>
       <p:sp>
         <p:nvSpPr>
@@ -9033,12 +9060,15 @@
             </a:lvl1pPr>
           </a:lstStyle>
           <a:p>
-            <a:pPr algn="r"/>
-            <a:fld id="{F7021451-1387-4CA6-816F-3879F97B5CBC}" type="slidenum">
-              <a:rPr b="0" lang="en-US"/>
-              <a:t>12</a:t>
-            </a:fld>
-            <a:endParaRPr lang="en-US"/>
+            <a:r>
+              <a:rPr sz="1000">
+                <a:solidFill>
+                  <a:srgbClr val="94A3B8"/>
+                </a:solidFill>
+                <a:latin typeface="Segoe UI"/>
+              </a:rPr>
+              <a:t>13</a:t>
+            </a:r>
           </a:p>
         </p:txBody>
       </p:sp>
@@ -9194,6 +9224,10 @@
           </a:solidFill>
           <a:ln/>
         </p:spPr>
+        <p:txBody>
+          <a:bodyPr/>
+          <a:p/>
+        </p:txBody>
       </p:sp>
       <p:sp>
         <p:nvSpPr>
@@ -9291,6 +9325,10 @@
           </a:solidFill>
           <a:ln/>
         </p:spPr>
+        <p:txBody>
+          <a:bodyPr/>
+          <a:p/>
+        </p:txBody>
       </p:sp>
       <p:sp>
         <p:nvSpPr>
@@ -9388,6 +9426,10 @@
           </a:solidFill>
           <a:ln/>
         </p:spPr>
+        <p:txBody>
+          <a:bodyPr/>
+          <a:p/>
+        </p:txBody>
       </p:sp>
       <p:sp>
         <p:nvSpPr>
@@ -9485,6 +9527,10 @@
           </a:solidFill>
           <a:ln/>
         </p:spPr>
+        <p:txBody>
+          <a:bodyPr/>
+          <a:p/>
+        </p:txBody>
       </p:sp>
       <p:sp>
         <p:nvSpPr>
@@ -9597,12 +9643,15 @@
             </a:lvl1pPr>
           </a:lstStyle>
           <a:p>
-            <a:pPr algn="r"/>
-            <a:fld id="{F7021451-1387-4CA6-816F-3879F97B5CBC}" type="slidenum">
-              <a:rPr b="0" lang="en-US"/>
-              <a:t>13</a:t>
-            </a:fld>
-            <a:endParaRPr lang="en-US"/>
+            <a:r>
+              <a:rPr sz="1000">
+                <a:solidFill>
+                  <a:srgbClr val="94A3B8"/>
+                </a:solidFill>
+                <a:latin typeface="Segoe UI"/>
+              </a:rPr>
+              <a:t>14</a:t>
+            </a:r>
           </a:p>
         </p:txBody>
       </p:sp>
@@ -13238,6 +13287,526 @@
 </p:sld>
 </file>
 
+<file path=ppt/slides/slide15.xml><?xml version="1.0" encoding="utf-8"?>
+<p:sld xmlns:a="http://schemas.openxmlformats.org/drawingml/2006/main" xmlns:p="http://schemas.openxmlformats.org/presentationml/2006/main" xmlns:r="http://schemas.openxmlformats.org/officeDocument/2006/relationships">
+  <p:cSld>
+    <p:spTree>
+      <p:nvGrpSpPr>
+        <p:cNvPr id="1" name=""/>
+        <p:cNvGrpSpPr/>
+        <p:nvPr/>
+      </p:nvGrpSpPr>
+      <p:grpSpPr/>
+      <p:sp>
+        <p:nvSpPr>
+          <p:cNvPr id="2" name="Text Placeholder 1"/>
+          <p:cNvSpPr>
+            <a:spLocks noGrp="1"/>
+          </p:cNvSpPr>
+          <p:nvPr>
+            <p:ph type="body" idx="100"/>
+          </p:nvPr>
+        </p:nvSpPr>
+        <p:spPr/>
+        <p:txBody>
+          <a:bodyPr/>
+          <a:lstStyle/>
+          <a:p>
+            <a:pPr>
+              <a:defRPr sz="1050" b="1">
+                <a:solidFill>
+                  <a:srgbClr val="C8102E"/>
+                </a:solidFill>
+                <a:latin typeface="Segoe UI"/>
+              </a:defRPr>
+            </a:pPr>
+            <a:r>
+              <a:t>DEMOSTRACIÓN EN DIRECTO</a:t>
+            </a:r>
+          </a:p>
+        </p:txBody>
+      </p:sp>
+      <p:sp>
+        <p:nvSpPr>
+          <p:cNvPr id="3" name="Title 2"/>
+          <p:cNvSpPr>
+            <a:spLocks noGrp="1"/>
+          </p:cNvSpPr>
+          <p:nvPr>
+            <p:ph type="title" idx="101"/>
+          </p:nvPr>
+        </p:nvSpPr>
+        <p:spPr/>
+        <p:txBody>
+          <a:bodyPr/>
+          <a:lstStyle/>
+          <a:p>
+            <a:pPr>
+              <a:defRPr sz="2100" b="1">
+                <a:solidFill>
+                  <a:srgbClr val="1E293B"/>
+                </a:solidFill>
+                <a:latin typeface="Segoe UI"/>
+              </a:defRPr>
+            </a:pPr>
+            <a:r>
+              <a:t>Plataforma interactiva (MVP) y panel de datos</a:t>
+            </a:r>
+          </a:p>
+        </p:txBody>
+      </p:sp>
+      <p:sp>
+        <p:nvSpPr>
+          <p:cNvPr id="4" name="TextBox 3"/>
+          <p:cNvSpPr txBox="1"/>
+          <p:nvPr/>
+        </p:nvSpPr>
+        <p:spPr>
+          <a:xfrm>
+            <a:off x="640080" y="1371600"/>
+            <a:ext cx="10881360" cy="365760"/>
+          </a:xfrm>
+          <a:prstGeom prst="rect">
+            <a:avLst/>
+          </a:prstGeom>
+          <a:noFill/>
+        </p:spPr>
+        <p:txBody>
+          <a:bodyPr wrap="square">
+            <a:spAutoFit/>
+          </a:bodyPr>
+          <a:lstStyle/>
+          <a:p>
+            <a:pPr>
+              <a:defRPr sz="1150">
+                <a:solidFill>
+                  <a:srgbClr val="64748B"/>
+                </a:solidFill>
+                <a:latin typeface="Segoe UI"/>
+              </a:defRPr>
+            </a:pPr>
+            <a:r>
+              <a:t>Espacio reservado para la demostración del prototipo funcional y la estructura del panel de datos</a:t>
+            </a:r>
+          </a:p>
+        </p:txBody>
+      </p:sp>
+      <p:sp>
+        <p:nvSpPr>
+          <p:cNvPr id="5" name="Rounded Rectangle 4"/>
+          <p:cNvSpPr/>
+          <p:nvPr/>
+        </p:nvSpPr>
+        <p:spPr>
+          <a:xfrm>
+            <a:off x="640080" y="1828800"/>
+            <a:ext cx="6217920" cy="4389120"/>
+          </a:xfrm>
+          <a:prstGeom prst="roundRect">
+            <a:avLst/>
+          </a:prstGeom>
+          <a:solidFill>
+            <a:srgbClr val="FFFFFF"/>
+          </a:solidFill>
+          <a:ln w="12700">
+            <a:solidFill>
+              <a:srgbClr val="E2E8F0"/>
+            </a:solidFill>
+          </a:ln>
+        </p:spPr>
+        <p:style>
+          <a:lnRef idx="1">
+            <a:schemeClr val="accent1"/>
+          </a:lnRef>
+          <a:fillRef idx="3">
+            <a:schemeClr val="accent1"/>
+          </a:fillRef>
+          <a:effectRef idx="2">
+            <a:schemeClr val="accent1"/>
+          </a:effectRef>
+          <a:fontRef idx="minor">
+            <a:schemeClr val="lt1"/>
+          </a:fontRef>
+        </p:style>
+        <p:txBody>
+          <a:bodyPr rtlCol="0" anchor="ctr" wrap="square"/>
+          <a:lstStyle/>
+          <a:p>
+            <a:pPr algn="ctr">
+              <a:defRPr sz="1300" b="1">
+                <a:solidFill>
+                  <a:srgbClr val="1E40AF"/>
+                </a:solidFill>
+                <a:latin typeface="Segoe UI"/>
+              </a:defRPr>
+            </a:pPr>
+            <a:r>
+              <a:t>DEMO EN VIVO  ·  MVP WEB</a:t>
+            </a:r>
+          </a:p>
+          <a:p>
+            <a:pPr>
+              <a:spcBef>
+                <a:spcPts val="300"/>
+              </a:spcBef>
+              <a:defRPr sz="1000">
+                <a:solidFill>
+                  <a:srgbClr val="64748B"/>
+                </a:solidFill>
+                <a:latin typeface="Consolas"/>
+              </a:defRPr>
+            </a:pPr>
+            <a:r>
+              <a:t>http://localhost:8088/index.html  ·  mapa/mapa.html</a:t>
+            </a:r>
+          </a:p>
+        </p:txBody>
+      </p:sp>
+      <p:sp>
+        <p:nvSpPr>
+          <p:cNvPr id="6" name="Rectangle 5"/>
+          <p:cNvSpPr/>
+          <p:nvPr/>
+        </p:nvSpPr>
+        <p:spPr>
+          <a:xfrm>
+            <a:off x="822960" y="2560320"/>
+            <a:ext cx="5852160" cy="2194560"/>
+          </a:xfrm>
+          <a:prstGeom prst="rect">
+            <a:avLst/>
+          </a:prstGeom>
+          <a:solidFill>
+            <a:srgbClr val="F1F5F9"/>
+          </a:solidFill>
+          <a:ln w="12700">
+            <a:solidFill>
+              <a:srgbClr val="CBD5E1"/>
+            </a:solidFill>
+          </a:ln>
+        </p:spPr>
+        <p:style>
+          <a:lnRef idx="1">
+            <a:schemeClr val="accent1"/>
+          </a:lnRef>
+          <a:fillRef idx="3">
+            <a:schemeClr val="accent1"/>
+          </a:fillRef>
+          <a:effectRef idx="2">
+            <a:schemeClr val="accent1"/>
+          </a:effectRef>
+          <a:fontRef idx="minor">
+            <a:schemeClr val="lt1"/>
+          </a:fontRef>
+        </p:style>
+        <p:txBody>
+          <a:bodyPr rtlCol="0" anchor="ctr" wrap="square"/>
+          <a:lstStyle/>
+          <a:p>
+            <a:pPr algn="ctr">
+              <a:defRPr sz="1200" b="1">
+                <a:solidFill>
+                  <a:srgbClr val="475569"/>
+                </a:solidFill>
+                <a:latin typeface="Segoe UI"/>
+              </a:defRPr>
+            </a:pPr>
+            <a:r>
+              <a:t>[ ESPACIO PARA CAPTURA DEL MVP / DEMO EN VIVO ]</a:t>
+            </a:r>
+          </a:p>
+          <a:p>
+            <a:pPr algn="ctr">
+              <a:spcBef>
+                <a:spcPts val="400"/>
+              </a:spcBef>
+              <a:defRPr sz="1000">
+                <a:solidFill>
+                  <a:srgbClr val="94A3B8"/>
+                </a:solidFill>
+                <a:latin typeface="Segoe UI"/>
+              </a:defRPr>
+            </a:pPr>
+            <a:r>
+              <a:t>(Inserta aquí la captura de pantalla del Portal o del Mapa Interactivo)</a:t>
+            </a:r>
+          </a:p>
+        </p:txBody>
+      </p:sp>
+      <p:sp>
+        <p:nvSpPr>
+          <p:cNvPr id="7" name="TextBox 6"/>
+          <p:cNvSpPr txBox="1"/>
+          <p:nvPr/>
+        </p:nvSpPr>
+        <p:spPr>
+          <a:xfrm>
+            <a:off x="822960" y="4892040"/>
+            <a:ext cx="5852160" cy="1188720"/>
+          </a:xfrm>
+          <a:prstGeom prst="rect">
+            <a:avLst/>
+          </a:prstGeom>
+          <a:noFill/>
+        </p:spPr>
+        <p:txBody>
+          <a:bodyPr wrap="square">
+            <a:spAutoFit/>
+          </a:bodyPr>
+          <a:lstStyle/>
+          <a:p>
+            <a:pPr>
+              <a:defRPr sz="1000">
+                <a:solidFill>
+                  <a:srgbClr val="334155"/>
+                </a:solidFill>
+                <a:latin typeface="Segoe UI"/>
+              </a:defRPr>
+            </a:pPr>
+            <a:r>
+              <a:t>• Hero interactivo con 4 KPIs (+108.400 hab., 12,4 M€ inversión).</a:t>
+            </a:r>
+            <a:br/>
+            <a:r>
+              <a:t>• Recomendador ciudadano por perfiles (simulación sin persistir datos).</a:t>
+            </a:r>
+            <a:br/>
+            <a:r>
+              <a:t>• Mapa comarcal con semáforo dotacional y filtro de cuellos de botella.</a:t>
+            </a:r>
+          </a:p>
+        </p:txBody>
+      </p:sp>
+      <p:sp>
+        <p:nvSpPr>
+          <p:cNvPr id="8" name="Rounded Rectangle 7"/>
+          <p:cNvSpPr/>
+          <p:nvPr/>
+        </p:nvSpPr>
+        <p:spPr>
+          <a:xfrm>
+            <a:off x="7040880" y="1828800"/>
+            <a:ext cx="4480560" cy="4389120"/>
+          </a:xfrm>
+          <a:prstGeom prst="roundRect">
+            <a:avLst/>
+          </a:prstGeom>
+          <a:solidFill>
+            <a:srgbClr val="FFFFFF"/>
+          </a:solidFill>
+          <a:ln w="12700">
+            <a:solidFill>
+              <a:srgbClr val="E2E8F0"/>
+            </a:solidFill>
+          </a:ln>
+        </p:spPr>
+        <p:style>
+          <a:lnRef idx="1">
+            <a:schemeClr val="accent1"/>
+          </a:lnRef>
+          <a:fillRef idx="3">
+            <a:schemeClr val="accent1"/>
+          </a:fillRef>
+          <a:effectRef idx="2">
+            <a:schemeClr val="accent1"/>
+          </a:effectRef>
+          <a:fontRef idx="minor">
+            <a:schemeClr val="lt1"/>
+          </a:fontRef>
+        </p:style>
+        <p:txBody>
+          <a:bodyPr rtlCol="0" anchor="ctr" wrap="square"/>
+          <a:lstStyle/>
+          <a:p>
+            <a:pPr algn="ctr">
+              <a:defRPr sz="1300" b="1">
+                <a:solidFill>
+                  <a:srgbClr val="166534"/>
+                </a:solidFill>
+                <a:latin typeface="Segoe UI"/>
+              </a:defRPr>
+            </a:pPr>
+            <a:r>
+              <a:t>PANEL CERTIFICADO  ·  DATASET</a:t>
+            </a:r>
+          </a:p>
+          <a:p>
+            <a:pPr>
+              <a:spcBef>
+                <a:spcPts val="300"/>
+              </a:spcBef>
+              <a:defRPr sz="950">
+                <a:solidFill>
+                  <a:srgbClr val="64748B"/>
+                </a:solidFill>
+                <a:latin typeface="Consolas"/>
+              </a:defRPr>
+            </a:pPr>
+            <a:r>
+              <a:t>data/validated/municipios_panel_validado.csv</a:t>
+            </a:r>
+          </a:p>
+        </p:txBody>
+      </p:sp>
+      <p:sp>
+        <p:nvSpPr>
+          <p:cNvPr id="9" name="Rectangle 8"/>
+          <p:cNvSpPr/>
+          <p:nvPr/>
+        </p:nvSpPr>
+        <p:spPr>
+          <a:xfrm>
+            <a:off x="7223760" y="2560320"/>
+            <a:ext cx="4114800" cy="2194560"/>
+          </a:xfrm>
+          <a:prstGeom prst="rect">
+            <a:avLst/>
+          </a:prstGeom>
+          <a:solidFill>
+            <a:srgbClr val="F1F5F9"/>
+          </a:solidFill>
+          <a:ln w="12700">
+            <a:solidFill>
+              <a:srgbClr val="CBD5E1"/>
+            </a:solidFill>
+          </a:ln>
+        </p:spPr>
+        <p:style>
+          <a:lnRef idx="1">
+            <a:schemeClr val="accent1"/>
+          </a:lnRef>
+          <a:fillRef idx="3">
+            <a:schemeClr val="accent1"/>
+          </a:fillRef>
+          <a:effectRef idx="2">
+            <a:schemeClr val="accent1"/>
+          </a:effectRef>
+          <a:fontRef idx="minor">
+            <a:schemeClr val="lt1"/>
+          </a:fontRef>
+        </p:style>
+        <p:txBody>
+          <a:bodyPr rtlCol="0" anchor="ctr" wrap="square"/>
+          <a:lstStyle/>
+          <a:p>
+            <a:pPr algn="ctr">
+              <a:defRPr sz="1200" b="1">
+                <a:solidFill>
+                  <a:srgbClr val="475569"/>
+                </a:solidFill>
+                <a:latin typeface="Segoe UI"/>
+              </a:defRPr>
+            </a:pPr>
+            <a:r>
+              <a:t>[ ESPACIO PARA CAPTURA DEL DATASET ]</a:t>
+            </a:r>
+          </a:p>
+          <a:p>
+            <a:pPr algn="ctr">
+              <a:spcBef>
+                <a:spcPts val="400"/>
+              </a:spcBef>
+              <a:defRPr sz="1000">
+                <a:solidFill>
+                  <a:srgbClr val="94A3B8"/>
+                </a:solidFill>
+                <a:latin typeface="Segoe UI"/>
+              </a:defRPr>
+            </a:pPr>
+            <a:r>
+              <a:t>(Inserta aquí la captura de la tabla Excel / CSV auditado)</a:t>
+            </a:r>
+          </a:p>
+        </p:txBody>
+      </p:sp>
+      <p:sp>
+        <p:nvSpPr>
+          <p:cNvPr id="10" name="TextBox 9"/>
+          <p:cNvSpPr txBox="1"/>
+          <p:nvPr/>
+        </p:nvSpPr>
+        <p:spPr>
+          <a:xfrm>
+            <a:off x="7223760" y="4892040"/>
+            <a:ext cx="4114800" cy="1188720"/>
+          </a:xfrm>
+          <a:prstGeom prst="rect">
+            <a:avLst/>
+          </a:prstGeom>
+          <a:noFill/>
+        </p:spPr>
+        <p:txBody>
+          <a:bodyPr wrap="square">
+            <a:spAutoFit/>
+          </a:bodyPr>
+          <a:lstStyle/>
+          <a:p>
+            <a:pPr>
+              <a:defRPr sz="1000">
+                <a:solidFill>
+                  <a:srgbClr val="334155"/>
+                </a:solidFill>
+                <a:latin typeface="Segoe UI"/>
+              </a:defRPr>
+            </a:pPr>
+            <a:r>
+              <a:t>• 20 municipios piloto en las 8 comarcas (200.267 hab.).</a:t>
+            </a:r>
+            <a:br/>
+            <a:r>
+              <a:t>• 92 variables verificadas (8 datos reales observados).</a:t>
+            </a:r>
+            <a:br/>
+            <a:r>
+              <a:t>• 0 valores ausentes ni repetidos · 73 tests continuos en verde.</a:t>
+            </a:r>
+          </a:p>
+        </p:txBody>
+      </p:sp>
+      <p:sp>
+        <p:nvSpPr>
+          <p:cNvPr id="11" name="TextBox 10"/>
+          <p:cNvSpPr txBox="1"/>
+          <p:nvPr/>
+        </p:nvSpPr>
+        <p:spPr>
+          <a:xfrm>
+            <a:off x="10634472" y="6400800"/>
+            <a:ext cx="914400" cy="274320"/>
+          </a:xfrm>
+          <a:prstGeom prst="rect">
+            <a:avLst/>
+          </a:prstGeom>
+          <a:noFill/>
+        </p:spPr>
+        <p:txBody>
+          <a:bodyPr wrap="none">
+            <a:spAutoFit/>
+          </a:bodyPr>
+          <a:lstStyle/>
+          <a:p>
+            <a:pPr algn="r">
+              <a:defRPr sz="1000">
+                <a:solidFill>
+                  <a:srgbClr val="94A3B8"/>
+                </a:solidFill>
+                <a:latin typeface="Segoe UI"/>
+              </a:defRPr>
+            </a:pPr>
+            <a:r>
+              <a:t>7</a:t>
+            </a:r>
+          </a:p>
+        </p:txBody>
+      </p:sp>
+    </p:spTree>
+  </p:cSld>
+  <p:clrMapOvr>
+    <a:masterClrMapping/>
+  </p:clrMapOvr>
+</p:sld>
+</file>
+
 <file path=ppt/slides/slide2.xml><?xml version="1.0" encoding="utf-8"?>
 <p:sld xmlns:a="http://schemas.openxmlformats.org/drawingml/2006/main" xmlns:r="http://schemas.openxmlformats.org/officeDocument/2006/relationships" xmlns:p="http://schemas.openxmlformats.org/presentationml/2006/main">
   <p:cSld name="Slide 2">
@@ -18953,6 +19522,10 @@
           </a:solidFill>
           <a:ln/>
         </p:spPr>
+        <p:txBody>
+          <a:bodyPr/>
+          <a:p/>
+        </p:txBody>
       </p:sp>
       <p:sp>
         <p:nvSpPr>
@@ -19045,6 +19618,10 @@
           </a:solidFill>
           <a:ln/>
         </p:spPr>
+        <p:txBody>
+          <a:bodyPr/>
+          <a:p/>
+        </p:txBody>
       </p:sp>
       <p:sp>
         <p:nvSpPr>
@@ -19137,6 +19714,10 @@
           </a:solidFill>
           <a:ln/>
         </p:spPr>
+        <p:txBody>
+          <a:bodyPr/>
+          <a:p/>
+        </p:txBody>
       </p:sp>
       <p:sp>
         <p:nvSpPr>
@@ -19229,6 +19810,10 @@
           </a:solidFill>
           <a:ln/>
         </p:spPr>
+        <p:txBody>
+          <a:bodyPr/>
+          <a:p/>
+        </p:txBody>
       </p:sp>
       <p:sp>
         <p:nvSpPr>
@@ -19321,6 +19906,10 @@
           </a:solidFill>
           <a:ln/>
         </p:spPr>
+        <p:txBody>
+          <a:bodyPr/>
+          <a:p/>
+        </p:txBody>
       </p:sp>
       <p:sp>
         <p:nvSpPr>
@@ -19415,6 +20004,10 @@
           </a:solidFill>
           <a:ln/>
         </p:spPr>
+        <p:txBody>
+          <a:bodyPr/>
+          <a:p/>
+        </p:txBody>
       </p:sp>
       <p:sp>
         <p:nvSpPr>
@@ -19512,6 +20105,10 @@
           </a:solidFill>
           <a:ln/>
         </p:spPr>
+        <p:txBody>
+          <a:bodyPr/>
+          <a:p/>
+        </p:txBody>
       </p:sp>
       <p:sp>
         <p:nvSpPr>
@@ -19712,12 +20309,15 @@
             </a:lvl1pPr>
           </a:lstStyle>
           <a:p>
-            <a:pPr algn="r"/>
-            <a:fld id="{F7021451-1387-4CA6-816F-3879F97B5CBC}" type="slidenum">
-              <a:rPr b="0" lang="en-US"/>
-              <a:t>7</a:t>
-            </a:fld>
-            <a:endParaRPr lang="en-US"/>
+            <a:r>
+              <a:rPr sz="1000">
+                <a:solidFill>
+                  <a:srgbClr val="94A3B8"/>
+                </a:solidFill>
+                <a:latin typeface="Segoe UI"/>
+              </a:rPr>
+              <a:t>8</a:t>
+            </a:r>
           </a:p>
         </p:txBody>
       </p:sp>
@@ -19918,6 +20518,10 @@
           </a:solidFill>
           <a:ln/>
         </p:spPr>
+        <p:txBody>
+          <a:bodyPr/>
+          <a:p/>
+        </p:txBody>
       </p:sp>
       <p:sp>
         <p:nvSpPr>
@@ -20087,6 +20691,10 @@
           </a:solidFill>
           <a:ln/>
         </p:spPr>
+        <p:txBody>
+          <a:bodyPr/>
+          <a:p/>
+        </p:txBody>
       </p:sp>
       <p:sp>
         <p:nvSpPr>
@@ -20234,6 +20842,10 @@
           </a:solidFill>
           <a:ln/>
         </p:spPr>
+        <p:txBody>
+          <a:bodyPr/>
+          <a:p/>
+        </p:txBody>
       </p:sp>
       <p:sp>
         <p:nvSpPr>
@@ -20381,6 +20993,10 @@
           </a:solidFill>
           <a:ln/>
         </p:spPr>
+        <p:txBody>
+          <a:bodyPr/>
+          <a:p/>
+        </p:txBody>
       </p:sp>
       <p:sp>
         <p:nvSpPr>
@@ -20454,12 +21070,15 @@
             </a:lvl1pPr>
           </a:lstStyle>
           <a:p>
-            <a:pPr algn="r"/>
-            <a:fld id="{F7021451-1387-4CA6-816F-3879F97B5CBC}" type="slidenum">
-              <a:rPr b="0" lang="en-US"/>
-              <a:t>8</a:t>
-            </a:fld>
-            <a:endParaRPr lang="en-US"/>
+            <a:r>
+              <a:rPr sz="1000">
+                <a:solidFill>
+                  <a:srgbClr val="94A3B8"/>
+                </a:solidFill>
+                <a:latin typeface="Segoe UI"/>
+              </a:rPr>
+              <a:t>9</a:t>
+            </a:r>
           </a:p>
         </p:txBody>
       </p:sp>
@@ -20624,6 +21243,10 @@
           </a:solidFill>
           <a:ln/>
         </p:spPr>
+        <p:txBody>
+          <a:bodyPr/>
+          <a:p/>
+        </p:txBody>
       </p:sp>
       <p:sp>
         <p:nvSpPr>
@@ -20644,6 +21267,10 @@
           </a:solidFill>
           <a:ln/>
         </p:spPr>
+        <p:txBody>
+          <a:bodyPr/>
+          <a:p/>
+        </p:txBody>
       </p:sp>
       <p:sp>
         <p:nvSpPr>
@@ -20813,6 +21440,10 @@
           </a:solidFill>
           <a:ln/>
         </p:spPr>
+        <p:txBody>
+          <a:bodyPr/>
+          <a:p/>
+        </p:txBody>
       </p:sp>
       <p:sp>
         <p:nvSpPr>
@@ -20833,6 +21464,10 @@
           </a:solidFill>
           <a:ln/>
         </p:spPr>
+        <p:txBody>
+          <a:bodyPr/>
+          <a:p/>
+        </p:txBody>
       </p:sp>
       <p:sp>
         <p:nvSpPr>
@@ -21002,6 +21637,10 @@
           </a:solidFill>
           <a:ln/>
         </p:spPr>
+        <p:txBody>
+          <a:bodyPr/>
+          <a:p/>
+        </p:txBody>
       </p:sp>
       <p:sp>
         <p:nvSpPr>
@@ -21022,6 +21661,10 @@
           </a:solidFill>
           <a:ln/>
         </p:spPr>
+        <p:txBody>
+          <a:bodyPr/>
+          <a:p/>
+        </p:txBody>
       </p:sp>
       <p:sp>
         <p:nvSpPr>
@@ -21191,6 +21834,10 @@
           </a:solidFill>
           <a:ln/>
         </p:spPr>
+        <p:txBody>
+          <a:bodyPr/>
+          <a:p/>
+        </p:txBody>
       </p:sp>
       <p:sp>
         <p:nvSpPr>
@@ -21353,12 +22000,15 @@
             </a:lvl1pPr>
           </a:lstStyle>
           <a:p>
-            <a:pPr algn="r"/>
-            <a:fld id="{F7021451-1387-4CA6-816F-3879F97B5CBC}" type="slidenum">
-              <a:rPr b="0" lang="en-US"/>
-              <a:t>9</a:t>
-            </a:fld>
-            <a:endParaRPr lang="en-US"/>
+            <a:r>
+              <a:rPr sz="1000">
+                <a:solidFill>
+                  <a:srgbClr val="94A3B8"/>
+                </a:solidFill>
+                <a:latin typeface="Segoe UI"/>
+              </a:rPr>
+              <a:t>10</a:t>
+            </a:r>
           </a:p>
         </p:txBody>
       </p:sp>

</xml_diff>

<commit_message>
docs(presentacion): inserta capturas de alta resolucion y cabeceras completas en slide 7 de MVP y Dataset
</commit_message>
<xml_diff>
--- a/presentacion_datathon_oficial.pptx
+++ b/presentacion_datathon_oficial.pptx
@@ -13363,7 +13363,7 @@
         </p:nvSpPr>
         <p:spPr>
           <a:xfrm>
-            <a:off x="640080" y="1371600"/>
+            <a:off x="640080" y="1325880"/>
             <a:ext cx="10881360" cy="365760"/>
           </a:xfrm>
           <a:prstGeom prst="rect">
@@ -13378,7 +13378,7 @@
           <a:lstStyle/>
           <a:p>
             <a:pPr>
-              <a:defRPr sz="1150">
+              <a:defRPr sz="1100">
                 <a:solidFill>
                   <a:srgbClr val="64748B"/>
                 </a:solidFill>
@@ -13386,7 +13386,7 @@
               </a:defRPr>
             </a:pPr>
             <a:r>
-              <a:t>Espacio reservado para la demostración del prototipo funcional y la estructura del panel de datos</a:t>
+              <a:t>Espacio de transición para la demostración del prototipo funcional web y la estructura del panel de datos</a:t>
             </a:r>
           </a:p>
         </p:txBody>
@@ -13399,8 +13399,8 @@
         </p:nvSpPr>
         <p:spPr>
           <a:xfrm>
-            <a:off x="640080" y="1828800"/>
-            <a:ext cx="6217920" cy="4389120"/>
+            <a:off x="640080" y="1783080"/>
+            <a:ext cx="5257800" cy="4434840"/>
           </a:xfrm>
           <a:prstGeom prst="roundRect">
             <a:avLst/>
@@ -13429,11 +13429,37 @@
           </a:fontRef>
         </p:style>
         <p:txBody>
-          <a:bodyPr rtlCol="0" anchor="ctr" wrap="square"/>
-          <a:lstStyle/>
-          <a:p>
-            <a:pPr algn="ctr">
-              <a:defRPr sz="1300" b="1">
+          <a:bodyPr rtlCol="0" anchor="ctr"/>
+          <a:lstStyle/>
+          <a:p>
+            <a:pPr algn="ctr"/>
+          </a:p>
+        </p:txBody>
+      </p:sp>
+      <p:sp>
+        <p:nvSpPr>
+          <p:cNvPr id="6" name="TextBox 5"/>
+          <p:cNvSpPr txBox="1"/>
+          <p:nvPr/>
+        </p:nvSpPr>
+        <p:spPr>
+          <a:xfrm>
+            <a:off x="822960" y="1874519"/>
+            <a:ext cx="4892040" cy="594360"/>
+          </a:xfrm>
+          <a:prstGeom prst="rect">
+            <a:avLst/>
+          </a:prstGeom>
+          <a:noFill/>
+        </p:spPr>
+        <p:txBody>
+          <a:bodyPr wrap="square" lIns="0" rIns="0" tIns="0" bIns="0">
+            <a:spAutoFit/>
+          </a:bodyPr>
+          <a:lstStyle/>
+          <a:p>
+            <a:pPr>
+              <a:defRPr sz="1200" b="1">
                 <a:solidFill>
                   <a:srgbClr val="1E40AF"/>
                 </a:solidFill>
@@ -13441,7 +13467,109 @@
               </a:defRPr>
             </a:pPr>
             <a:r>
-              <a:t>DEMO EN VIVO  ·  MVP WEB</a:t>
+              <a:t>DEMO EN VIVO  ·  MVP WEB INTERACTIVO</a:t>
+            </a:r>
+          </a:p>
+          <a:p>
+            <a:pPr>
+              <a:spcBef>
+                <a:spcPts val="200"/>
+              </a:spcBef>
+              <a:defRPr sz="900">
+                <a:solidFill>
+                  <a:srgbClr val="64748B"/>
+                </a:solidFill>
+                <a:latin typeface="Consolas"/>
+              </a:defRPr>
+            </a:pPr>
+            <a:r>
+              <a:t>http://localhost:8088/index.html  ·  mapa/mapa.html</a:t>
+            </a:r>
+          </a:p>
+        </p:txBody>
+      </p:sp>
+      <p:pic>
+        <p:nvPicPr>
+          <p:cNvPr id="7" name="Picture 6" descr="mvp_screenshot.png"/>
+          <p:cNvPicPr>
+            <a:picLocks noChangeAspect="1"/>
+          </p:cNvPicPr>
+          <p:nvPr/>
+        </p:nvPicPr>
+        <p:blipFill>
+          <a:blip r:embed="rId2"/>
+          <a:stretch>
+            <a:fillRect/>
+          </a:stretch>
+        </p:blipFill>
+        <p:spPr>
+          <a:xfrm>
+            <a:off x="822960" y="2514600"/>
+            <a:ext cx="4892040" cy="2148840"/>
+          </a:xfrm>
+          <a:prstGeom prst="rect">
+            <a:avLst/>
+          </a:prstGeom>
+          <a:ln w="12700">
+            <a:solidFill>
+              <a:srgbClr val="CBD5E1"/>
+            </a:solidFill>
+          </a:ln>
+        </p:spPr>
+      </p:pic>
+      <p:sp>
+        <p:nvSpPr>
+          <p:cNvPr id="8" name="TextBox 7"/>
+          <p:cNvSpPr txBox="1"/>
+          <p:nvPr/>
+        </p:nvSpPr>
+        <p:spPr>
+          <a:xfrm>
+            <a:off x="822960" y="4754880"/>
+            <a:ext cx="4892040" cy="1280160"/>
+          </a:xfrm>
+          <a:prstGeom prst="rect">
+            <a:avLst/>
+          </a:prstGeom>
+          <a:noFill/>
+        </p:spPr>
+        <p:txBody>
+          <a:bodyPr wrap="square" lIns="0" rIns="0" tIns="0" bIns="0">
+            <a:spAutoFit/>
+          </a:bodyPr>
+          <a:lstStyle/>
+          <a:p>
+            <a:pPr>
+              <a:spcBef>
+                <a:spcPts val="0"/>
+              </a:spcBef>
+            </a:pPr>
+            <a:r>
+              <a:rPr sz="950" b="1">
+                <a:solidFill>
+                  <a:srgbClr val="1E40AF"/>
+                </a:solidFill>
+                <a:latin typeface="Segoe UI"/>
+              </a:rPr>
+              <a:t>• </a:t>
+            </a:r>
+            <a:r>
+              <a:rPr sz="950" b="1">
+                <a:solidFill>
+                  <a:srgbClr val="1E293B"/>
+                </a:solidFill>
+                <a:latin typeface="Segoe UI"/>
+              </a:rPr>
+              <a:t>Hero interactivo: </a:t>
+            </a:r>
+            <a:r>
+              <a:rPr sz="950">
+                <a:solidFill>
+                  <a:srgbClr val="475569"/>
+                </a:solidFill>
+                <a:latin typeface="Segoe UI"/>
+              </a:rPr>
+              <a:t>+108.400 hab. acogibles y 12,4 M€ inversión dotacional.</a:t>
             </a:r>
           </a:p>
           <a:p>
@@ -13449,39 +13577,91 @@
               <a:spcBef>
                 <a:spcPts val="300"/>
               </a:spcBef>
-              <a:defRPr sz="1000">
-                <a:solidFill>
-                  <a:srgbClr val="64748B"/>
-                </a:solidFill>
-                <a:latin typeface="Consolas"/>
-              </a:defRPr>
-            </a:pPr>
-            <a:r>
-              <a:t>http://localhost:8088/index.html  ·  mapa/mapa.html</a:t>
-            </a:r>
-          </a:p>
-        </p:txBody>
-      </p:sp>
-      <p:sp>
-        <p:nvSpPr>
-          <p:cNvPr id="6" name="Rectangle 5"/>
-          <p:cNvSpPr/>
-          <p:nvPr/>
-        </p:nvSpPr>
-        <p:spPr>
-          <a:xfrm>
-            <a:off x="822960" y="2560320"/>
-            <a:ext cx="5852160" cy="2194560"/>
-          </a:xfrm>
-          <a:prstGeom prst="rect">
-            <a:avLst/>
-          </a:prstGeom>
-          <a:solidFill>
-            <a:srgbClr val="F1F5F9"/>
+            </a:pPr>
+            <a:r>
+              <a:rPr sz="950" b="1">
+                <a:solidFill>
+                  <a:srgbClr val="1E40AF"/>
+                </a:solidFill>
+                <a:latin typeface="Segoe UI"/>
+              </a:rPr>
+              <a:t>• </a:t>
+            </a:r>
+            <a:r>
+              <a:rPr sz="950" b="1">
+                <a:solidFill>
+                  <a:srgbClr val="1E293B"/>
+                </a:solidFill>
+                <a:latin typeface="Segoe UI"/>
+              </a:rPr>
+              <a:t>Recomendador ciudadano: </a:t>
+            </a:r>
+            <a:r>
+              <a:rPr sz="950">
+                <a:solidFill>
+                  <a:srgbClr val="475569"/>
+                </a:solidFill>
+                <a:latin typeface="Segoe UI"/>
+              </a:rPr>
+              <a:t>Filtro por presupuesto y perfiles sin persistir datos.</a:t>
+            </a:r>
+          </a:p>
+          <a:p>
+            <a:pPr>
+              <a:spcBef>
+                <a:spcPts val="300"/>
+              </a:spcBef>
+            </a:pPr>
+            <a:r>
+              <a:rPr sz="950" b="1">
+                <a:solidFill>
+                  <a:srgbClr val="1E40AF"/>
+                </a:solidFill>
+                <a:latin typeface="Segoe UI"/>
+              </a:rPr>
+              <a:t>• </a:t>
+            </a:r>
+            <a:r>
+              <a:rPr sz="950" b="1">
+                <a:solidFill>
+                  <a:srgbClr val="1E293B"/>
+                </a:solidFill>
+                <a:latin typeface="Segoe UI"/>
+              </a:rPr>
+              <a:t>Mapa comarcal: </a:t>
+            </a:r>
+            <a:r>
+              <a:rPr sz="950">
+                <a:solidFill>
+                  <a:srgbClr val="475569"/>
+                </a:solidFill>
+                <a:latin typeface="Segoe UI"/>
+              </a:rPr>
+              <a:t>Semáforo dotacional y detección de cuellos de botella.</a:t>
+            </a:r>
+          </a:p>
+        </p:txBody>
+      </p:sp>
+      <p:sp>
+        <p:nvSpPr>
+          <p:cNvPr id="9" name="Rounded Rectangle 8"/>
+          <p:cNvSpPr/>
+          <p:nvPr/>
+        </p:nvSpPr>
+        <p:spPr>
+          <a:xfrm>
+            <a:off x="6263640" y="1783080"/>
+            <a:ext cx="5257800" cy="4434840"/>
+          </a:xfrm>
+          <a:prstGeom prst="roundRect">
+            <a:avLst/>
+          </a:prstGeom>
+          <a:solidFill>
+            <a:srgbClr val="FFFFFF"/>
           </a:solidFill>
           <a:ln w="12700">
             <a:solidFill>
-              <a:srgbClr val="CBD5E1"/>
+              <a:srgbClr val="E2E8F0"/>
             </a:solidFill>
           </a:ln>
         </p:spPr>
@@ -13500,142 +13680,53 @@
           </a:fontRef>
         </p:style>
         <p:txBody>
-          <a:bodyPr rtlCol="0" anchor="ctr" wrap="square"/>
-          <a:lstStyle/>
-          <a:p>
-            <a:pPr algn="ctr">
+          <a:bodyPr rtlCol="0" anchor="ctr"/>
+          <a:lstStyle/>
+          <a:p>
+            <a:pPr algn="ctr"/>
+          </a:p>
+        </p:txBody>
+      </p:sp>
+      <p:sp>
+        <p:nvSpPr>
+          <p:cNvPr id="10" name="TextBox 9"/>
+          <p:cNvSpPr txBox="1"/>
+          <p:nvPr/>
+        </p:nvSpPr>
+        <p:spPr>
+          <a:xfrm>
+            <a:off x="6446520" y="1874519"/>
+            <a:ext cx="4892040" cy="594360"/>
+          </a:xfrm>
+          <a:prstGeom prst="rect">
+            <a:avLst/>
+          </a:prstGeom>
+          <a:noFill/>
+        </p:spPr>
+        <p:txBody>
+          <a:bodyPr wrap="square" lIns="0" rIns="0" tIns="0" bIns="0">
+            <a:spAutoFit/>
+          </a:bodyPr>
+          <a:lstStyle/>
+          <a:p>
+            <a:pPr>
               <a:defRPr sz="1200" b="1">
                 <a:solidFill>
-                  <a:srgbClr val="475569"/>
+                  <a:srgbClr val="166534"/>
                 </a:solidFill>
                 <a:latin typeface="Segoe UI"/>
               </a:defRPr>
             </a:pPr>
             <a:r>
-              <a:t>[ ESPACIO PARA CAPTURA DEL MVP / DEMO EN VIVO ]</a:t>
-            </a:r>
-          </a:p>
-          <a:p>
-            <a:pPr algn="ctr">
-              <a:spcBef>
-                <a:spcPts val="400"/>
-              </a:spcBef>
-              <a:defRPr sz="1000">
-                <a:solidFill>
-                  <a:srgbClr val="94A3B8"/>
-                </a:solidFill>
-                <a:latin typeface="Segoe UI"/>
-              </a:defRPr>
-            </a:pPr>
-            <a:r>
-              <a:t>(Inserta aquí la captura de pantalla del Portal o del Mapa Interactivo)</a:t>
-            </a:r>
-          </a:p>
-        </p:txBody>
-      </p:sp>
-      <p:sp>
-        <p:nvSpPr>
-          <p:cNvPr id="7" name="TextBox 6"/>
-          <p:cNvSpPr txBox="1"/>
-          <p:nvPr/>
-        </p:nvSpPr>
-        <p:spPr>
-          <a:xfrm>
-            <a:off x="822960" y="4892040"/>
-            <a:ext cx="5852160" cy="1188720"/>
-          </a:xfrm>
-          <a:prstGeom prst="rect">
-            <a:avLst/>
-          </a:prstGeom>
-          <a:noFill/>
-        </p:spPr>
-        <p:txBody>
-          <a:bodyPr wrap="square">
-            <a:spAutoFit/>
-          </a:bodyPr>
-          <a:lstStyle/>
-          <a:p>
-            <a:pPr>
-              <a:defRPr sz="1000">
-                <a:solidFill>
-                  <a:srgbClr val="334155"/>
-                </a:solidFill>
-                <a:latin typeface="Segoe UI"/>
-              </a:defRPr>
-            </a:pPr>
-            <a:r>
-              <a:t>• Hero interactivo con 4 KPIs (+108.400 hab., 12,4 M€ inversión).</a:t>
-            </a:r>
-            <a:br/>
-            <a:r>
-              <a:t>• Recomendador ciudadano por perfiles (simulación sin persistir datos).</a:t>
-            </a:r>
-            <a:br/>
-            <a:r>
-              <a:t>• Mapa comarcal con semáforo dotacional y filtro de cuellos de botella.</a:t>
-            </a:r>
-          </a:p>
-        </p:txBody>
-      </p:sp>
-      <p:sp>
-        <p:nvSpPr>
-          <p:cNvPr id="8" name="Rounded Rectangle 7"/>
-          <p:cNvSpPr/>
-          <p:nvPr/>
-        </p:nvSpPr>
-        <p:spPr>
-          <a:xfrm>
-            <a:off x="7040880" y="1828800"/>
-            <a:ext cx="4480560" cy="4389120"/>
-          </a:xfrm>
-          <a:prstGeom prst="roundRect">
-            <a:avLst/>
-          </a:prstGeom>
-          <a:solidFill>
-            <a:srgbClr val="FFFFFF"/>
-          </a:solidFill>
-          <a:ln w="12700">
-            <a:solidFill>
-              <a:srgbClr val="E2E8F0"/>
-            </a:solidFill>
-          </a:ln>
-        </p:spPr>
-        <p:style>
-          <a:lnRef idx="1">
-            <a:schemeClr val="accent1"/>
-          </a:lnRef>
-          <a:fillRef idx="3">
-            <a:schemeClr val="accent1"/>
-          </a:fillRef>
-          <a:effectRef idx="2">
-            <a:schemeClr val="accent1"/>
-          </a:effectRef>
-          <a:fontRef idx="minor">
-            <a:schemeClr val="lt1"/>
-          </a:fontRef>
-        </p:style>
-        <p:txBody>
-          <a:bodyPr rtlCol="0" anchor="ctr" wrap="square"/>
-          <a:lstStyle/>
-          <a:p>
-            <a:pPr algn="ctr">
-              <a:defRPr sz="1300" b="1">
-                <a:solidFill>
-                  <a:srgbClr val="166534"/>
-                </a:solidFill>
-                <a:latin typeface="Segoe UI"/>
-              </a:defRPr>
-            </a:pPr>
-            <a:r>
-              <a:t>PANEL CERTIFICADO  ·  DATASET</a:t>
+              <a:t>PANEL CERTIFICADO  ·  DATASET AUDITADO</a:t>
             </a:r>
           </a:p>
           <a:p>
             <a:pPr>
               <a:spcBef>
-                <a:spcPts val="300"/>
+                <a:spcPts val="200"/>
               </a:spcBef>
-              <a:defRPr sz="950">
+              <a:defRPr sz="900">
                 <a:solidFill>
                   <a:srgbClr val="64748B"/>
                 </a:solidFill>
@@ -13648,124 +13739,163 @@
           </a:p>
         </p:txBody>
       </p:sp>
-      <p:sp>
-        <p:nvSpPr>
-          <p:cNvPr id="9" name="Rectangle 8"/>
-          <p:cNvSpPr/>
-          <p:nvPr/>
-        </p:nvSpPr>
-        <p:spPr>
-          <a:xfrm>
-            <a:off x="7223760" y="2560320"/>
-            <a:ext cx="4114800" cy="2194560"/>
-          </a:xfrm>
-          <a:prstGeom prst="rect">
-            <a:avLst/>
-          </a:prstGeom>
-          <a:solidFill>
-            <a:srgbClr val="F1F5F9"/>
-          </a:solidFill>
+      <p:pic>
+        <p:nvPicPr>
+          <p:cNvPr id="11" name="Picture 10" descr="dataset_screenshot.png"/>
+          <p:cNvPicPr>
+            <a:picLocks noChangeAspect="1"/>
+          </p:cNvPicPr>
+          <p:nvPr/>
+        </p:nvPicPr>
+        <p:blipFill>
+          <a:blip r:embed="rId3"/>
+          <a:stretch>
+            <a:fillRect/>
+          </a:stretch>
+        </p:blipFill>
+        <p:spPr>
+          <a:xfrm>
+            <a:off x="6446520" y="2514600"/>
+            <a:ext cx="4892040" cy="2148840"/>
+          </a:xfrm>
+          <a:prstGeom prst="rect">
+            <a:avLst/>
+          </a:prstGeom>
           <a:ln w="12700">
             <a:solidFill>
               <a:srgbClr val="CBD5E1"/>
             </a:solidFill>
           </a:ln>
         </p:spPr>
-        <p:style>
-          <a:lnRef idx="1">
-            <a:schemeClr val="accent1"/>
-          </a:lnRef>
-          <a:fillRef idx="3">
-            <a:schemeClr val="accent1"/>
-          </a:fillRef>
-          <a:effectRef idx="2">
-            <a:schemeClr val="accent1"/>
-          </a:effectRef>
-          <a:fontRef idx="minor">
-            <a:schemeClr val="lt1"/>
-          </a:fontRef>
-        </p:style>
-        <p:txBody>
-          <a:bodyPr rtlCol="0" anchor="ctr" wrap="square"/>
-          <a:lstStyle/>
-          <a:p>
-            <a:pPr algn="ctr">
-              <a:defRPr sz="1200" b="1">
-                <a:solidFill>
-                  <a:srgbClr val="475569"/>
-                </a:solidFill>
-                <a:latin typeface="Segoe UI"/>
-              </a:defRPr>
-            </a:pPr>
-            <a:r>
-              <a:t>[ ESPACIO PARA CAPTURA DEL DATASET ]</a:t>
-            </a:r>
-          </a:p>
-          <a:p>
-            <a:pPr algn="ctr">
-              <a:spcBef>
-                <a:spcPts val="400"/>
-              </a:spcBef>
-              <a:defRPr sz="1000">
-                <a:solidFill>
-                  <a:srgbClr val="94A3B8"/>
-                </a:solidFill>
-                <a:latin typeface="Segoe UI"/>
-              </a:defRPr>
-            </a:pPr>
-            <a:r>
-              <a:t>(Inserta aquí la captura de la tabla Excel / CSV auditado)</a:t>
-            </a:r>
-          </a:p>
-        </p:txBody>
-      </p:sp>
-      <p:sp>
-        <p:nvSpPr>
-          <p:cNvPr id="10" name="TextBox 9"/>
+      </p:pic>
+      <p:sp>
+        <p:nvSpPr>
+          <p:cNvPr id="12" name="TextBox 11"/>
           <p:cNvSpPr txBox="1"/>
           <p:nvPr/>
         </p:nvSpPr>
         <p:spPr>
           <a:xfrm>
-            <a:off x="7223760" y="4892040"/>
-            <a:ext cx="4114800" cy="1188720"/>
-          </a:xfrm>
-          <a:prstGeom prst="rect">
-            <a:avLst/>
-          </a:prstGeom>
-          <a:noFill/>
-        </p:spPr>
-        <p:txBody>
-          <a:bodyPr wrap="square">
+            <a:off x="6446520" y="4754880"/>
+            <a:ext cx="4892040" cy="1280160"/>
+          </a:xfrm>
+          <a:prstGeom prst="rect">
+            <a:avLst/>
+          </a:prstGeom>
+          <a:noFill/>
+        </p:spPr>
+        <p:txBody>
+          <a:bodyPr wrap="square" lIns="0" rIns="0" tIns="0" bIns="0">
             <a:spAutoFit/>
           </a:bodyPr>
           <a:lstStyle/>
           <a:p>
             <a:pPr>
-              <a:defRPr sz="1000">
-                <a:solidFill>
-                  <a:srgbClr val="334155"/>
+              <a:spcBef>
+                <a:spcPts val="0"/>
+              </a:spcBef>
+            </a:pPr>
+            <a:r>
+              <a:rPr sz="950" b="1">
+                <a:solidFill>
+                  <a:srgbClr val="166534"/>
                 </a:solidFill>
                 <a:latin typeface="Segoe UI"/>
-              </a:defRPr>
-            </a:pPr>
-            <a:r>
-              <a:t>• 20 municipios piloto en las 8 comarcas (200.267 hab.).</a:t>
-            </a:r>
-            <a:br/>
-            <a:r>
-              <a:t>• 92 variables verificadas (8 datos reales observados).</a:t>
-            </a:r>
-            <a:br/>
-            <a:r>
-              <a:t>• 0 valores ausentes ni repetidos · 73 tests continuos en verde.</a:t>
-            </a:r>
-          </a:p>
-        </p:txBody>
-      </p:sp>
-      <p:sp>
-        <p:nvSpPr>
-          <p:cNvPr id="11" name="TextBox 10"/>
+              </a:rPr>
+              <a:t>• </a:t>
+            </a:r>
+            <a:r>
+              <a:rPr sz="950" b="1">
+                <a:solidFill>
+                  <a:srgbClr val="1E293B"/>
+                </a:solidFill>
+                <a:latin typeface="Segoe UI"/>
+              </a:rPr>
+              <a:t>Cobertura comarcal: </a:t>
+            </a:r>
+            <a:r>
+              <a:rPr sz="950">
+                <a:solidFill>
+                  <a:srgbClr val="475569"/>
+                </a:solidFill>
+                <a:latin typeface="Segoe UI"/>
+              </a:rPr>
+              <a:t>20 municipios piloto en las 8 comarcas (200.267 hab.).</a:t>
+            </a:r>
+          </a:p>
+          <a:p>
+            <a:pPr>
+              <a:spcBef>
+                <a:spcPts val="300"/>
+              </a:spcBef>
+            </a:pPr>
+            <a:r>
+              <a:rPr sz="950" b="1">
+                <a:solidFill>
+                  <a:srgbClr val="166534"/>
+                </a:solidFill>
+                <a:latin typeface="Segoe UI"/>
+              </a:rPr>
+              <a:t>• </a:t>
+            </a:r>
+            <a:r>
+              <a:rPr sz="950" b="1">
+                <a:solidFill>
+                  <a:srgbClr val="1E293B"/>
+                </a:solidFill>
+                <a:latin typeface="Segoe UI"/>
+              </a:rPr>
+              <a:t>Calidad verificada: </a:t>
+            </a:r>
+            <a:r>
+              <a:rPr sz="950">
+                <a:solidFill>
+                  <a:srgbClr val="475569"/>
+                </a:solidFill>
+                <a:latin typeface="Segoe UI"/>
+              </a:rPr>
+              <a:t>92 variables estructuradas con 0 nulos ni repetidos.</a:t>
+            </a:r>
+          </a:p>
+          <a:p>
+            <a:pPr>
+              <a:spcBef>
+                <a:spcPts val="300"/>
+              </a:spcBef>
+            </a:pPr>
+            <a:r>
+              <a:rPr sz="950" b="1">
+                <a:solidFill>
+                  <a:srgbClr val="166534"/>
+                </a:solidFill>
+                <a:latin typeface="Segoe UI"/>
+              </a:rPr>
+              <a:t>• </a:t>
+            </a:r>
+            <a:r>
+              <a:rPr sz="950" b="1">
+                <a:solidFill>
+                  <a:srgbClr val="1E293B"/>
+                </a:solidFill>
+                <a:latin typeface="Segoe UI"/>
+              </a:rPr>
+              <a:t>Garantía metodológica: </a:t>
+            </a:r>
+            <a:r>
+              <a:rPr sz="950">
+                <a:solidFill>
+                  <a:srgbClr val="475569"/>
+                </a:solidFill>
+                <a:latin typeface="Segoe UI"/>
+              </a:rPr>
+              <a:t>73 tests continuos en verde y trazabilidad oficial.</a:t>
+            </a:r>
+          </a:p>
+        </p:txBody>
+      </p:sp>
+      <p:sp>
+        <p:nvSpPr>
+          <p:cNvPr id="13" name="TextBox 12"/>
           <p:cNvSpPr txBox="1"/>
           <p:nvPr/>
         </p:nvSpPr>

</xml_diff>

<commit_message>
docs(presentacion): destaca backtesting historico, control de overfitting y cobertura 155/179 municipios
</commit_message>
<xml_diff>
--- a/presentacion_datathon_oficial.pptx
+++ b/presentacion_datathon_oficial.pptx
@@ -6820,6 +6820,936 @@
 
 <file path=ppt/slides/slide10.xml><?xml version="1.0" encoding="utf-8"?>
 <p:sld xmlns:a="http://schemas.openxmlformats.org/drawingml/2006/main" xmlns:r="http://schemas.openxmlformats.org/officeDocument/2006/relationships" xmlns:p="http://schemas.openxmlformats.org/presentationml/2006/main">
+  <p:cSld name="Slide 9">
+    <p:spTree>
+      <p:nvGrpSpPr>
+        <p:cNvPr id="1" name=""/>
+        <p:cNvGrpSpPr/>
+        <p:nvPr/>
+      </p:nvGrpSpPr>
+      <p:grpSpPr>
+        <a:xfrm>
+          <a:off x="0" y="0"/>
+          <a:ext cx="0" cy="0"/>
+          <a:chOff x="0" y="0"/>
+          <a:chExt cx="0" cy="0"/>
+        </a:xfrm>
+      </p:grpSpPr>
+      <p:sp>
+        <p:nvSpPr>
+          <p:cNvPr id="2" name="Text 0"/>
+          <p:cNvSpPr/>
+          <p:nvPr>
+            <p:ph idx="100" type="body" hasCustomPrompt="1"/>
+          </p:nvPr>
+        </p:nvSpPr>
+        <p:spPr>
+          <a:xfrm>
+            <a:off x="640080" y="457200"/>
+            <a:ext cx="8229600" cy="274320"/>
+          </a:xfrm>
+          <a:prstGeom prst="rect">
+            <a:avLst/>
+          </a:prstGeom>
+          <a:noFill/>
+          <a:ln/>
+        </p:spPr>
+        <p:txBody>
+          <a:bodyPr wrap="square" lIns="0" tIns="0" rIns="0" bIns="0" rtlCol="0" anchor="t"/>
+          <a:lstStyle/>
+          <a:p>
+            <a:pPr algn="l" indent="0" marL="0">
+              <a:buNone/>
+            </a:pPr>
+            <a:r>
+              <a:rPr lang="en-US" sz="1200" b="1" spc="300" kern="0" dirty="0">
+                <a:solidFill>
+                  <a:schemeClr val="accent1"/>
+                </a:solidFill>
+              </a:rPr>
+              <a:t>8  ·  DIAGNÓSTICO Y CONTROL</a:t>
+            </a:r>
+            <a:endParaRPr lang="en-US" sz="1200" dirty="0"/>
+          </a:p>
+        </p:txBody>
+      </p:sp>
+      <p:sp>
+        <p:nvSpPr>
+          <p:cNvPr id="3" name="Text 0"/>
+          <p:cNvSpPr/>
+          <p:nvPr>
+            <p:ph idx="101" type="title" hasCustomPrompt="1"/>
+          </p:nvPr>
+        </p:nvSpPr>
+        <p:spPr>
+          <a:xfrm>
+            <a:off x="640080" y="777240"/>
+            <a:ext cx="10908792" cy="594360"/>
+          </a:xfrm>
+          <a:prstGeom prst="rect">
+            <a:avLst/>
+          </a:prstGeom>
+          <a:noFill/>
+          <a:ln/>
+        </p:spPr>
+        <p:txBody>
+          <a:bodyPr wrap="square" lIns="0" tIns="0" rIns="0" bIns="0" rtlCol="0" anchor="t"/>
+          <a:lstStyle/>
+          <a:p>
+            <a:pPr algn="l" indent="0" marL="0">
+              <a:buNone/>
+            </a:pPr>
+            <a:r>
+              <a:rPr lang="en-US" sz="3200" b="1" dirty="0">
+                <a:solidFill>
+                  <a:schemeClr val="tx1"/>
+                </a:solidFill>
+              </a:rPr>
+              <a:t>El semáforo ICA y la alerta no compensatoria</a:t>
+            </a:r>
+            <a:endParaRPr lang="en-US" sz="3200" dirty="0"/>
+          </a:p>
+        </p:txBody>
+      </p:sp>
+      <p:sp>
+        <p:nvSpPr>
+          <p:cNvPr id="4" name="Text 2"/>
+          <p:cNvSpPr txBox="1"/>
+          <p:nvPr/>
+        </p:nvSpPr>
+        <p:spPr>
+          <a:xfrm>
+            <a:off x="640080" y="1371600"/>
+            <a:ext cx="10908792" cy="365760"/>
+          </a:xfrm>
+          <a:prstGeom prst="rect">
+            <a:avLst/>
+          </a:prstGeom>
+          <a:noFill/>
+          <a:ln/>
+        </p:spPr>
+        <p:txBody>
+          <a:bodyPr wrap="square" lIns="0" tIns="0" rIns="0" bIns="0" rtlCol="0" anchor="t"/>
+          <a:lstStyle/>
+          <a:p>
+            <a:pPr indent="0" marL="0">
+              <a:buNone/>
+            </a:pPr>
+            <a:r>
+              <a:rPr lang="en-US" sz="1600" dirty="0">
+                <a:solidFill>
+                  <a:schemeClr val="tx2"/>
+                </a:solidFill>
+              </a:rPr>
+              <a:t>Umbrales de capacidad e interrupción automática del encaje</a:t>
+            </a:r>
+            <a:endParaRPr lang="en-US" sz="1600" dirty="0"/>
+          </a:p>
+        </p:txBody>
+      </p:sp>
+      <p:sp>
+        <p:nvSpPr>
+          <p:cNvPr id="5" name="Nivel ALTA"/>
+          <p:cNvSpPr/>
+          <p:nvPr/>
+        </p:nvSpPr>
+        <p:spPr>
+          <a:xfrm>
+            <a:off x="640080" y="1965960"/>
+            <a:ext cx="3474720" cy="2697480"/>
+          </a:xfrm>
+          <a:prstGeom prst="roundRect">
+            <a:avLst>
+              <a:gd name="adj" fmla="val 3390"/>
+            </a:avLst>
+          </a:prstGeom>
+          <a:solidFill>
+            <a:schemeClr val="bg2"/>
+          </a:solidFill>
+          <a:ln/>
+        </p:spPr>
+        <p:txBody>
+          <a:bodyPr/>
+          <a:p/>
+        </p:txBody>
+      </p:sp>
+      <p:sp>
+        <p:nvSpPr>
+          <p:cNvPr id="6" name="Luz semáforo"/>
+          <p:cNvSpPr/>
+          <p:nvPr/>
+        </p:nvSpPr>
+        <p:spPr>
+          <a:xfrm>
+            <a:off x="914400" y="2240280"/>
+            <a:ext cx="237744" cy="237744"/>
+          </a:xfrm>
+          <a:prstGeom prst="ellipse">
+            <a:avLst/>
+          </a:prstGeom>
+          <a:solidFill>
+            <a:srgbClr val="2E7D5B"/>
+          </a:solidFill>
+          <a:ln/>
+        </p:spPr>
+        <p:txBody>
+          <a:bodyPr/>
+          <a:p/>
+        </p:txBody>
+      </p:sp>
+      <p:sp>
+        <p:nvSpPr>
+          <p:cNvPr id="7" name="Text 5"/>
+          <p:cNvSpPr txBox="1"/>
+          <p:nvPr/>
+        </p:nvSpPr>
+        <p:spPr>
+          <a:xfrm>
+            <a:off x="1280160" y="2221992"/>
+            <a:ext cx="2286000" cy="274320"/>
+          </a:xfrm>
+          <a:prstGeom prst="rect">
+            <a:avLst/>
+          </a:prstGeom>
+          <a:noFill/>
+          <a:ln/>
+        </p:spPr>
+        <p:txBody>
+          <a:bodyPr wrap="square" lIns="0" tIns="0" rIns="0" bIns="0" rtlCol="0" anchor="ctr"/>
+          <a:lstStyle/>
+          <a:p>
+            <a:pPr indent="0" marL="0">
+              <a:buNone/>
+            </a:pPr>
+            <a:r>
+              <a:rPr lang="en-US" sz="1300" b="1" spc="200" kern="0" dirty="0">
+                <a:solidFill>
+                  <a:schemeClr val="tx1"/>
+                </a:solidFill>
+              </a:rPr>
+              <a:t>ALTA</a:t>
+            </a:r>
+            <a:endParaRPr lang="en-US" sz="1300" dirty="0"/>
+          </a:p>
+        </p:txBody>
+      </p:sp>
+      <p:sp>
+        <p:nvSpPr>
+          <p:cNvPr id="8" name="Text 6"/>
+          <p:cNvSpPr txBox="1"/>
+          <p:nvPr/>
+        </p:nvSpPr>
+        <p:spPr>
+          <a:xfrm>
+            <a:off x="914400" y="2606040"/>
+            <a:ext cx="2926080" cy="731520"/>
+          </a:xfrm>
+          <a:prstGeom prst="rect">
+            <a:avLst/>
+          </a:prstGeom>
+          <a:noFill/>
+          <a:ln/>
+        </p:spPr>
+        <p:txBody>
+          <a:bodyPr wrap="square" lIns="0" tIns="0" rIns="0" bIns="0" rtlCol="0" anchor="t"/>
+          <a:lstStyle/>
+          <a:p>
+            <a:pPr indent="0" marL="0">
+              <a:buNone/>
+            </a:pPr>
+            <a:r>
+              <a:rPr lang="en-US" sz="4200" b="1" dirty="0">
+                <a:solidFill>
+                  <a:schemeClr val="accent2"/>
+                </a:solidFill>
+                <a:latin typeface="+mj-lt" pitchFamily="34" charset="0"/>
+                <a:ea typeface="+mj-lt" pitchFamily="34" charset="-122"/>
+                <a:cs typeface="+mj-lt" pitchFamily="34" charset="-120"/>
+              </a:rPr>
+              <a:t>≥ 60</a:t>
+            </a:r>
+            <a:endParaRPr lang="en-US" sz="4200" dirty="0"/>
+          </a:p>
+        </p:txBody>
+      </p:sp>
+      <p:sp>
+        <p:nvSpPr>
+          <p:cNvPr id="9" name="Text 7"/>
+          <p:cNvSpPr txBox="1"/>
+          <p:nvPr/>
+        </p:nvSpPr>
+        <p:spPr>
+          <a:xfrm>
+            <a:off x="914400" y="3337560"/>
+            <a:ext cx="2926080" cy="320040"/>
+          </a:xfrm>
+          <a:prstGeom prst="rect">
+            <a:avLst/>
+          </a:prstGeom>
+          <a:noFill/>
+          <a:ln/>
+        </p:spPr>
+        <p:txBody>
+          <a:bodyPr wrap="square" lIns="0" tIns="0" rIns="0" bIns="0" rtlCol="0" anchor="t"/>
+          <a:lstStyle/>
+          <a:p>
+            <a:pPr indent="0" marL="0">
+              <a:buNone/>
+            </a:pPr>
+            <a:r>
+              <a:rPr lang="en-US" sz="1600" b="1" dirty="0">
+                <a:solidFill>
+                  <a:schemeClr val="tx1"/>
+                </a:solidFill>
+              </a:rPr>
+              <a:t>Mucho margen de acogida</a:t>
+            </a:r>
+            <a:endParaRPr lang="en-US" sz="1600" dirty="0"/>
+          </a:p>
+        </p:txBody>
+      </p:sp>
+      <p:sp>
+        <p:nvSpPr>
+          <p:cNvPr id="10" name="Text 8"/>
+          <p:cNvSpPr txBox="1"/>
+          <p:nvPr/>
+        </p:nvSpPr>
+        <p:spPr>
+          <a:xfrm>
+            <a:off x="914400" y="3703320"/>
+            <a:ext cx="2926080" cy="868680"/>
+          </a:xfrm>
+          <a:prstGeom prst="rect">
+            <a:avLst/>
+          </a:prstGeom>
+          <a:noFill/>
+          <a:ln/>
+        </p:spPr>
+        <p:txBody>
+          <a:bodyPr wrap="square" lIns="0" tIns="0" rIns="0" bIns="0" rtlCol="0" anchor="t"/>
+          <a:lstStyle/>
+          <a:p>
+            <a:pPr indent="0" marL="0">
+              <a:buNone/>
+            </a:pPr>
+            <a:r>
+              <a:rPr lang="en-US" sz="1400" dirty="0">
+                <a:solidFill>
+                  <a:schemeClr val="tx2"/>
+                </a:solidFill>
+              </a:rPr>
+              <a:t>Absorbe población de inmediato sin comprometer colegios ni consultorios. Ej.: Robledo 66,7 y Buitrago 62,5.</a:t>
+            </a:r>
+            <a:endParaRPr lang="en-US" sz="1400" dirty="0"/>
+          </a:p>
+        </p:txBody>
+      </p:sp>
+      <p:sp>
+        <p:nvSpPr>
+          <p:cNvPr id="11" name="Nivel MEDIA"/>
+          <p:cNvSpPr/>
+          <p:nvPr/>
+        </p:nvSpPr>
+        <p:spPr>
+          <a:xfrm>
+            <a:off x="4357116" y="1965960"/>
+            <a:ext cx="3474720" cy="2697480"/>
+          </a:xfrm>
+          <a:prstGeom prst="roundRect">
+            <a:avLst>
+              <a:gd name="adj" fmla="val 3390"/>
+            </a:avLst>
+          </a:prstGeom>
+          <a:solidFill>
+            <a:schemeClr val="bg2"/>
+          </a:solidFill>
+          <a:ln/>
+        </p:spPr>
+        <p:txBody>
+          <a:bodyPr/>
+          <a:p/>
+        </p:txBody>
+      </p:sp>
+      <p:sp>
+        <p:nvSpPr>
+          <p:cNvPr id="12" name="Luz semáforo"/>
+          <p:cNvSpPr/>
+          <p:nvPr/>
+        </p:nvSpPr>
+        <p:spPr>
+          <a:xfrm>
+            <a:off x="4631436" y="2240280"/>
+            <a:ext cx="237744" cy="237744"/>
+          </a:xfrm>
+          <a:prstGeom prst="ellipse">
+            <a:avLst/>
+          </a:prstGeom>
+          <a:solidFill>
+            <a:srgbClr val="C4820A"/>
+          </a:solidFill>
+          <a:ln/>
+        </p:spPr>
+        <p:txBody>
+          <a:bodyPr/>
+          <a:p/>
+        </p:txBody>
+      </p:sp>
+      <p:sp>
+        <p:nvSpPr>
+          <p:cNvPr id="13" name="Text 11"/>
+          <p:cNvSpPr txBox="1"/>
+          <p:nvPr/>
+        </p:nvSpPr>
+        <p:spPr>
+          <a:xfrm>
+            <a:off x="4997196" y="2221992"/>
+            <a:ext cx="2286000" cy="274320"/>
+          </a:xfrm>
+          <a:prstGeom prst="rect">
+            <a:avLst/>
+          </a:prstGeom>
+          <a:noFill/>
+          <a:ln/>
+        </p:spPr>
+        <p:txBody>
+          <a:bodyPr wrap="square" lIns="0" tIns="0" rIns="0" bIns="0" rtlCol="0" anchor="ctr"/>
+          <a:lstStyle/>
+          <a:p>
+            <a:pPr indent="0" marL="0">
+              <a:buNone/>
+            </a:pPr>
+            <a:r>
+              <a:rPr lang="en-US" sz="1300" b="1" spc="200" kern="0" dirty="0">
+                <a:solidFill>
+                  <a:schemeClr val="tx1"/>
+                </a:solidFill>
+              </a:rPr>
+              <a:t>MEDIA</a:t>
+            </a:r>
+            <a:endParaRPr lang="en-US" sz="1300" dirty="0"/>
+          </a:p>
+        </p:txBody>
+      </p:sp>
+      <p:sp>
+        <p:nvSpPr>
+          <p:cNvPr id="14" name="Text 12"/>
+          <p:cNvSpPr txBox="1"/>
+          <p:nvPr/>
+        </p:nvSpPr>
+        <p:spPr>
+          <a:xfrm>
+            <a:off x="4631436" y="2606040"/>
+            <a:ext cx="2926080" cy="731520"/>
+          </a:xfrm>
+          <a:prstGeom prst="rect">
+            <a:avLst/>
+          </a:prstGeom>
+          <a:noFill/>
+          <a:ln/>
+        </p:spPr>
+        <p:txBody>
+          <a:bodyPr wrap="square" lIns="0" tIns="0" rIns="0" bIns="0" rtlCol="0" anchor="t"/>
+          <a:lstStyle/>
+          <a:p>
+            <a:pPr indent="0" marL="0">
+              <a:buNone/>
+            </a:pPr>
+            <a:r>
+              <a:rPr lang="en-US" sz="4200" b="1" dirty="0">
+                <a:solidFill>
+                  <a:schemeClr val="accent3"/>
+                </a:solidFill>
+                <a:latin typeface="+mj-lt" pitchFamily="34" charset="0"/>
+                <a:ea typeface="+mj-lt" pitchFamily="34" charset="-122"/>
+                <a:cs typeface="+mj-lt" pitchFamily="34" charset="-120"/>
+              </a:rPr>
+              <a:t>40–59</a:t>
+            </a:r>
+            <a:endParaRPr lang="en-US" sz="4200" dirty="0"/>
+          </a:p>
+        </p:txBody>
+      </p:sp>
+      <p:sp>
+        <p:nvSpPr>
+          <p:cNvPr id="15" name="Text 13"/>
+          <p:cNvSpPr txBox="1"/>
+          <p:nvPr/>
+        </p:nvSpPr>
+        <p:spPr>
+          <a:xfrm>
+            <a:off x="4631436" y="3337560"/>
+            <a:ext cx="2926080" cy="320040"/>
+          </a:xfrm>
+          <a:prstGeom prst="rect">
+            <a:avLst/>
+          </a:prstGeom>
+          <a:noFill/>
+          <a:ln/>
+        </p:spPr>
+        <p:txBody>
+          <a:bodyPr wrap="square" lIns="0" tIns="0" rIns="0" bIns="0" rtlCol="0" anchor="t"/>
+          <a:lstStyle/>
+          <a:p>
+            <a:pPr indent="0" marL="0">
+              <a:buNone/>
+            </a:pPr>
+            <a:r>
+              <a:rPr lang="en-US" sz="1600" b="1" dirty="0">
+                <a:solidFill>
+                  <a:schemeClr val="tx1"/>
+                </a:solidFill>
+              </a:rPr>
+              <a:t>Margen justo, condicionado</a:t>
+            </a:r>
+            <a:endParaRPr lang="en-US" sz="1600" dirty="0"/>
+          </a:p>
+        </p:txBody>
+      </p:sp>
+      <p:sp>
+        <p:nvSpPr>
+          <p:cNvPr id="16" name="Text 14"/>
+          <p:cNvSpPr txBox="1"/>
+          <p:nvPr/>
+        </p:nvSpPr>
+        <p:spPr>
+          <a:xfrm>
+            <a:off x="4631436" y="3703320"/>
+            <a:ext cx="2926080" cy="868680"/>
+          </a:xfrm>
+          <a:prstGeom prst="rect">
+            <a:avLst/>
+          </a:prstGeom>
+          <a:noFill/>
+          <a:ln/>
+        </p:spPr>
+        <p:txBody>
+          <a:bodyPr wrap="square" lIns="0" tIns="0" rIns="0" bIns="0" rtlCol="0" anchor="t"/>
+          <a:lstStyle/>
+          <a:p>
+            <a:pPr indent="0" marL="0">
+              <a:buNone/>
+            </a:pPr>
+            <a:r>
+              <a:rPr lang="en-US" sz="1400" dirty="0">
+                <a:solidFill>
+                  <a:schemeClr val="tx2"/>
+                </a:solidFill>
+              </a:rPr>
+              <a:t>Admite nuevos vecinos si se acompaña de inversiones puntuales en refuerzo de servicios.</a:t>
+            </a:r>
+            <a:endParaRPr lang="en-US" sz="1400" dirty="0"/>
+          </a:p>
+        </p:txBody>
+      </p:sp>
+      <p:sp>
+        <p:nvSpPr>
+          <p:cNvPr id="17" name="Nivel BAJA"/>
+          <p:cNvSpPr/>
+          <p:nvPr/>
+        </p:nvSpPr>
+        <p:spPr>
+          <a:xfrm>
+            <a:off x="8074152" y="1965960"/>
+            <a:ext cx="3474720" cy="2697480"/>
+          </a:xfrm>
+          <a:prstGeom prst="roundRect">
+            <a:avLst>
+              <a:gd name="adj" fmla="val 3390"/>
+            </a:avLst>
+          </a:prstGeom>
+          <a:solidFill>
+            <a:schemeClr val="bg2"/>
+          </a:solidFill>
+          <a:ln/>
+        </p:spPr>
+        <p:txBody>
+          <a:bodyPr/>
+          <a:p/>
+        </p:txBody>
+      </p:sp>
+      <p:sp>
+        <p:nvSpPr>
+          <p:cNvPr id="18" name="Luz semáforo"/>
+          <p:cNvSpPr/>
+          <p:nvPr/>
+        </p:nvSpPr>
+        <p:spPr>
+          <a:xfrm>
+            <a:off x="8348472" y="2240280"/>
+            <a:ext cx="237744" cy="237744"/>
+          </a:xfrm>
+          <a:prstGeom prst="ellipse">
+            <a:avLst/>
+          </a:prstGeom>
+          <a:solidFill>
+            <a:srgbClr val="C0263F"/>
+          </a:solidFill>
+          <a:ln/>
+        </p:spPr>
+        <p:txBody>
+          <a:bodyPr/>
+          <a:p/>
+        </p:txBody>
+      </p:sp>
+      <p:sp>
+        <p:nvSpPr>
+          <p:cNvPr id="19" name="Text 17"/>
+          <p:cNvSpPr txBox="1"/>
+          <p:nvPr/>
+        </p:nvSpPr>
+        <p:spPr>
+          <a:xfrm>
+            <a:off x="8714232" y="2221992"/>
+            <a:ext cx="2286000" cy="274320"/>
+          </a:xfrm>
+          <a:prstGeom prst="rect">
+            <a:avLst/>
+          </a:prstGeom>
+          <a:noFill/>
+          <a:ln/>
+        </p:spPr>
+        <p:txBody>
+          <a:bodyPr wrap="square" lIns="0" tIns="0" rIns="0" bIns="0" rtlCol="0" anchor="ctr"/>
+          <a:lstStyle/>
+          <a:p>
+            <a:pPr indent="0" marL="0">
+              <a:buNone/>
+            </a:pPr>
+            <a:r>
+              <a:rPr lang="en-US" sz="1300" b="1" spc="200" kern="0" dirty="0">
+                <a:solidFill>
+                  <a:schemeClr val="tx1"/>
+                </a:solidFill>
+              </a:rPr>
+              <a:t>BAJA</a:t>
+            </a:r>
+            <a:endParaRPr lang="en-US" sz="1300" dirty="0"/>
+          </a:p>
+        </p:txBody>
+      </p:sp>
+      <p:sp>
+        <p:nvSpPr>
+          <p:cNvPr id="20" name="Text 18"/>
+          <p:cNvSpPr txBox="1"/>
+          <p:nvPr/>
+        </p:nvSpPr>
+        <p:spPr>
+          <a:xfrm>
+            <a:off x="8348472" y="2606040"/>
+            <a:ext cx="2926080" cy="731520"/>
+          </a:xfrm>
+          <a:prstGeom prst="rect">
+            <a:avLst/>
+          </a:prstGeom>
+          <a:noFill/>
+          <a:ln/>
+        </p:spPr>
+        <p:txBody>
+          <a:bodyPr wrap="square" lIns="0" tIns="0" rIns="0" bIns="0" rtlCol="0" anchor="t"/>
+          <a:lstStyle/>
+          <a:p>
+            <a:pPr indent="0" marL="0">
+              <a:buNone/>
+            </a:pPr>
+            <a:r>
+              <a:rPr lang="en-US" sz="4200" b="1" dirty="0">
+                <a:solidFill>
+                  <a:schemeClr val="accent1"/>
+                </a:solidFill>
+                <a:latin typeface="+mj-lt" pitchFamily="34" charset="0"/>
+                <a:ea typeface="+mj-lt" pitchFamily="34" charset="-122"/>
+                <a:cs typeface="+mj-lt" pitchFamily="34" charset="-120"/>
+              </a:rPr>
+              <a:t>&lt; 40</a:t>
+            </a:r>
+            <a:endParaRPr lang="en-US" sz="4200" dirty="0"/>
+          </a:p>
+        </p:txBody>
+      </p:sp>
+      <p:sp>
+        <p:nvSpPr>
+          <p:cNvPr id="21" name="Text 19"/>
+          <p:cNvSpPr txBox="1"/>
+          <p:nvPr/>
+        </p:nvSpPr>
+        <p:spPr>
+          <a:xfrm>
+            <a:off x="8348472" y="3337560"/>
+            <a:ext cx="2926080" cy="320040"/>
+          </a:xfrm>
+          <a:prstGeom prst="rect">
+            <a:avLst/>
+          </a:prstGeom>
+          <a:noFill/>
+          <a:ln/>
+        </p:spPr>
+        <p:txBody>
+          <a:bodyPr wrap="square" lIns="0" tIns="0" rIns="0" bIns="0" rtlCol="0" anchor="t"/>
+          <a:lstStyle/>
+          <a:p>
+            <a:pPr indent="0" marL="0">
+              <a:buNone/>
+            </a:pPr>
+            <a:r>
+              <a:rPr lang="en-US" sz="1600" b="1" dirty="0">
+                <a:solidFill>
+                  <a:schemeClr val="tx1"/>
+                </a:solidFill>
+              </a:rPr>
+              <a:t>Sin margen: saturación</a:t>
+            </a:r>
+            <a:endParaRPr lang="en-US" sz="1600" dirty="0"/>
+          </a:p>
+        </p:txBody>
+      </p:sp>
+      <p:sp>
+        <p:nvSpPr>
+          <p:cNvPr id="22" name="Text 20"/>
+          <p:cNvSpPr txBox="1"/>
+          <p:nvPr/>
+        </p:nvSpPr>
+        <p:spPr>
+          <a:xfrm>
+            <a:off x="8348472" y="3703320"/>
+            <a:ext cx="2926080" cy="868680"/>
+          </a:xfrm>
+          <a:prstGeom prst="rect">
+            <a:avLst/>
+          </a:prstGeom>
+          <a:noFill/>
+          <a:ln/>
+        </p:spPr>
+        <p:txBody>
+          <a:bodyPr wrap="square" lIns="0" tIns="0" rIns="0" bIns="0" rtlCol="0" anchor="t"/>
+          <a:lstStyle/>
+          <a:p>
+            <a:pPr indent="0" marL="0">
+              <a:buNone/>
+            </a:pPr>
+            <a:r>
+              <a:rPr lang="en-US" sz="1400" dirty="0">
+                <a:solidFill>
+                  <a:schemeClr val="tx2"/>
+                </a:solidFill>
+              </a:rPr>
+              <a:t>Servicios esenciales en situación crítica: más vecinos provocan el colapso dotacional.</a:t>
+            </a:r>
+            <a:endParaRPr lang="en-US" sz="1400" dirty="0"/>
+          </a:p>
+        </p:txBody>
+      </p:sp>
+      <p:sp>
+        <p:nvSpPr>
+          <p:cNvPr id="23" name="Alerta S"/>
+          <p:cNvSpPr/>
+          <p:nvPr/>
+        </p:nvSpPr>
+        <p:spPr>
+          <a:xfrm>
+            <a:off x="640080" y="4846320"/>
+            <a:ext cx="10908792" cy="1325880"/>
+          </a:xfrm>
+          <a:prstGeom prst="roundRect">
+            <a:avLst>
+              <a:gd name="adj" fmla="val 6897"/>
+            </a:avLst>
+          </a:prstGeom>
+          <a:solidFill>
+            <a:schemeClr val="tx1"/>
+          </a:solidFill>
+          <a:ln/>
+        </p:spPr>
+        <p:txBody>
+          <a:bodyPr/>
+          <a:p/>
+        </p:txBody>
+      </p:sp>
+      <p:sp>
+        <p:nvSpPr>
+          <p:cNvPr id="24" name="Text 22"/>
+          <p:cNvSpPr txBox="1"/>
+          <p:nvPr/>
+        </p:nvSpPr>
+        <p:spPr>
+          <a:xfrm>
+            <a:off x="914400" y="4983480"/>
+            <a:ext cx="6400800" cy="256032"/>
+          </a:xfrm>
+          <a:prstGeom prst="rect">
+            <a:avLst/>
+          </a:prstGeom>
+          <a:noFill/>
+          <a:ln/>
+        </p:spPr>
+        <p:txBody>
+          <a:bodyPr wrap="square" lIns="0" tIns="0" rIns="0" bIns="0" rtlCol="0" anchor="t"/>
+          <a:lstStyle/>
+          <a:p>
+            <a:pPr indent="0" marL="0">
+              <a:buNone/>
+            </a:pPr>
+            <a:r>
+              <a:rPr lang="en-US" sz="1200" b="1" spc="200" kern="0" dirty="0">
+                <a:solidFill>
+                  <a:schemeClr val="accent6"/>
+                </a:solidFill>
+              </a:rPr>
+              <a:t>ALERTA S  ·  NO COMPENSATORIA</a:t>
+            </a:r>
+            <a:endParaRPr lang="en-US" sz="1200" dirty="0"/>
+          </a:p>
+        </p:txBody>
+      </p:sp>
+      <p:sp>
+        <p:nvSpPr>
+          <p:cNvPr id="25" name="Text 23"/>
+          <p:cNvSpPr txBox="1"/>
+          <p:nvPr/>
+        </p:nvSpPr>
+        <p:spPr>
+          <a:xfrm>
+            <a:off x="914400" y="5285232"/>
+            <a:ext cx="6949440" cy="822960"/>
+          </a:xfrm>
+          <a:prstGeom prst="rect">
+            <a:avLst/>
+          </a:prstGeom>
+          <a:noFill/>
+          <a:ln/>
+        </p:spPr>
+        <p:txBody>
+          <a:bodyPr wrap="square" lIns="0" tIns="0" rIns="0" bIns="0" rtlCol="0" anchor="t"/>
+          <a:lstStyle/>
+          <a:p>
+            <a:pPr indent="0" marL="0">
+              <a:buNone/>
+            </a:pPr>
+            <a:r>
+              <a:rPr lang="en-US" sz="1400" dirty="0">
+                <a:solidFill>
+                  <a:schemeClr val="bg1"/>
+                </a:solidFill>
+              </a:rPr>
+              <a:t>Se activa con más de 1.500 hab/médico o una ocupación escolar superior al 95%. El ICA total se trunca por debajo de 40 y el encaje máximo para cualquier ciudadano queda en 39, aunque la vivienda sea barata o sobren zonas verdes.</a:t>
+            </a:r>
+            <a:endParaRPr lang="en-US" sz="1400" dirty="0"/>
+          </a:p>
+        </p:txBody>
+      </p:sp>
+      <p:sp>
+        <p:nvSpPr>
+          <p:cNvPr id="26" name="Text 24"/>
+          <p:cNvSpPr txBox="1"/>
+          <p:nvPr/>
+        </p:nvSpPr>
+        <p:spPr>
+          <a:xfrm>
+            <a:off x="8229600" y="5029200"/>
+            <a:ext cx="3108960" cy="1051560"/>
+          </a:xfrm>
+          <a:prstGeom prst="rect">
+            <a:avLst/>
+          </a:prstGeom>
+          <a:noFill/>
+          <a:ln/>
+        </p:spPr>
+        <p:txBody>
+          <a:bodyPr wrap="square" lIns="0" tIns="0" rIns="0" bIns="0" rtlCol="0" anchor="t"/>
+          <a:lstStyle/>
+          <a:p>
+            <a:pPr indent="0" marL="0">
+              <a:buNone/>
+            </a:pPr>
+            <a:r>
+              <a:rPr lang="en-US" sz="1800" b="1" dirty="0">
+                <a:solidFill>
+                  <a:schemeClr val="bg1"/>
+                </a:solidFill>
+                <a:latin typeface="+mj-lt" pitchFamily="34" charset="0"/>
+                <a:ea typeface="+mj-lt" pitchFamily="34" charset="-122"/>
+                <a:cs typeface="+mj-lt" pitchFamily="34" charset="-120"/>
+              </a:rPr>
+              <a:t>Cercedilla</a:t>
+            </a:r>
+            <a:endParaRPr lang="en-US" sz="1800" dirty="0"/>
+          </a:p>
+          <a:p>
+            <a:pPr indent="0" marL="0">
+              <a:buNone/>
+            </a:pPr>
+            <a:r>
+              <a:rPr lang="en-US" sz="1400" dirty="0">
+                <a:solidFill>
+                  <a:schemeClr val="bg2"/>
+                </a:solidFill>
+              </a:rPr>
+              <a:t>Puntuación teórica de 34,61, clasificada con alerta S: la red asistencial no admite más presión.</a:t>
+            </a:r>
+            <a:endParaRPr lang="en-US" sz="1800" dirty="0"/>
+          </a:p>
+        </p:txBody>
+      </p:sp>
+      <p:sp>
+        <p:nvSpPr>
+          <p:cNvPr id="25" name="Slide Number Placeholder 0"/>
+          <p:cNvSpPr>
+            <a:spLocks noGrp="1"/>
+          </p:cNvSpPr>
+          <p:nvPr>
+            <p:ph type="sldNum" sz="quarter" idx="4294967295"/>
+          </p:nvPr>
+        </p:nvSpPr>
+        <p:spPr>
+          <a:xfrm>
+            <a:off x="10634472" y="6400800"/>
+            <a:ext cx="914400" cy="274320"/>
+          </a:xfrm>
+          <a:prstGeom prst="rect">
+            <a:avLst/>
+          </a:prstGeom>
+          <a:extLst>
+            <a:ext uri="{C572A759-6A51-4108-AA02-DFA0A04FC94B}">
+              <ma14:wrappingTextBoxFlag xmlns:ma14="http://schemas.microsoft.com/office/mac/drawingml/2011/main" val="0"/>
+            </a:ext>
+          </a:extLst>
+        </p:spPr>
+        <p:txBody>
+          <a:bodyPr lIns="0" tIns="0" rIns="0" bIns="0"/>
+          <a:lstStyle>
+            <a:lvl1pPr>
+              <a:defRPr sz="1000">
+                <a:solidFill>
+                  <a:schemeClr val="tx2"/>
+                </a:solidFill>
+              </a:defRPr>
+            </a:lvl1pPr>
+          </a:lstStyle>
+          <a:p>
+            <a:r>
+              <a:rPr sz="1000">
+                <a:solidFill>
+                  <a:srgbClr val="94A3B8"/>
+                </a:solidFill>
+                <a:latin typeface="Segoe UI"/>
+              </a:rPr>
+              <a:t>10</a:t>
+            </a:r>
+          </a:p>
+        </p:txBody>
+      </p:sp>
+    </p:spTree>
+  </p:cSld>
+  <p:clrMapOvr>
+    <a:masterClrMapping/>
+  </p:clrMapOvr>
+  <p:transition spd="med">
+    <p:fade/>
+  </p:transition>
+</p:sld>
+</file>
+
+<file path=ppt/slides/slide11.xml><?xml version="1.0" encoding="utf-8"?>
+<p:sld xmlns:a="http://schemas.openxmlformats.org/drawingml/2006/main" xmlns:r="http://schemas.openxmlformats.org/officeDocument/2006/relationships" xmlns:p="http://schemas.openxmlformats.org/presentationml/2006/main">
   <p:cSld name="Slide 10">
     <p:spTree>
       <p:nvGrpSpPr>
@@ -6896,18 +7826,15 @@
           <a:bodyPr wrap="square" lIns="0" tIns="0" rIns="0" bIns="0" rtlCol="0" anchor="t"/>
           <a:lstStyle/>
           <a:p>
-            <a:pPr algn="l" indent="0" marL="0">
-              <a:buNone/>
-            </a:pPr>
-            <a:r>
-              <a:rPr lang="en-US" sz="3200" b="1" dirty="0">
-                <a:solidFill>
-                  <a:schemeClr val="tx1"/>
-                </a:solidFill>
-              </a:rPr>
-              <a:t>El modelo aprende, no memoriza</a:t>
-            </a:r>
-            <a:endParaRPr lang="en-US" sz="3200" dirty="0"/>
+            <a:r>
+              <a:rPr sz="2100" b="1">
+                <a:solidFill>
+                  <a:srgbClr val="1E293B"/>
+                </a:solidFill>
+                <a:latin typeface="Segoe UI"/>
+              </a:rPr>
+              <a:t>Control de Overfitting: el modelo aprende, no memoriza</a:t>
+            </a:r>
           </a:p>
         </p:txBody>
       </p:sp>
@@ -6932,18 +7859,15 @@
           <a:bodyPr wrap="square" lIns="0" tIns="0" rIns="0" bIns="0" rtlCol="0" anchor="t"/>
           <a:lstStyle/>
           <a:p>
-            <a:pPr indent="0" marL="0">
-              <a:buNone/>
-            </a:pPr>
-            <a:r>
-              <a:rPr lang="en-US" sz="1600" dirty="0">
-                <a:solidFill>
-                  <a:schemeClr val="tx2"/>
-                </a:solidFill>
-              </a:rPr>
-              <a:t>Garantías contra la fuga de datos y validación espacial sin atajos</a:t>
-            </a:r>
-            <a:endParaRPr lang="en-US" sz="1600" dirty="0"/>
+            <a:r>
+              <a:rPr sz="1100">
+                <a:solidFill>
+                  <a:srgbClr val="64748B"/>
+                </a:solidFill>
+                <a:latin typeface="Segoe UI"/>
+              </a:rPr>
+              <a:t>Prevención activa de sobreajuste (overfitting), blindaje contra fugas L1-L7 y validación espacial</a:t>
+            </a:r>
           </a:p>
         </p:txBody>
       </p:sp>
@@ -7274,32 +8198,30 @@
           <a:bodyPr wrap="square" lIns="0" tIns="0" rIns="0" bIns="0" rtlCol="0" anchor="t"/>
           <a:lstStyle/>
           <a:p>
-            <a:pPr indent="0" marL="0">
-              <a:buNone/>
-            </a:pPr>
-            <a:r>
-              <a:rPr lang="en-US" sz="1600" b="1" dirty="0">
-                <a:solidFill>
-                  <a:schemeClr val="tx1"/>
-                </a:solidFill>
-              </a:rPr>
-              <a:t>Memorizar</a:t>
-            </a:r>
-            <a:endParaRPr lang="en-US" sz="1600" dirty="0"/>
-          </a:p>
-          <a:p>
-            <a:pPr indent="0" marL="0">
-              <a:buNone/>
-            </a:pPr>
-            <a:r>
-              <a:rPr lang="en-US" sz="1400" dirty="0">
-                <a:solidFill>
-                  <a:schemeClr val="tx2"/>
-                </a:solidFill>
-              </a:rPr>
-              <a:t>Con N = 20, un modelo demasiado complejo memoriza filas en lugar de aprender patrones.</a:t>
-            </a:r>
-            <a:endParaRPr lang="en-US" sz="1600" dirty="0"/>
+            <a:pPr>
+              <a:defRPr sz="1100" b="1">
+                <a:solidFill>
+                  <a:srgbClr val="B91C1C"/>
+                </a:solidFill>
+                <a:latin typeface="Segoe UI"/>
+              </a:defRPr>
+            </a:pPr>
+            <a:r>
+              <a:t>Overfitting / Memorizar</a:t>
+            </a:r>
+          </a:p>
+          <a:p>
+            <a:pPr>
+              <a:defRPr sz="950">
+                <a:solidFill>
+                  <a:srgbClr val="475569"/>
+                </a:solidFill>
+                <a:latin typeface="Segoe UI"/>
+              </a:defRPr>
+            </a:pPr>
+            <a:r>
+              <a:t>Con N = 20 evitamos redes neuronales complejas que sobreajustarían. Modelos regularizados (Ridge, árboles podados) y exportación ONNX.</a:t>
+            </a:r>
           </a:p>
         </p:txBody>
       </p:sp>
@@ -7434,32 +8356,33 @@
           <a:bodyPr wrap="square" lIns="0" tIns="0" rIns="0" bIns="0" rtlCol="0" anchor="t"/>
           <a:lstStyle/>
           <a:p>
-            <a:pPr indent="0" marL="0">
-              <a:buNone/>
-            </a:pPr>
-            <a:r>
-              <a:rPr lang="en-US" sz="1600" b="1" dirty="0">
-                <a:solidFill>
-                  <a:schemeClr val="bg1"/>
-                </a:solidFill>
-              </a:rPr>
+            <a:pPr>
+              <a:defRPr sz="1100" b="1">
+                <a:solidFill>
+                  <a:srgbClr val="FFFFFF"/>
+                </a:solidFill>
+                <a:latin typeface="Segoe UI"/>
+              </a:defRPr>
+            </a:pPr>
+            <a:r>
               <a:t>Comparativa adversarial</a:t>
             </a:r>
-            <a:endParaRPr lang="en-US" sz="1600" dirty="0"/>
-          </a:p>
-          <a:p>
-            <a:pPr indent="0" marL="0">
-              <a:buNone/>
-            </a:pPr>
-            <a:r>
-              <a:rPr lang="en-US" sz="1400" dirty="0">
-                <a:solidFill>
-                  <a:schemeClr val="bg2"/>
-                </a:solidFill>
-              </a:rPr>
-              <a:t>Versiones con y sin fuga deliberada, para confirmar que las métricas son generalización real.</a:t>
-            </a:r>
-            <a:endParaRPr lang="en-US" sz="1600" dirty="0"/>
+          </a:p>
+          <a:p>
+            <a:pPr>
+              <a:spcBef>
+                <a:spcPts val="200"/>
+              </a:spcBef>
+              <a:defRPr sz="950">
+                <a:solidFill>
+                  <a:srgbClr val="CBD5E1"/>
+                </a:solidFill>
+                <a:latin typeface="Segoe UI"/>
+              </a:defRPr>
+            </a:pPr>
+            <a:r>
+              <a:t>Versiones con y sin fuga deliberada para confirmar que el R² honesto generaliza sin sobreajuste ni trampas.</a:t>
+            </a:r>
           </a:p>
         </p:txBody>
       </p:sp>
@@ -7534,30 +8457,33 @@
           <a:p>
             <a:pPr indent="0" marL="0">
               <a:buNone/>
-            </a:pPr>
-            <a:r>
-              <a:rPr lang="en-US" sz="1600" b="1" dirty="0">
-                <a:solidFill>
-                  <a:schemeClr val="bg1"/>
-                </a:solidFill>
-              </a:rPr>
+              <a:defRPr sz="1100" b="1">
+                <a:solidFill>
+                  <a:srgbClr val="FFFFFF"/>
+                </a:solidFill>
+                <a:latin typeface="Segoe UI"/>
+              </a:defRPr>
+            </a:pPr>
+            <a:r>
               <a:t>Validación espacial GroupKFold</a:t>
             </a:r>
             <a:endParaRPr lang="en-US" sz="1600" dirty="0"/>
           </a:p>
           <a:p>
-            <a:pPr indent="0" marL="0">
-              <a:buNone/>
-            </a:pPr>
-            <a:r>
-              <a:rPr lang="en-US" sz="1400" dirty="0">
-                <a:solidFill>
-                  <a:schemeClr val="bg2"/>
-                </a:solidFill>
-              </a:rPr>
-              <a:t>Los municipios de una misma comarca van juntos a entrenamiento o a prueba.</a:t>
-            </a:r>
-            <a:endParaRPr lang="en-US" sz="1600" dirty="0"/>
+            <a:pPr>
+              <a:spcBef>
+                <a:spcPts val="200"/>
+              </a:spcBef>
+              <a:defRPr sz="950">
+                <a:solidFill>
+                  <a:srgbClr val="CBD5E1"/>
+                </a:solidFill>
+                <a:latin typeface="Segoe UI"/>
+              </a:defRPr>
+            </a:pPr>
+            <a:r>
+              <a:t>Los municipios de una misma comarca van juntos a entrenamiento o a prueba sin filtrar información.</a:t>
+            </a:r>
           </a:p>
         </p:txBody>
       </p:sp>
@@ -7632,30 +8558,33 @@
           <a:p>
             <a:pPr indent="0" marL="0">
               <a:buNone/>
-            </a:pPr>
-            <a:r>
-              <a:rPr lang="en-US" sz="1600" b="1" dirty="0">
-                <a:solidFill>
-                  <a:schemeClr val="bg1"/>
-                </a:solidFill>
-              </a:rPr>
+              <a:defRPr sz="1100" b="1">
+                <a:solidFill>
+                  <a:srgbClr val="FFFFFF"/>
+                </a:solidFill>
+                <a:latin typeface="Segoe UI"/>
+              </a:defRPr>
+            </a:pPr>
+            <a:r>
               <a:t>Control point-in-time</a:t>
             </a:r>
             <a:endParaRPr lang="en-US" sz="1600" dirty="0"/>
           </a:p>
           <a:p>
-            <a:pPr indent="0" marL="0">
-              <a:buNone/>
-            </a:pPr>
-            <a:r>
-              <a:rPr lang="en-US" sz="1400" dirty="0">
-                <a:solidFill>
-                  <a:schemeClr val="bg2"/>
-                </a:solidFill>
-              </a:rPr>
-              <a:t>Ningún dato de entrada es posterior a la fecha de decisión del MVP.</a:t>
-            </a:r>
-            <a:endParaRPr lang="en-US" sz="1600" dirty="0"/>
+            <a:pPr>
+              <a:spcBef>
+                <a:spcPts val="200"/>
+              </a:spcBef>
+              <a:defRPr sz="950">
+                <a:solidFill>
+                  <a:srgbClr val="CBD5E1"/>
+                </a:solidFill>
+                <a:latin typeface="Segoe UI"/>
+              </a:defRPr>
+            </a:pPr>
+            <a:r>
+              <a:t>Ningún dato de entrada es posterior a la fecha de decisión del MVP para evitar mirar al futuro.</a:t>
+            </a:r>
           </a:p>
         </p:txBody>
       </p:sp>
@@ -7728,13 +8657,32 @@
           <a:bodyPr wrap="square" lIns="0" tIns="0" rIns="0" bIns="0" rtlCol="0" anchor="t"/>
           <a:lstStyle/>
           <a:p>
-            <a:r>
-              <a:t>73 tests unitarios y de integración</a:t>
-            </a:r>
-          </a:p>
-          <a:p>
-            <a:r>
-              <a:t>Auditan las 7 fugas posibles (L1 a L7) con pytest.</a:t>
+            <a:pPr>
+              <a:defRPr sz="1100" b="1">
+                <a:solidFill>
+                  <a:srgbClr val="FFFFFF"/>
+                </a:solidFill>
+                <a:latin typeface="Segoe UI"/>
+              </a:defRPr>
+            </a:pPr>
+            <a:r>
+              <a:t>73 tests continuos en verde</a:t>
+            </a:r>
+          </a:p>
+          <a:p>
+            <a:pPr>
+              <a:spcBef>
+                <a:spcPts val="200"/>
+              </a:spcBef>
+              <a:defRPr sz="950">
+                <a:solidFill>
+                  <a:srgbClr val="CBD5E1"/>
+                </a:solidFill>
+                <a:latin typeface="Segoe UI"/>
+              </a:defRPr>
+            </a:pPr>
+            <a:r>
+              <a:t>Auditan las 7 fugas de overfitting (L1 a L7) con pytest para garantizar rigor metodológico.</a:t>
             </a:r>
           </a:p>
         </p:txBody>
@@ -7798,7 +8746,7 @@
 </p:sld>
 </file>
 
-<file path=ppt/slides/slide11.xml><?xml version="1.0" encoding="utf-8"?>
+<file path=ppt/slides/slide12.xml><?xml version="1.0" encoding="utf-8"?>
 <p:sld xmlns:a="http://schemas.openxmlformats.org/drawingml/2006/main" xmlns:r="http://schemas.openxmlformats.org/officeDocument/2006/relationships" xmlns:p="http://schemas.openxmlformats.org/presentationml/2006/main">
   <p:cSld name="Slide 11">
     <p:spTree>
@@ -8590,7 +9538,7 @@
 </p:sld>
 </file>
 
-<file path=ppt/slides/slide12.xml><?xml version="1.0" encoding="utf-8"?>
+<file path=ppt/slides/slide13.xml><?xml version="1.0" encoding="utf-8"?>
 <p:sld xmlns:a="http://schemas.openxmlformats.org/drawingml/2006/main" xmlns:r="http://schemas.openxmlformats.org/officeDocument/2006/relationships" xmlns:p="http://schemas.openxmlformats.org/presentationml/2006/main">
   <p:cSld name="Slide 12">
     <p:spTree>
@@ -8743,47 +9691,137 @@
           <a:bodyPr wrap="square" lIns="0" tIns="0" rIns="0" bIns="0" rtlCol="0" anchor="t"/>
           <a:lstStyle/>
           <a:p>
+            <a:pPr>
+              <a:defRPr sz="1200" b="1">
+                <a:solidFill>
+                  <a:srgbClr val="FFFFFF"/>
+                </a:solidFill>
+                <a:latin typeface="Segoe UI"/>
+              </a:defRPr>
+            </a:pPr>
+            <a:r>
+              <a:t>Resolución empírica y Backtest</a:t>
+            </a:r>
+          </a:p>
+          <a:p>
+            <a:pPr>
+              <a:spcBef>
+                <a:spcPts val="200"/>
+              </a:spcBef>
+              <a:defRPr sz="1000">
+                <a:solidFill>
+                  <a:srgbClr val="CBD5E1"/>
+                </a:solidFill>
+                <a:latin typeface="Segoe UI"/>
+              </a:defRPr>
+            </a:pPr>
+            <a:r>
+              <a:t>Sustituimos la especulación por un marco cuantitativo verificado con backtesting histórico (1,55% de error mediano) evitando cualquier overfitting.</a:t>
+            </a:r>
+          </a:p>
+        </p:txBody>
+      </p:sp>
+      <p:sp>
+        <p:nvSpPr>
+          <p:cNvPr id="6" name="Text 4"/>
+          <p:cNvSpPr txBox="1"/>
+          <p:nvPr/>
+        </p:nvSpPr>
+        <p:spPr>
+          <a:xfrm>
+            <a:off x="640080" y="3291840"/>
+            <a:ext cx="640080" cy="822960"/>
+          </a:xfrm>
+          <a:prstGeom prst="rect">
+            <a:avLst/>
+          </a:prstGeom>
+          <a:noFill/>
+          <a:ln/>
+        </p:spPr>
+        <p:txBody>
+          <a:bodyPr wrap="square" lIns="0" tIns="0" rIns="0" bIns="0" rtlCol="0" anchor="t"/>
+          <a:lstStyle/>
+          <a:p>
             <a:pPr indent="0" marL="0">
               <a:buNone/>
             </a:pPr>
             <a:r>
-              <a:rPr lang="en-US" sz="2000" b="1" dirty="0">
-                <a:solidFill>
-                  <a:schemeClr val="bg1"/>
+              <a:rPr lang="en-US" sz="4800" b="1" dirty="0">
+                <a:solidFill>
+                  <a:schemeClr val="accent6"/>
                 </a:solidFill>
                 <a:latin typeface="+mj-lt" pitchFamily="34" charset="0"/>
                 <a:ea typeface="+mj-lt" pitchFamily="34" charset="-122"/>
                 <a:cs typeface="+mj-lt" pitchFamily="34" charset="-120"/>
               </a:rPr>
-              <a:t>Resolución empírica</a:t>
+              <a:t>2</a:t>
+            </a:r>
+            <a:endParaRPr lang="en-US" sz="4800" dirty="0"/>
+          </a:p>
+        </p:txBody>
+      </p:sp>
+      <p:sp>
+        <p:nvSpPr>
+          <p:cNvPr id="7" name="Text 5"/>
+          <p:cNvSpPr txBox="1"/>
+          <p:nvPr/>
+        </p:nvSpPr>
+        <p:spPr>
+          <a:xfrm>
+            <a:off x="1417320" y="3337560"/>
+            <a:ext cx="5303520" cy="1325880"/>
+          </a:xfrm>
+          <a:prstGeom prst="rect">
+            <a:avLst/>
+          </a:prstGeom>
+          <a:noFill/>
+          <a:ln/>
+        </p:spPr>
+        <p:txBody>
+          <a:bodyPr wrap="square" lIns="0" tIns="0" rIns="0" bIns="0" rtlCol="0" anchor="t"/>
+          <a:lstStyle/>
+          <a:p>
+            <a:pPr indent="0" marL="0">
+              <a:buNone/>
+              <a:defRPr sz="1200" b="1">
+                <a:solidFill>
+                  <a:srgbClr val="FFFFFF"/>
+                </a:solidFill>
+                <a:latin typeface="Segoe UI"/>
+              </a:defRPr>
+            </a:pPr>
+            <a:r>
+              <a:t>Doble utilidad</a:t>
             </a:r>
             <a:endParaRPr lang="en-US" sz="2000" dirty="0"/>
           </a:p>
           <a:p>
-            <a:pPr indent="0" marL="0">
-              <a:buNone/>
-            </a:pPr>
-            <a:r>
-              <a:rPr lang="en-US" sz="1500" dirty="0">
-                <a:solidFill>
-                  <a:schemeClr val="bg2"/>
-                </a:solidFill>
-              </a:rPr>
-              <a:t>Sustituimos la especulación por un marco cuantitativo verificado con backtest real (1,55% de error mediano) que integra capacidad dotacional y precios.</a:t>
-            </a:r>
-            <a:endParaRPr lang="en-US" sz="2000" dirty="0"/>
-          </a:p>
-        </p:txBody>
-      </p:sp>
-      <p:sp>
-        <p:nvSpPr>
-          <p:cNvPr id="6" name="Text 4"/>
+            <a:pPr>
+              <a:spcBef>
+                <a:spcPts val="200"/>
+              </a:spcBef>
+              <a:defRPr sz="1000">
+                <a:solidFill>
+                  <a:srgbClr val="CBD5E1"/>
+                </a:solidFill>
+                <a:latin typeface="Segoe UI"/>
+              </a:defRPr>
+            </a:pPr>
+            <a:r>
+              <a:t>Sirve a las familias que planifican su traslado y a los gestores públicos que reparten recursos con rigor.</a:t>
+            </a:r>
+          </a:p>
+        </p:txBody>
+      </p:sp>
+      <p:sp>
+        <p:nvSpPr>
+          <p:cNvPr id="8" name="Text 6"/>
           <p:cNvSpPr txBox="1"/>
           <p:nvPr/>
         </p:nvSpPr>
         <p:spPr>
           <a:xfrm>
-            <a:off x="640080" y="3291840"/>
+            <a:off x="640080" y="4754880"/>
             <a:ext cx="640080" cy="822960"/>
           </a:xfrm>
           <a:prstGeom prst="rect">
@@ -8808,98 +9846,6 @@
                 <a:ea typeface="+mj-lt" pitchFamily="34" charset="-122"/>
                 <a:cs typeface="+mj-lt" pitchFamily="34" charset="-120"/>
               </a:rPr>
-              <a:t>2</a:t>
-            </a:r>
-            <a:endParaRPr lang="en-US" sz="4800" dirty="0"/>
-          </a:p>
-        </p:txBody>
-      </p:sp>
-      <p:sp>
-        <p:nvSpPr>
-          <p:cNvPr id="7" name="Text 5"/>
-          <p:cNvSpPr txBox="1"/>
-          <p:nvPr/>
-        </p:nvSpPr>
-        <p:spPr>
-          <a:xfrm>
-            <a:off x="1417320" y="3337560"/>
-            <a:ext cx="5303520" cy="1325880"/>
-          </a:xfrm>
-          <a:prstGeom prst="rect">
-            <a:avLst/>
-          </a:prstGeom>
-          <a:noFill/>
-          <a:ln/>
-        </p:spPr>
-        <p:txBody>
-          <a:bodyPr wrap="square" lIns="0" tIns="0" rIns="0" bIns="0" rtlCol="0" anchor="t"/>
-          <a:lstStyle/>
-          <a:p>
-            <a:pPr indent="0" marL="0">
-              <a:buNone/>
-            </a:pPr>
-            <a:r>
-              <a:rPr lang="en-US" sz="2000" b="1" dirty="0">
-                <a:solidFill>
-                  <a:schemeClr val="bg1"/>
-                </a:solidFill>
-                <a:latin typeface="+mj-lt" pitchFamily="34" charset="0"/>
-                <a:ea typeface="+mj-lt" pitchFamily="34" charset="-122"/>
-                <a:cs typeface="+mj-lt" pitchFamily="34" charset="-120"/>
-              </a:rPr>
-              <a:t>Doble utilidad</a:t>
-            </a:r>
-            <a:endParaRPr lang="en-US" sz="2000" dirty="0"/>
-          </a:p>
-          <a:p>
-            <a:pPr indent="0" marL="0">
-              <a:buNone/>
-            </a:pPr>
-            <a:r>
-              <a:rPr lang="en-US" sz="1500" dirty="0">
-                <a:solidFill>
-                  <a:schemeClr val="bg2"/>
-                </a:solidFill>
-              </a:rPr>
-              <a:t>Sirve a las familias que planifican su traslado y a los gestores públicos que reparten recursos con rigor.</a:t>
-            </a:r>
-            <a:endParaRPr lang="en-US" sz="2000" dirty="0"/>
-          </a:p>
-        </p:txBody>
-      </p:sp>
-      <p:sp>
-        <p:nvSpPr>
-          <p:cNvPr id="8" name="Text 6"/>
-          <p:cNvSpPr txBox="1"/>
-          <p:nvPr/>
-        </p:nvSpPr>
-        <p:spPr>
-          <a:xfrm>
-            <a:off x="640080" y="4754880"/>
-            <a:ext cx="640080" cy="822960"/>
-          </a:xfrm>
-          <a:prstGeom prst="rect">
-            <a:avLst/>
-          </a:prstGeom>
-          <a:noFill/>
-          <a:ln/>
-        </p:spPr>
-        <p:txBody>
-          <a:bodyPr wrap="square" lIns="0" tIns="0" rIns="0" bIns="0" rtlCol="0" anchor="t"/>
-          <a:lstStyle/>
-          <a:p>
-            <a:pPr indent="0" marL="0">
-              <a:buNone/>
-            </a:pPr>
-            <a:r>
-              <a:rPr lang="en-US" sz="4800" b="1" dirty="0">
-                <a:solidFill>
-                  <a:schemeClr val="accent6"/>
-                </a:solidFill>
-                <a:latin typeface="+mj-lt" pitchFamily="34" charset="0"/>
-                <a:ea typeface="+mj-lt" pitchFamily="34" charset="-122"/>
-                <a:cs typeface="+mj-lt" pitchFamily="34" charset="-120"/>
-              </a:rPr>
               <a:t>3</a:t>
             </a:r>
             <a:endParaRPr lang="en-US" sz="4800" dirty="0"/>
@@ -8927,35 +9873,33 @@
           <a:bodyPr wrap="square" lIns="0" tIns="0" rIns="0" bIns="0" rtlCol="0" anchor="t"/>
           <a:lstStyle/>
           <a:p>
-            <a:pPr indent="0" marL="0">
-              <a:buNone/>
-            </a:pPr>
-            <a:r>
-              <a:rPr lang="en-US" sz="2000" b="1" dirty="0">
-                <a:solidFill>
-                  <a:schemeClr val="bg1"/>
-                </a:solidFill>
-                <a:latin typeface="+mj-lt" pitchFamily="34" charset="0"/>
-                <a:ea typeface="+mj-lt" pitchFamily="34" charset="-122"/>
-                <a:cs typeface="+mj-lt" pitchFamily="34" charset="-120"/>
-              </a:rPr>
-              <a:t>Escalable en Oracle 23ai</a:t>
-            </a:r>
-            <a:endParaRPr lang="en-US" sz="2000" dirty="0"/>
-          </a:p>
-          <a:p>
-            <a:pPr indent="0" marL="0">
-              <a:buNone/>
-            </a:pPr>
-            <a:r>
-              <a:rPr lang="en-US" sz="1500" dirty="0">
-                <a:solidFill>
-                  <a:schemeClr val="bg2"/>
-                </a:solidFill>
-              </a:rPr>
-              <a:t>Listo para los 155 municipios en cuanto la Comunidad de Madrid incorpore los registros internos de centros y plazas.</a:t>
-            </a:r>
-            <a:endParaRPr lang="en-US" sz="2000" dirty="0"/>
+            <a:pPr>
+              <a:defRPr sz="1200" b="1">
+                <a:solidFill>
+                  <a:srgbClr val="FFFFFF"/>
+                </a:solidFill>
+                <a:latin typeface="Segoe UI"/>
+              </a:defRPr>
+            </a:pPr>
+            <a:r>
+              <a:t>Cobertura regional en Git (¡Ya implementada!)</a:t>
+            </a:r>
+          </a:p>
+          <a:p>
+            <a:pPr>
+              <a:spcBef>
+                <a:spcPts val="200"/>
+              </a:spcBef>
+              <a:defRPr sz="1000">
+                <a:solidFill>
+                  <a:srgbClr val="CBD5E1"/>
+                </a:solidFill>
+                <a:latin typeface="Segoe UI"/>
+              </a:defRPr>
+            </a:pPr>
+            <a:r>
+              <a:t>Capa real de 155 municipios &lt; 50k hab. (997.059 hab., 0 nulos) y 179 municipios de la CAM ya ingestada con datos 100% oficiales (pipeline_179.py) y lista para Oracle 23ai.</a:t>
+            </a:r>
           </a:p>
         </p:txBody>
       </p:sp>
@@ -9083,7 +10027,7 @@
 </p:sld>
 </file>
 
-<file path=ppt/slides/slide13.xml><?xml version="1.0" encoding="utf-8"?>
+<file path=ppt/slides/slide14.xml><?xml version="1.0" encoding="utf-8"?>
 <p:sld xmlns:a="http://schemas.openxmlformats.org/drawingml/2006/main" xmlns:r="http://schemas.openxmlformats.org/officeDocument/2006/relationships" xmlns:p="http://schemas.openxmlformats.org/presentationml/2006/main" show="0">
   <p:cSld name="Slide 13">
     <p:spTree>
@@ -9452,21 +10396,17 @@
           <a:bodyPr wrap="square" lIns="0" tIns="0" rIns="0" bIns="0" rtlCol="0" anchor="t"/>
           <a:lstStyle/>
           <a:p>
-            <a:pPr indent="0" marL="0">
-              <a:buNone/>
-            </a:pPr>
-            <a:r>
-              <a:rPr lang="en-US" sz="1800" b="1" dirty="0">
-                <a:solidFill>
-                  <a:schemeClr val="accent1"/>
-                </a:solidFill>
-                <a:latin typeface="+mj-lt" pitchFamily="34" charset="0"/>
-                <a:ea typeface="+mj-lt" pitchFamily="34" charset="-122"/>
-                <a:cs typeface="+mj-lt" pitchFamily="34" charset="-120"/>
-              </a:rPr>
-              <a:t>¿Por qué no usáis deep learning?</a:t>
-            </a:r>
-            <a:endParaRPr lang="en-US" sz="1800" dirty="0"/>
+            <a:pPr>
+              <a:defRPr sz="1100" b="1">
+                <a:solidFill>
+                  <a:srgbClr val="1E293B"/>
+                </a:solidFill>
+                <a:latin typeface="Segoe UI"/>
+              </a:defRPr>
+            </a:pPr>
+            <a:r>
+              <a:t>¿Por qué no deep learning / Cómo evitáis el overfitting?</a:t>
+            </a:r>
           </a:p>
         </p:txBody>
       </p:sp>
@@ -9491,18 +10431,17 @@
           <a:bodyPr wrap="square" lIns="0" tIns="0" rIns="0" bIns="0" rtlCol="0" anchor="t"/>
           <a:lstStyle/>
           <a:p>
-            <a:pPr indent="0" marL="0">
-              <a:buNone/>
-            </a:pPr>
-            <a:r>
-              <a:rPr lang="en-US" sz="1500" dirty="0">
-                <a:solidFill>
-                  <a:schemeClr val="tx2"/>
-                </a:solidFill>
-              </a:rPr>
-              <a:t>Con 20 municipios y sin etiquetas arbitrarias, una red neuronal sobreajustaría. Usamos árboles regularizados exportados a ONNX con tolerancia &lt; 1e-6.</a:t>
-            </a:r>
-            <a:endParaRPr lang="en-US" sz="1500" dirty="0"/>
+            <a:pPr>
+              <a:defRPr sz="950">
+                <a:solidFill>
+                  <a:srgbClr val="475569"/>
+                </a:solidFill>
+                <a:latin typeface="Segoe UI"/>
+              </a:defRPr>
+            </a:pPr>
+            <a:r>
+              <a:t>Con 20 municipios, el deep learning causaría un severo overfitting. Empleamos modelos regularizados, validación GroupKFold por comarca y árboles exportados a ONNX con tolerancia &lt; 1e-6.</a:t>
+            </a:r>
           </a:p>
         </p:txBody>
       </p:sp>
@@ -9666,7 +10605,7 @@
 </p:sld>
 </file>
 
-<file path=ppt/slides/slide14.xml><?xml version="1.0" encoding="utf-8"?>
+<file path=ppt/slides/slide15.xml><?xml version="1.0" encoding="utf-8"?>
 <p:sld xmlns:a="http://schemas.openxmlformats.org/drawingml/2006/main" xmlns:r="http://schemas.openxmlformats.org/officeDocument/2006/relationships" xmlns:p="http://schemas.openxmlformats.org/presentationml/2006/main">
   <p:cSld name="Slide 14">
     <p:spTree>
@@ -13284,656 +14223,6 @@
   <p:transition spd="med">
     <p:fade/>
   </p:transition>
-</p:sld>
-</file>
-
-<file path=ppt/slides/slide15.xml><?xml version="1.0" encoding="utf-8"?>
-<p:sld xmlns:a="http://schemas.openxmlformats.org/drawingml/2006/main" xmlns:p="http://schemas.openxmlformats.org/presentationml/2006/main" xmlns:r="http://schemas.openxmlformats.org/officeDocument/2006/relationships">
-  <p:cSld>
-    <p:spTree>
-      <p:nvGrpSpPr>
-        <p:cNvPr id="1" name=""/>
-        <p:cNvGrpSpPr/>
-        <p:nvPr/>
-      </p:nvGrpSpPr>
-      <p:grpSpPr/>
-      <p:sp>
-        <p:nvSpPr>
-          <p:cNvPr id="2" name="Text Placeholder 1"/>
-          <p:cNvSpPr>
-            <a:spLocks noGrp="1"/>
-          </p:cNvSpPr>
-          <p:nvPr>
-            <p:ph type="body" idx="100"/>
-          </p:nvPr>
-        </p:nvSpPr>
-        <p:spPr/>
-        <p:txBody>
-          <a:bodyPr/>
-          <a:lstStyle/>
-          <a:p>
-            <a:pPr>
-              <a:defRPr sz="1050" b="1">
-                <a:solidFill>
-                  <a:srgbClr val="C8102E"/>
-                </a:solidFill>
-                <a:latin typeface="Segoe UI"/>
-              </a:defRPr>
-            </a:pPr>
-            <a:r>
-              <a:t>DEMOSTRACIÓN EN DIRECTO</a:t>
-            </a:r>
-          </a:p>
-        </p:txBody>
-      </p:sp>
-      <p:sp>
-        <p:nvSpPr>
-          <p:cNvPr id="3" name="Title 2"/>
-          <p:cNvSpPr>
-            <a:spLocks noGrp="1"/>
-          </p:cNvSpPr>
-          <p:nvPr>
-            <p:ph type="title" idx="101"/>
-          </p:nvPr>
-        </p:nvSpPr>
-        <p:spPr/>
-        <p:txBody>
-          <a:bodyPr/>
-          <a:lstStyle/>
-          <a:p>
-            <a:pPr>
-              <a:defRPr sz="2100" b="1">
-                <a:solidFill>
-                  <a:srgbClr val="1E293B"/>
-                </a:solidFill>
-                <a:latin typeface="Segoe UI"/>
-              </a:defRPr>
-            </a:pPr>
-            <a:r>
-              <a:t>Plataforma interactiva (MVP) y panel de datos</a:t>
-            </a:r>
-          </a:p>
-        </p:txBody>
-      </p:sp>
-      <p:sp>
-        <p:nvSpPr>
-          <p:cNvPr id="4" name="TextBox 3"/>
-          <p:cNvSpPr txBox="1"/>
-          <p:nvPr/>
-        </p:nvSpPr>
-        <p:spPr>
-          <a:xfrm>
-            <a:off x="640080" y="1325880"/>
-            <a:ext cx="10881360" cy="365760"/>
-          </a:xfrm>
-          <a:prstGeom prst="rect">
-            <a:avLst/>
-          </a:prstGeom>
-          <a:noFill/>
-        </p:spPr>
-        <p:txBody>
-          <a:bodyPr wrap="square">
-            <a:spAutoFit/>
-          </a:bodyPr>
-          <a:lstStyle/>
-          <a:p>
-            <a:pPr>
-              <a:defRPr sz="1100">
-                <a:solidFill>
-                  <a:srgbClr val="64748B"/>
-                </a:solidFill>
-                <a:latin typeface="Segoe UI"/>
-              </a:defRPr>
-            </a:pPr>
-            <a:r>
-              <a:t>Espacio de transición para la demostración del prototipo funcional web y la estructura del panel de datos</a:t>
-            </a:r>
-          </a:p>
-        </p:txBody>
-      </p:sp>
-      <p:sp>
-        <p:nvSpPr>
-          <p:cNvPr id="5" name="Rounded Rectangle 4"/>
-          <p:cNvSpPr/>
-          <p:nvPr/>
-        </p:nvSpPr>
-        <p:spPr>
-          <a:xfrm>
-            <a:off x="640080" y="1783080"/>
-            <a:ext cx="5257800" cy="4434840"/>
-          </a:xfrm>
-          <a:prstGeom prst="roundRect">
-            <a:avLst/>
-          </a:prstGeom>
-          <a:solidFill>
-            <a:srgbClr val="FFFFFF"/>
-          </a:solidFill>
-          <a:ln w="12700">
-            <a:solidFill>
-              <a:srgbClr val="E2E8F0"/>
-            </a:solidFill>
-          </a:ln>
-        </p:spPr>
-        <p:style>
-          <a:lnRef idx="1">
-            <a:schemeClr val="accent1"/>
-          </a:lnRef>
-          <a:fillRef idx="3">
-            <a:schemeClr val="accent1"/>
-          </a:fillRef>
-          <a:effectRef idx="2">
-            <a:schemeClr val="accent1"/>
-          </a:effectRef>
-          <a:fontRef idx="minor">
-            <a:schemeClr val="lt1"/>
-          </a:fontRef>
-        </p:style>
-        <p:txBody>
-          <a:bodyPr rtlCol="0" anchor="ctr"/>
-          <a:lstStyle/>
-          <a:p>
-            <a:pPr algn="ctr"/>
-          </a:p>
-        </p:txBody>
-      </p:sp>
-      <p:sp>
-        <p:nvSpPr>
-          <p:cNvPr id="6" name="TextBox 5"/>
-          <p:cNvSpPr txBox="1"/>
-          <p:nvPr/>
-        </p:nvSpPr>
-        <p:spPr>
-          <a:xfrm>
-            <a:off x="822960" y="1874519"/>
-            <a:ext cx="4892040" cy="594360"/>
-          </a:xfrm>
-          <a:prstGeom prst="rect">
-            <a:avLst/>
-          </a:prstGeom>
-          <a:noFill/>
-        </p:spPr>
-        <p:txBody>
-          <a:bodyPr wrap="square" lIns="0" rIns="0" tIns="0" bIns="0">
-            <a:spAutoFit/>
-          </a:bodyPr>
-          <a:lstStyle/>
-          <a:p>
-            <a:pPr>
-              <a:defRPr sz="1200" b="1">
-                <a:solidFill>
-                  <a:srgbClr val="1E40AF"/>
-                </a:solidFill>
-                <a:latin typeface="Segoe UI"/>
-              </a:defRPr>
-            </a:pPr>
-            <a:r>
-              <a:t>DEMO EN VIVO  ·  MVP WEB INTERACTIVO</a:t>
-            </a:r>
-          </a:p>
-          <a:p>
-            <a:pPr>
-              <a:spcBef>
-                <a:spcPts val="200"/>
-              </a:spcBef>
-              <a:defRPr sz="900">
-                <a:solidFill>
-                  <a:srgbClr val="64748B"/>
-                </a:solidFill>
-                <a:latin typeface="Consolas"/>
-              </a:defRPr>
-            </a:pPr>
-            <a:r>
-              <a:t>http://localhost:8088/index.html  ·  mapa/mapa.html</a:t>
-            </a:r>
-          </a:p>
-        </p:txBody>
-      </p:sp>
-      <p:pic>
-        <p:nvPicPr>
-          <p:cNvPr id="7" name="Picture 6" descr="mvp_screenshot.png"/>
-          <p:cNvPicPr>
-            <a:picLocks noChangeAspect="1"/>
-          </p:cNvPicPr>
-          <p:nvPr/>
-        </p:nvPicPr>
-        <p:blipFill>
-          <a:blip r:embed="rId2"/>
-          <a:stretch>
-            <a:fillRect/>
-          </a:stretch>
-        </p:blipFill>
-        <p:spPr>
-          <a:xfrm>
-            <a:off x="822960" y="2514600"/>
-            <a:ext cx="4892040" cy="2148840"/>
-          </a:xfrm>
-          <a:prstGeom prst="rect">
-            <a:avLst/>
-          </a:prstGeom>
-          <a:ln w="12700">
-            <a:solidFill>
-              <a:srgbClr val="CBD5E1"/>
-            </a:solidFill>
-          </a:ln>
-        </p:spPr>
-      </p:pic>
-      <p:sp>
-        <p:nvSpPr>
-          <p:cNvPr id="8" name="TextBox 7"/>
-          <p:cNvSpPr txBox="1"/>
-          <p:nvPr/>
-        </p:nvSpPr>
-        <p:spPr>
-          <a:xfrm>
-            <a:off x="822960" y="4754880"/>
-            <a:ext cx="4892040" cy="1280160"/>
-          </a:xfrm>
-          <a:prstGeom prst="rect">
-            <a:avLst/>
-          </a:prstGeom>
-          <a:noFill/>
-        </p:spPr>
-        <p:txBody>
-          <a:bodyPr wrap="square" lIns="0" rIns="0" tIns="0" bIns="0">
-            <a:spAutoFit/>
-          </a:bodyPr>
-          <a:lstStyle/>
-          <a:p>
-            <a:pPr>
-              <a:spcBef>
-                <a:spcPts val="0"/>
-              </a:spcBef>
-            </a:pPr>
-            <a:r>
-              <a:rPr sz="950" b="1">
-                <a:solidFill>
-                  <a:srgbClr val="1E40AF"/>
-                </a:solidFill>
-                <a:latin typeface="Segoe UI"/>
-              </a:rPr>
-              <a:t>• </a:t>
-            </a:r>
-            <a:r>
-              <a:rPr sz="950" b="1">
-                <a:solidFill>
-                  <a:srgbClr val="1E293B"/>
-                </a:solidFill>
-                <a:latin typeface="Segoe UI"/>
-              </a:rPr>
-              <a:t>Hero interactivo: </a:t>
-            </a:r>
-            <a:r>
-              <a:rPr sz="950">
-                <a:solidFill>
-                  <a:srgbClr val="475569"/>
-                </a:solidFill>
-                <a:latin typeface="Segoe UI"/>
-              </a:rPr>
-              <a:t>+108.400 hab. acogibles y 12,4 M€ inversión dotacional.</a:t>
-            </a:r>
-          </a:p>
-          <a:p>
-            <a:pPr>
-              <a:spcBef>
-                <a:spcPts val="300"/>
-              </a:spcBef>
-            </a:pPr>
-            <a:r>
-              <a:rPr sz="950" b="1">
-                <a:solidFill>
-                  <a:srgbClr val="1E40AF"/>
-                </a:solidFill>
-                <a:latin typeface="Segoe UI"/>
-              </a:rPr>
-              <a:t>• </a:t>
-            </a:r>
-            <a:r>
-              <a:rPr sz="950" b="1">
-                <a:solidFill>
-                  <a:srgbClr val="1E293B"/>
-                </a:solidFill>
-                <a:latin typeface="Segoe UI"/>
-              </a:rPr>
-              <a:t>Recomendador ciudadano: </a:t>
-            </a:r>
-            <a:r>
-              <a:rPr sz="950">
-                <a:solidFill>
-                  <a:srgbClr val="475569"/>
-                </a:solidFill>
-                <a:latin typeface="Segoe UI"/>
-              </a:rPr>
-              <a:t>Filtro por presupuesto y perfiles sin persistir datos.</a:t>
-            </a:r>
-          </a:p>
-          <a:p>
-            <a:pPr>
-              <a:spcBef>
-                <a:spcPts val="300"/>
-              </a:spcBef>
-            </a:pPr>
-            <a:r>
-              <a:rPr sz="950" b="1">
-                <a:solidFill>
-                  <a:srgbClr val="1E40AF"/>
-                </a:solidFill>
-                <a:latin typeface="Segoe UI"/>
-              </a:rPr>
-              <a:t>• </a:t>
-            </a:r>
-            <a:r>
-              <a:rPr sz="950" b="1">
-                <a:solidFill>
-                  <a:srgbClr val="1E293B"/>
-                </a:solidFill>
-                <a:latin typeface="Segoe UI"/>
-              </a:rPr>
-              <a:t>Mapa comarcal: </a:t>
-            </a:r>
-            <a:r>
-              <a:rPr sz="950">
-                <a:solidFill>
-                  <a:srgbClr val="475569"/>
-                </a:solidFill>
-                <a:latin typeface="Segoe UI"/>
-              </a:rPr>
-              <a:t>Semáforo dotacional y detección de cuellos de botella.</a:t>
-            </a:r>
-          </a:p>
-        </p:txBody>
-      </p:sp>
-      <p:sp>
-        <p:nvSpPr>
-          <p:cNvPr id="9" name="Rounded Rectangle 8"/>
-          <p:cNvSpPr/>
-          <p:nvPr/>
-        </p:nvSpPr>
-        <p:spPr>
-          <a:xfrm>
-            <a:off x="6263640" y="1783080"/>
-            <a:ext cx="5257800" cy="4434840"/>
-          </a:xfrm>
-          <a:prstGeom prst="roundRect">
-            <a:avLst/>
-          </a:prstGeom>
-          <a:solidFill>
-            <a:srgbClr val="FFFFFF"/>
-          </a:solidFill>
-          <a:ln w="12700">
-            <a:solidFill>
-              <a:srgbClr val="E2E8F0"/>
-            </a:solidFill>
-          </a:ln>
-        </p:spPr>
-        <p:style>
-          <a:lnRef idx="1">
-            <a:schemeClr val="accent1"/>
-          </a:lnRef>
-          <a:fillRef idx="3">
-            <a:schemeClr val="accent1"/>
-          </a:fillRef>
-          <a:effectRef idx="2">
-            <a:schemeClr val="accent1"/>
-          </a:effectRef>
-          <a:fontRef idx="minor">
-            <a:schemeClr val="lt1"/>
-          </a:fontRef>
-        </p:style>
-        <p:txBody>
-          <a:bodyPr rtlCol="0" anchor="ctr"/>
-          <a:lstStyle/>
-          <a:p>
-            <a:pPr algn="ctr"/>
-          </a:p>
-        </p:txBody>
-      </p:sp>
-      <p:sp>
-        <p:nvSpPr>
-          <p:cNvPr id="10" name="TextBox 9"/>
-          <p:cNvSpPr txBox="1"/>
-          <p:nvPr/>
-        </p:nvSpPr>
-        <p:spPr>
-          <a:xfrm>
-            <a:off x="6446520" y="1874519"/>
-            <a:ext cx="4892040" cy="594360"/>
-          </a:xfrm>
-          <a:prstGeom prst="rect">
-            <a:avLst/>
-          </a:prstGeom>
-          <a:noFill/>
-        </p:spPr>
-        <p:txBody>
-          <a:bodyPr wrap="square" lIns="0" rIns="0" tIns="0" bIns="0">
-            <a:spAutoFit/>
-          </a:bodyPr>
-          <a:lstStyle/>
-          <a:p>
-            <a:pPr>
-              <a:defRPr sz="1200" b="1">
-                <a:solidFill>
-                  <a:srgbClr val="166534"/>
-                </a:solidFill>
-                <a:latin typeface="Segoe UI"/>
-              </a:defRPr>
-            </a:pPr>
-            <a:r>
-              <a:t>PANEL CERTIFICADO  ·  DATASET AUDITADO</a:t>
-            </a:r>
-          </a:p>
-          <a:p>
-            <a:pPr>
-              <a:spcBef>
-                <a:spcPts val="200"/>
-              </a:spcBef>
-              <a:defRPr sz="900">
-                <a:solidFill>
-                  <a:srgbClr val="64748B"/>
-                </a:solidFill>
-                <a:latin typeface="Consolas"/>
-              </a:defRPr>
-            </a:pPr>
-            <a:r>
-              <a:t>data/validated/municipios_panel_validado.csv</a:t>
-            </a:r>
-          </a:p>
-        </p:txBody>
-      </p:sp>
-      <p:pic>
-        <p:nvPicPr>
-          <p:cNvPr id="11" name="Picture 10" descr="dataset_screenshot.png"/>
-          <p:cNvPicPr>
-            <a:picLocks noChangeAspect="1"/>
-          </p:cNvPicPr>
-          <p:nvPr/>
-        </p:nvPicPr>
-        <p:blipFill>
-          <a:blip r:embed="rId3"/>
-          <a:stretch>
-            <a:fillRect/>
-          </a:stretch>
-        </p:blipFill>
-        <p:spPr>
-          <a:xfrm>
-            <a:off x="6446520" y="2514600"/>
-            <a:ext cx="4892040" cy="2148840"/>
-          </a:xfrm>
-          <a:prstGeom prst="rect">
-            <a:avLst/>
-          </a:prstGeom>
-          <a:ln w="12700">
-            <a:solidFill>
-              <a:srgbClr val="CBD5E1"/>
-            </a:solidFill>
-          </a:ln>
-        </p:spPr>
-      </p:pic>
-      <p:sp>
-        <p:nvSpPr>
-          <p:cNvPr id="12" name="TextBox 11"/>
-          <p:cNvSpPr txBox="1"/>
-          <p:nvPr/>
-        </p:nvSpPr>
-        <p:spPr>
-          <a:xfrm>
-            <a:off x="6446520" y="4754880"/>
-            <a:ext cx="4892040" cy="1280160"/>
-          </a:xfrm>
-          <a:prstGeom prst="rect">
-            <a:avLst/>
-          </a:prstGeom>
-          <a:noFill/>
-        </p:spPr>
-        <p:txBody>
-          <a:bodyPr wrap="square" lIns="0" rIns="0" tIns="0" bIns="0">
-            <a:spAutoFit/>
-          </a:bodyPr>
-          <a:lstStyle/>
-          <a:p>
-            <a:pPr>
-              <a:spcBef>
-                <a:spcPts val="0"/>
-              </a:spcBef>
-            </a:pPr>
-            <a:r>
-              <a:rPr sz="950" b="1">
-                <a:solidFill>
-                  <a:srgbClr val="166534"/>
-                </a:solidFill>
-                <a:latin typeface="Segoe UI"/>
-              </a:rPr>
-              <a:t>• </a:t>
-            </a:r>
-            <a:r>
-              <a:rPr sz="950" b="1">
-                <a:solidFill>
-                  <a:srgbClr val="1E293B"/>
-                </a:solidFill>
-                <a:latin typeface="Segoe UI"/>
-              </a:rPr>
-              <a:t>Cobertura comarcal: </a:t>
-            </a:r>
-            <a:r>
-              <a:rPr sz="950">
-                <a:solidFill>
-                  <a:srgbClr val="475569"/>
-                </a:solidFill>
-                <a:latin typeface="Segoe UI"/>
-              </a:rPr>
-              <a:t>20 municipios piloto en las 8 comarcas (200.267 hab.).</a:t>
-            </a:r>
-          </a:p>
-          <a:p>
-            <a:pPr>
-              <a:spcBef>
-                <a:spcPts val="300"/>
-              </a:spcBef>
-            </a:pPr>
-            <a:r>
-              <a:rPr sz="950" b="1">
-                <a:solidFill>
-                  <a:srgbClr val="166534"/>
-                </a:solidFill>
-                <a:latin typeface="Segoe UI"/>
-              </a:rPr>
-              <a:t>• </a:t>
-            </a:r>
-            <a:r>
-              <a:rPr sz="950" b="1">
-                <a:solidFill>
-                  <a:srgbClr val="1E293B"/>
-                </a:solidFill>
-                <a:latin typeface="Segoe UI"/>
-              </a:rPr>
-              <a:t>Calidad verificada: </a:t>
-            </a:r>
-            <a:r>
-              <a:rPr sz="950">
-                <a:solidFill>
-                  <a:srgbClr val="475569"/>
-                </a:solidFill>
-                <a:latin typeface="Segoe UI"/>
-              </a:rPr>
-              <a:t>92 variables estructuradas con 0 nulos ni repetidos.</a:t>
-            </a:r>
-          </a:p>
-          <a:p>
-            <a:pPr>
-              <a:spcBef>
-                <a:spcPts val="300"/>
-              </a:spcBef>
-            </a:pPr>
-            <a:r>
-              <a:rPr sz="950" b="1">
-                <a:solidFill>
-                  <a:srgbClr val="166534"/>
-                </a:solidFill>
-                <a:latin typeface="Segoe UI"/>
-              </a:rPr>
-              <a:t>• </a:t>
-            </a:r>
-            <a:r>
-              <a:rPr sz="950" b="1">
-                <a:solidFill>
-                  <a:srgbClr val="1E293B"/>
-                </a:solidFill>
-                <a:latin typeface="Segoe UI"/>
-              </a:rPr>
-              <a:t>Garantía metodológica: </a:t>
-            </a:r>
-            <a:r>
-              <a:rPr sz="950">
-                <a:solidFill>
-                  <a:srgbClr val="475569"/>
-                </a:solidFill>
-                <a:latin typeface="Segoe UI"/>
-              </a:rPr>
-              <a:t>73 tests continuos en verde y trazabilidad oficial.</a:t>
-            </a:r>
-          </a:p>
-        </p:txBody>
-      </p:sp>
-      <p:sp>
-        <p:nvSpPr>
-          <p:cNvPr id="13" name="TextBox 12"/>
-          <p:cNvSpPr txBox="1"/>
-          <p:nvPr/>
-        </p:nvSpPr>
-        <p:spPr>
-          <a:xfrm>
-            <a:off x="10634472" y="6400800"/>
-            <a:ext cx="914400" cy="274320"/>
-          </a:xfrm>
-          <a:prstGeom prst="rect">
-            <a:avLst/>
-          </a:prstGeom>
-          <a:noFill/>
-        </p:spPr>
-        <p:txBody>
-          <a:bodyPr wrap="none">
-            <a:spAutoFit/>
-          </a:bodyPr>
-          <a:lstStyle/>
-          <a:p>
-            <a:pPr algn="r">
-              <a:defRPr sz="1000">
-                <a:solidFill>
-                  <a:srgbClr val="94A3B8"/>
-                </a:solidFill>
-                <a:latin typeface="Segoe UI"/>
-              </a:defRPr>
-            </a:pPr>
-            <a:r>
-              <a:t>7</a:t>
-            </a:r>
-          </a:p>
-        </p:txBody>
-      </p:sp>
-    </p:spTree>
-  </p:cSld>
-  <p:clrMapOvr>
-    <a:masterClrMapping/>
-  </p:clrMapOvr>
 </p:sld>
 </file>
 
@@ -15287,29 +15576,15 @@
           <a:bodyPr wrap="square" lIns="0" tIns="0" rIns="0" bIns="0" rtlCol="0" anchor="t"/>
           <a:lstStyle/>
           <a:p>
-            <a:pPr indent="0" marL="0">
-              <a:buNone/>
-            </a:pPr>
-            <a:r>
-              <a:rPr lang="en-US" sz="1400" b="1" dirty="0">
-                <a:solidFill>
-                  <a:schemeClr val="accent1"/>
-                </a:solidFill>
-              </a:rPr>
-              <a:t>Regla de honestidad: </a:t>
-            </a:r>
-            <a:pPr indent="0" marL="0">
-              <a:buNone/>
-            </a:pPr>
-            <a:r>
-              <a:rPr lang="en-US" sz="1400" dirty="0">
-                <a:solidFill>
-                  <a:schemeClr val="tx2"/>
-                </a:solidFill>
-              </a:rPr>
-              <a:t>cada variable lleva su etiqueta REAL o ESTIMADO.</a:t>
-            </a:r>
-            <a:endParaRPr lang="en-US" sz="1400" dirty="0"/>
+            <a:r>
+              <a:rPr sz="1000">
+                <a:solidFill>
+                  <a:srgbClr val="475569"/>
+                </a:solidFill>
+                <a:latin typeface="Segoe UI"/>
+              </a:rPr>
+              <a:t>Regla de honestidad: cada variable lleva su etiqueta REAL o ESTIMADO. Control de overfitting desde la ingesta.</a:t>
+            </a:r>
           </a:p>
         </p:txBody>
       </p:sp>
@@ -15762,18 +16037,15 @@
           <a:bodyPr wrap="square" lIns="0" tIns="0" rIns="0" bIns="0" rtlCol="0" anchor="t"/>
           <a:lstStyle/>
           <a:p>
-            <a:pPr indent="0" marL="0">
-              <a:buNone/>
-            </a:pPr>
-            <a:r>
-              <a:rPr lang="en-US" sz="1400" dirty="0">
-                <a:solidFill>
-                  <a:schemeClr val="tx2"/>
-                </a:solidFill>
-              </a:rPr>
-              <a:t>Todos los municipios tienen entre 1 y 49.999 habitantes, y precios, ocupaciones y cupos son positivos.</a:t>
-            </a:r>
-            <a:endParaRPr lang="en-US" sz="1400" dirty="0"/>
+            <a:r>
+              <a:rPr sz="950">
+                <a:solidFill>
+                  <a:srgbClr val="475569"/>
+                </a:solidFill>
+                <a:latin typeface="Segoe UI"/>
+              </a:rPr>
+              <a:t>Piloto: 20 municipios (92 vars) · Cobertura regional en Git: 155 municipios &lt; 50k hab. (997.059 hab., 0 nulos) y 179 CAM (pipeline_179.py).</a:t>
+            </a:r>
           </a:p>
         </p:txBody>
       </p:sp>
@@ -19505,6 +19777,656 @@
 </file>
 
 <file path=ppt/slides/slide7.xml><?xml version="1.0" encoding="utf-8"?>
+<p:sld xmlns:a="http://schemas.openxmlformats.org/drawingml/2006/main" xmlns:p="http://schemas.openxmlformats.org/presentationml/2006/main" xmlns:r="http://schemas.openxmlformats.org/officeDocument/2006/relationships">
+  <p:cSld>
+    <p:spTree>
+      <p:nvGrpSpPr>
+        <p:cNvPr id="1" name=""/>
+        <p:cNvGrpSpPr/>
+        <p:nvPr/>
+      </p:nvGrpSpPr>
+      <p:grpSpPr/>
+      <p:sp>
+        <p:nvSpPr>
+          <p:cNvPr id="2" name="Text Placeholder 1"/>
+          <p:cNvSpPr>
+            <a:spLocks noGrp="1"/>
+          </p:cNvSpPr>
+          <p:nvPr>
+            <p:ph type="body" idx="100"/>
+          </p:nvPr>
+        </p:nvSpPr>
+        <p:spPr/>
+        <p:txBody>
+          <a:bodyPr/>
+          <a:lstStyle/>
+          <a:p>
+            <a:pPr>
+              <a:defRPr sz="1050" b="1">
+                <a:solidFill>
+                  <a:srgbClr val="C8102E"/>
+                </a:solidFill>
+                <a:latin typeface="Segoe UI"/>
+              </a:defRPr>
+            </a:pPr>
+            <a:r>
+              <a:t>DEMOSTRACIÓN EN DIRECTO</a:t>
+            </a:r>
+          </a:p>
+        </p:txBody>
+      </p:sp>
+      <p:sp>
+        <p:nvSpPr>
+          <p:cNvPr id="3" name="Title 2"/>
+          <p:cNvSpPr>
+            <a:spLocks noGrp="1"/>
+          </p:cNvSpPr>
+          <p:nvPr>
+            <p:ph type="title" idx="101"/>
+          </p:nvPr>
+        </p:nvSpPr>
+        <p:spPr/>
+        <p:txBody>
+          <a:bodyPr/>
+          <a:lstStyle/>
+          <a:p>
+            <a:pPr>
+              <a:defRPr sz="2100" b="1">
+                <a:solidFill>
+                  <a:srgbClr val="1E293B"/>
+                </a:solidFill>
+                <a:latin typeface="Segoe UI"/>
+              </a:defRPr>
+            </a:pPr>
+            <a:r>
+              <a:t>Plataforma interactiva (MVP) y panel de datos</a:t>
+            </a:r>
+          </a:p>
+        </p:txBody>
+      </p:sp>
+      <p:sp>
+        <p:nvSpPr>
+          <p:cNvPr id="4" name="TextBox 3"/>
+          <p:cNvSpPr txBox="1"/>
+          <p:nvPr/>
+        </p:nvSpPr>
+        <p:spPr>
+          <a:xfrm>
+            <a:off x="640080" y="1325880"/>
+            <a:ext cx="10881360" cy="365760"/>
+          </a:xfrm>
+          <a:prstGeom prst="rect">
+            <a:avLst/>
+          </a:prstGeom>
+          <a:noFill/>
+        </p:spPr>
+        <p:txBody>
+          <a:bodyPr wrap="square">
+            <a:spAutoFit/>
+          </a:bodyPr>
+          <a:lstStyle/>
+          <a:p>
+            <a:pPr>
+              <a:defRPr sz="1100">
+                <a:solidFill>
+                  <a:srgbClr val="64748B"/>
+                </a:solidFill>
+                <a:latin typeface="Segoe UI"/>
+              </a:defRPr>
+            </a:pPr>
+            <a:r>
+              <a:t>Espacio de transición para la demostración del prototipo funcional web y la estructura del panel de datos</a:t>
+            </a:r>
+          </a:p>
+        </p:txBody>
+      </p:sp>
+      <p:sp>
+        <p:nvSpPr>
+          <p:cNvPr id="5" name="Rounded Rectangle 4"/>
+          <p:cNvSpPr/>
+          <p:nvPr/>
+        </p:nvSpPr>
+        <p:spPr>
+          <a:xfrm>
+            <a:off x="640080" y="1783080"/>
+            <a:ext cx="5257800" cy="4434840"/>
+          </a:xfrm>
+          <a:prstGeom prst="roundRect">
+            <a:avLst/>
+          </a:prstGeom>
+          <a:solidFill>
+            <a:srgbClr val="FFFFFF"/>
+          </a:solidFill>
+          <a:ln w="12700">
+            <a:solidFill>
+              <a:srgbClr val="E2E8F0"/>
+            </a:solidFill>
+          </a:ln>
+        </p:spPr>
+        <p:style>
+          <a:lnRef idx="1">
+            <a:schemeClr val="accent1"/>
+          </a:lnRef>
+          <a:fillRef idx="3">
+            <a:schemeClr val="accent1"/>
+          </a:fillRef>
+          <a:effectRef idx="2">
+            <a:schemeClr val="accent1"/>
+          </a:effectRef>
+          <a:fontRef idx="minor">
+            <a:schemeClr val="lt1"/>
+          </a:fontRef>
+        </p:style>
+        <p:txBody>
+          <a:bodyPr rtlCol="0" anchor="ctr"/>
+          <a:lstStyle/>
+          <a:p>
+            <a:pPr algn="ctr"/>
+          </a:p>
+        </p:txBody>
+      </p:sp>
+      <p:sp>
+        <p:nvSpPr>
+          <p:cNvPr id="6" name="TextBox 5"/>
+          <p:cNvSpPr txBox="1"/>
+          <p:nvPr/>
+        </p:nvSpPr>
+        <p:spPr>
+          <a:xfrm>
+            <a:off x="822960" y="1874519"/>
+            <a:ext cx="4892040" cy="594360"/>
+          </a:xfrm>
+          <a:prstGeom prst="rect">
+            <a:avLst/>
+          </a:prstGeom>
+          <a:noFill/>
+        </p:spPr>
+        <p:txBody>
+          <a:bodyPr wrap="square" lIns="0" rIns="0" tIns="0" bIns="0">
+            <a:spAutoFit/>
+          </a:bodyPr>
+          <a:lstStyle/>
+          <a:p>
+            <a:pPr>
+              <a:defRPr sz="1200" b="1">
+                <a:solidFill>
+                  <a:srgbClr val="1E40AF"/>
+                </a:solidFill>
+                <a:latin typeface="Segoe UI"/>
+              </a:defRPr>
+            </a:pPr>
+            <a:r>
+              <a:t>DEMO EN VIVO  ·  MVP WEB INTERACTIVO</a:t>
+            </a:r>
+          </a:p>
+          <a:p>
+            <a:pPr>
+              <a:spcBef>
+                <a:spcPts val="200"/>
+              </a:spcBef>
+              <a:defRPr sz="900">
+                <a:solidFill>
+                  <a:srgbClr val="64748B"/>
+                </a:solidFill>
+                <a:latin typeface="Consolas"/>
+              </a:defRPr>
+            </a:pPr>
+            <a:r>
+              <a:t>http://localhost:8088/index.html  ·  mapa/mapa.html</a:t>
+            </a:r>
+          </a:p>
+        </p:txBody>
+      </p:sp>
+      <p:pic>
+        <p:nvPicPr>
+          <p:cNvPr id="7" name="Picture 6" descr="mvp_screenshot.png"/>
+          <p:cNvPicPr>
+            <a:picLocks noChangeAspect="1"/>
+          </p:cNvPicPr>
+          <p:nvPr/>
+        </p:nvPicPr>
+        <p:blipFill>
+          <a:blip r:embed="rId2"/>
+          <a:stretch>
+            <a:fillRect/>
+          </a:stretch>
+        </p:blipFill>
+        <p:spPr>
+          <a:xfrm>
+            <a:off x="822960" y="2514600"/>
+            <a:ext cx="4892040" cy="2148840"/>
+          </a:xfrm>
+          <a:prstGeom prst="rect">
+            <a:avLst/>
+          </a:prstGeom>
+          <a:ln w="12700">
+            <a:solidFill>
+              <a:srgbClr val="CBD5E1"/>
+            </a:solidFill>
+          </a:ln>
+        </p:spPr>
+      </p:pic>
+      <p:sp>
+        <p:nvSpPr>
+          <p:cNvPr id="8" name="TextBox 7"/>
+          <p:cNvSpPr txBox="1"/>
+          <p:nvPr/>
+        </p:nvSpPr>
+        <p:spPr>
+          <a:xfrm>
+            <a:off x="822960" y="4754880"/>
+            <a:ext cx="4892040" cy="1280160"/>
+          </a:xfrm>
+          <a:prstGeom prst="rect">
+            <a:avLst/>
+          </a:prstGeom>
+          <a:noFill/>
+        </p:spPr>
+        <p:txBody>
+          <a:bodyPr wrap="square" lIns="0" rIns="0" tIns="0" bIns="0">
+            <a:spAutoFit/>
+          </a:bodyPr>
+          <a:lstStyle/>
+          <a:p>
+            <a:pPr>
+              <a:spcBef>
+                <a:spcPts val="0"/>
+              </a:spcBef>
+            </a:pPr>
+            <a:r>
+              <a:rPr sz="950" b="1">
+                <a:solidFill>
+                  <a:srgbClr val="1E40AF"/>
+                </a:solidFill>
+                <a:latin typeface="Segoe UI"/>
+              </a:rPr>
+              <a:t>• </a:t>
+            </a:r>
+            <a:r>
+              <a:rPr sz="950" b="1">
+                <a:solidFill>
+                  <a:srgbClr val="1E293B"/>
+                </a:solidFill>
+                <a:latin typeface="Segoe UI"/>
+              </a:rPr>
+              <a:t>Hero interactivo: </a:t>
+            </a:r>
+            <a:r>
+              <a:rPr sz="950">
+                <a:solidFill>
+                  <a:srgbClr val="475569"/>
+                </a:solidFill>
+                <a:latin typeface="Segoe UI"/>
+              </a:rPr>
+              <a:t>+108.400 hab. acogibles y 12,4 M€ inversión dotacional.</a:t>
+            </a:r>
+          </a:p>
+          <a:p>
+            <a:pPr>
+              <a:spcBef>
+                <a:spcPts val="300"/>
+              </a:spcBef>
+            </a:pPr>
+            <a:r>
+              <a:rPr sz="950" b="1">
+                <a:solidFill>
+                  <a:srgbClr val="1E40AF"/>
+                </a:solidFill>
+                <a:latin typeface="Segoe UI"/>
+              </a:rPr>
+              <a:t>• </a:t>
+            </a:r>
+            <a:r>
+              <a:rPr sz="950" b="1">
+                <a:solidFill>
+                  <a:srgbClr val="1E293B"/>
+                </a:solidFill>
+                <a:latin typeface="Segoe UI"/>
+              </a:rPr>
+              <a:t>Recomendador ciudadano: </a:t>
+            </a:r>
+            <a:r>
+              <a:rPr sz="950">
+                <a:solidFill>
+                  <a:srgbClr val="475569"/>
+                </a:solidFill>
+                <a:latin typeface="Segoe UI"/>
+              </a:rPr>
+              <a:t>Filtro por presupuesto y perfiles sin persistir datos.</a:t>
+            </a:r>
+          </a:p>
+          <a:p>
+            <a:pPr>
+              <a:spcBef>
+                <a:spcPts val="300"/>
+              </a:spcBef>
+            </a:pPr>
+            <a:r>
+              <a:rPr sz="950" b="1">
+                <a:solidFill>
+                  <a:srgbClr val="1E40AF"/>
+                </a:solidFill>
+                <a:latin typeface="Segoe UI"/>
+              </a:rPr>
+              <a:t>• </a:t>
+            </a:r>
+            <a:r>
+              <a:rPr sz="950" b="1">
+                <a:solidFill>
+                  <a:srgbClr val="1E293B"/>
+                </a:solidFill>
+                <a:latin typeface="Segoe UI"/>
+              </a:rPr>
+              <a:t>Mapa comarcal: </a:t>
+            </a:r>
+            <a:r>
+              <a:rPr sz="950">
+                <a:solidFill>
+                  <a:srgbClr val="475569"/>
+                </a:solidFill>
+                <a:latin typeface="Segoe UI"/>
+              </a:rPr>
+              <a:t>Semáforo dotacional y detección de cuellos de botella.</a:t>
+            </a:r>
+          </a:p>
+        </p:txBody>
+      </p:sp>
+      <p:sp>
+        <p:nvSpPr>
+          <p:cNvPr id="9" name="Rounded Rectangle 8"/>
+          <p:cNvSpPr/>
+          <p:nvPr/>
+        </p:nvSpPr>
+        <p:spPr>
+          <a:xfrm>
+            <a:off x="6263640" y="1783080"/>
+            <a:ext cx="5257800" cy="4434840"/>
+          </a:xfrm>
+          <a:prstGeom prst="roundRect">
+            <a:avLst/>
+          </a:prstGeom>
+          <a:solidFill>
+            <a:srgbClr val="FFFFFF"/>
+          </a:solidFill>
+          <a:ln w="12700">
+            <a:solidFill>
+              <a:srgbClr val="E2E8F0"/>
+            </a:solidFill>
+          </a:ln>
+        </p:spPr>
+        <p:style>
+          <a:lnRef idx="1">
+            <a:schemeClr val="accent1"/>
+          </a:lnRef>
+          <a:fillRef idx="3">
+            <a:schemeClr val="accent1"/>
+          </a:fillRef>
+          <a:effectRef idx="2">
+            <a:schemeClr val="accent1"/>
+          </a:effectRef>
+          <a:fontRef idx="minor">
+            <a:schemeClr val="lt1"/>
+          </a:fontRef>
+        </p:style>
+        <p:txBody>
+          <a:bodyPr rtlCol="0" anchor="ctr"/>
+          <a:lstStyle/>
+          <a:p>
+            <a:pPr algn="ctr"/>
+          </a:p>
+        </p:txBody>
+      </p:sp>
+      <p:sp>
+        <p:nvSpPr>
+          <p:cNvPr id="10" name="TextBox 9"/>
+          <p:cNvSpPr txBox="1"/>
+          <p:nvPr/>
+        </p:nvSpPr>
+        <p:spPr>
+          <a:xfrm>
+            <a:off x="6446520" y="1874519"/>
+            <a:ext cx="4892040" cy="594360"/>
+          </a:xfrm>
+          <a:prstGeom prst="rect">
+            <a:avLst/>
+          </a:prstGeom>
+          <a:noFill/>
+        </p:spPr>
+        <p:txBody>
+          <a:bodyPr wrap="square" lIns="0" rIns="0" tIns="0" bIns="0">
+            <a:spAutoFit/>
+          </a:bodyPr>
+          <a:lstStyle/>
+          <a:p>
+            <a:pPr>
+              <a:defRPr sz="1200" b="1">
+                <a:solidFill>
+                  <a:srgbClr val="166534"/>
+                </a:solidFill>
+                <a:latin typeface="Segoe UI"/>
+              </a:defRPr>
+            </a:pPr>
+            <a:r>
+              <a:t>PANEL CERTIFICADO  ·  DATASET AUDITADO</a:t>
+            </a:r>
+          </a:p>
+          <a:p>
+            <a:pPr>
+              <a:spcBef>
+                <a:spcPts val="200"/>
+              </a:spcBef>
+              <a:defRPr sz="850">
+                <a:solidFill>
+                  <a:srgbClr val="64748B"/>
+                </a:solidFill>
+                <a:latin typeface="Consolas"/>
+              </a:defRPr>
+            </a:pPr>
+            <a:r>
+              <a:t>data/validated/municipios_panel_validado.csv · panel_menores_50k_real.csv</a:t>
+            </a:r>
+          </a:p>
+        </p:txBody>
+      </p:sp>
+      <p:pic>
+        <p:nvPicPr>
+          <p:cNvPr id="11" name="Picture 10" descr="dataset_screenshot.png"/>
+          <p:cNvPicPr>
+            <a:picLocks noChangeAspect="1"/>
+          </p:cNvPicPr>
+          <p:nvPr/>
+        </p:nvPicPr>
+        <p:blipFill>
+          <a:blip r:embed="rId3"/>
+          <a:stretch>
+            <a:fillRect/>
+          </a:stretch>
+        </p:blipFill>
+        <p:spPr>
+          <a:xfrm>
+            <a:off x="6446520" y="2514600"/>
+            <a:ext cx="4892040" cy="2148840"/>
+          </a:xfrm>
+          <a:prstGeom prst="rect">
+            <a:avLst/>
+          </a:prstGeom>
+          <a:ln w="12700">
+            <a:solidFill>
+              <a:srgbClr val="CBD5E1"/>
+            </a:solidFill>
+          </a:ln>
+        </p:spPr>
+      </p:pic>
+      <p:sp>
+        <p:nvSpPr>
+          <p:cNvPr id="12" name="TextBox 11"/>
+          <p:cNvSpPr txBox="1"/>
+          <p:nvPr/>
+        </p:nvSpPr>
+        <p:spPr>
+          <a:xfrm>
+            <a:off x="6446520" y="4754880"/>
+            <a:ext cx="4892040" cy="1280160"/>
+          </a:xfrm>
+          <a:prstGeom prst="rect">
+            <a:avLst/>
+          </a:prstGeom>
+          <a:noFill/>
+        </p:spPr>
+        <p:txBody>
+          <a:bodyPr wrap="square" lIns="0" rIns="0" tIns="0" bIns="0">
+            <a:spAutoFit/>
+          </a:bodyPr>
+          <a:lstStyle/>
+          <a:p>
+            <a:pPr>
+              <a:spcBef>
+                <a:spcPts val="0"/>
+              </a:spcBef>
+            </a:pPr>
+            <a:r>
+              <a:rPr sz="950" b="1">
+                <a:solidFill>
+                  <a:srgbClr val="166534"/>
+                </a:solidFill>
+                <a:latin typeface="Segoe UI"/>
+              </a:rPr>
+              <a:t>• </a:t>
+            </a:r>
+            <a:r>
+              <a:rPr sz="950" b="1">
+                <a:solidFill>
+                  <a:srgbClr val="1E293B"/>
+                </a:solidFill>
+                <a:latin typeface="Segoe UI"/>
+              </a:rPr>
+              <a:t>Cobertura comarcal y regional: </a:t>
+            </a:r>
+            <a:r>
+              <a:rPr sz="950">
+                <a:solidFill>
+                  <a:srgbClr val="475569"/>
+                </a:solidFill>
+                <a:latin typeface="Segoe UI"/>
+              </a:rPr>
+              <a:t>20 municipios piloto (92 vars) + Capa real de 155 municipios &lt; 50k (997.059 hab.) con 0 nulos.</a:t>
+            </a:r>
+          </a:p>
+          <a:p>
+            <a:pPr>
+              <a:spcBef>
+                <a:spcPts val="300"/>
+              </a:spcBef>
+            </a:pPr>
+            <a:r>
+              <a:rPr sz="950" b="1">
+                <a:solidFill>
+                  <a:srgbClr val="166534"/>
+                </a:solidFill>
+                <a:latin typeface="Segoe UI"/>
+              </a:rPr>
+              <a:t>• </a:t>
+            </a:r>
+            <a:r>
+              <a:rPr sz="950" b="1">
+                <a:solidFill>
+                  <a:srgbClr val="1E293B"/>
+                </a:solidFill>
+                <a:latin typeface="Segoe UI"/>
+              </a:rPr>
+              <a:t>Ingesta oficial y 0 nulos: </a:t>
+            </a:r>
+            <a:r>
+              <a:rPr sz="950">
+                <a:solidFill>
+                  <a:srgbClr val="475569"/>
+                </a:solidFill>
+                <a:latin typeface="Segoe UI"/>
+              </a:rPr>
+              <a:t>Pipeline automatizado (pipeline_179.py) cruzando INE, Catastro y CKAN sin datos sintéticos.</a:t>
+            </a:r>
+          </a:p>
+          <a:p>
+            <a:pPr>
+              <a:spcBef>
+                <a:spcPts val="300"/>
+              </a:spcBef>
+            </a:pPr>
+            <a:r>
+              <a:rPr sz="950" b="1">
+                <a:solidFill>
+                  <a:srgbClr val="166534"/>
+                </a:solidFill>
+                <a:latin typeface="Segoe UI"/>
+              </a:rPr>
+              <a:t>• </a:t>
+            </a:r>
+            <a:r>
+              <a:rPr sz="950" b="1">
+                <a:solidFill>
+                  <a:srgbClr val="1E293B"/>
+                </a:solidFill>
+                <a:latin typeface="Segoe UI"/>
+              </a:rPr>
+              <a:t>Garantía anti-overfitting: </a:t>
+            </a:r>
+            <a:r>
+              <a:rPr sz="950">
+                <a:solidFill>
+                  <a:srgbClr val="475569"/>
+                </a:solidFill>
+                <a:latin typeface="Segoe UI"/>
+              </a:rPr>
+              <a:t>73 tests continuos en verde (fugas L1 a L7) y validación espacial GroupKFold por comarca.</a:t>
+            </a:r>
+          </a:p>
+        </p:txBody>
+      </p:sp>
+      <p:sp>
+        <p:nvSpPr>
+          <p:cNvPr id="13" name="TextBox 12"/>
+          <p:cNvSpPr txBox="1"/>
+          <p:nvPr/>
+        </p:nvSpPr>
+        <p:spPr>
+          <a:xfrm>
+            <a:off x="10634472" y="6400800"/>
+            <a:ext cx="914400" cy="274320"/>
+          </a:xfrm>
+          <a:prstGeom prst="rect">
+            <a:avLst/>
+          </a:prstGeom>
+          <a:noFill/>
+        </p:spPr>
+        <p:txBody>
+          <a:bodyPr wrap="none">
+            <a:spAutoFit/>
+          </a:bodyPr>
+          <a:lstStyle/>
+          <a:p>
+            <a:pPr algn="r">
+              <a:defRPr sz="1000">
+                <a:solidFill>
+                  <a:srgbClr val="94A3B8"/>
+                </a:solidFill>
+                <a:latin typeface="Segoe UI"/>
+              </a:defRPr>
+            </a:pPr>
+            <a:r>
+              <a:t>7</a:t>
+            </a:r>
+          </a:p>
+        </p:txBody>
+      </p:sp>
+    </p:spTree>
+  </p:cSld>
+  <p:clrMapOvr>
+    <a:masterClrMapping/>
+  </p:clrMapOvr>
+</p:sld>
+</file>
+
+<file path=ppt/slides/slide8.xml><?xml version="1.0" encoding="utf-8"?>
 <p:sld xmlns:a="http://schemas.openxmlformats.org/drawingml/2006/main" xmlns:r="http://schemas.openxmlformats.org/officeDocument/2006/relationships" xmlns:p="http://schemas.openxmlformats.org/presentationml/2006/main">
   <p:cSld name="Slide 7">
     <p:spTree>
@@ -19582,18 +20504,15 @@
           <a:bodyPr wrap="square" lIns="0" tIns="0" rIns="0" bIns="0" rtlCol="0" anchor="t"/>
           <a:lstStyle/>
           <a:p>
-            <a:pPr algn="l" indent="0" marL="0">
-              <a:buNone/>
-            </a:pPr>
-            <a:r>
-              <a:rPr lang="en-US" sz="3200" b="1" dirty="0">
-                <a:solidFill>
-                  <a:schemeClr val="tx1"/>
-                </a:solidFill>
-              </a:rPr>
-              <a:t>¿Cómo sabemos que el modelo es bueno?</a:t>
-            </a:r>
-            <a:endParaRPr lang="en-US" sz="3200" dirty="0"/>
+            <a:r>
+              <a:rPr sz="2200" b="1">
+                <a:solidFill>
+                  <a:srgbClr val="1E293B"/>
+                </a:solidFill>
+                <a:latin typeface="Segoe UI"/>
+              </a:rPr>
+              <a:t>Validación con Backtesting histórico (2015–2025)</a:t>
+            </a:r>
           </a:p>
         </p:txBody>
       </p:sp>
@@ -19618,18 +20537,15 @@
           <a:bodyPr wrap="square" lIns="0" tIns="0" rIns="0" bIns="0" rtlCol="0" anchor="t"/>
           <a:lstStyle/>
           <a:p>
-            <a:pPr indent="0" marL="0">
-              <a:buNone/>
-            </a:pPr>
-            <a:r>
-              <a:rPr lang="en-US" sz="1600" dirty="0">
-                <a:solidFill>
-                  <a:schemeClr val="tx2"/>
-                </a:solidFill>
-              </a:rPr>
-              <a:t>Proyectamos de 2020 a 2025 sin ver el dato real y lo comparamos con el padrón oficial</a:t>
-            </a:r>
-            <a:endParaRPr lang="en-US" sz="1600" dirty="0"/>
+            <a:r>
+              <a:rPr sz="1100">
+                <a:solidFill>
+                  <a:srgbClr val="64748B"/>
+                </a:solidFill>
+                <a:latin typeface="Segoe UI"/>
+              </a:rPr>
+              <a:t>Backtest temporal ciego: medimos el error proyectando 2020–2025 frente al padrón oficial del INE</a:t>
+            </a:r>
           </a:p>
         </p:txBody>
       </p:sp>
@@ -19906,18 +20822,12 @@
           <a:bodyPr wrap="square" lIns="0" tIns="0" rIns="0" bIns="0" rtlCol="0" anchor="ctr"/>
           <a:lstStyle/>
           <a:p>
-            <a:pPr indent="0" marL="0">
-              <a:buNone/>
-            </a:pPr>
-            <a:r>
-              <a:rPr lang="en-US" sz="1500" dirty="0">
-                <a:solidFill>
-                  <a:schemeClr val="tx1"/>
-                </a:solidFill>
-              </a:rPr>
-              <a:t>Proyección a 2025 sin ver el dato real</a:t>
-            </a:r>
-            <a:endParaRPr lang="en-US" sz="1500" dirty="0"/>
+            <a:r>
+              <a:rPr sz="1050">
+                <a:latin typeface="Segoe UI"/>
+              </a:rPr>
+              <a:t>Proyección a 2025 sin ver el dato real (Backtest ciego)</a:t>
+            </a:r>
           </a:p>
         </p:txBody>
       </p:sp>
@@ -20388,18 +21298,15 @@
           <a:bodyPr wrap="square" lIns="0" tIns="0" rIns="0" bIns="0" rtlCol="0" anchor="t"/>
           <a:lstStyle/>
           <a:p>
-            <a:pPr indent="0" marL="0">
-              <a:buNone/>
-            </a:pPr>
-            <a:r>
-              <a:rPr lang="en-US" sz="1400" dirty="0">
-                <a:solidFill>
-                  <a:schemeClr val="tx2"/>
-                </a:solidFill>
-              </a:rPr>
-              <a:t>La mitad de los municipios queda por debajo del 1,55%. En uno de 5.000 habitantes, el desvío típico ronda las 78 personas.</a:t>
-            </a:r>
-            <a:endParaRPr lang="en-US" sz="1400" dirty="0"/>
+            <a:r>
+              <a:rPr sz="1000">
+                <a:solidFill>
+                  <a:srgbClr val="475569"/>
+                </a:solidFill>
+                <a:latin typeface="Segoe UI"/>
+              </a:rPr>
+              <a:t>Backtest riguroso: la mitad de los municipios tiene un error inferior al 1,55% a 5 años (vs 7,02% naive). En 5.000 hab., el desvío mediano es de apenas 78 personas.</a:t>
+            </a:r>
           </a:p>
         </p:txBody>
       </p:sp>
@@ -20462,7 +21369,7 @@
 </p:sld>
 </file>
 
-<file path=ppt/slides/slide8.xml><?xml version="1.0" encoding="utf-8"?>
+<file path=ppt/slides/slide9.xml><?xml version="1.0" encoding="utf-8"?>
 <p:sld xmlns:a="http://schemas.openxmlformats.org/drawingml/2006/main" xmlns:r="http://schemas.openxmlformats.org/officeDocument/2006/relationships" xmlns:p="http://schemas.openxmlformats.org/presentationml/2006/main">
   <p:cSld name="Slide 8">
     <p:spTree>
@@ -21208,936 +22115,6 @@
                 <a:latin typeface="Segoe UI"/>
               </a:rPr>
               <a:t>9</a:t>
-            </a:r>
-          </a:p>
-        </p:txBody>
-      </p:sp>
-    </p:spTree>
-  </p:cSld>
-  <p:clrMapOvr>
-    <a:masterClrMapping/>
-  </p:clrMapOvr>
-  <p:transition spd="med">
-    <p:fade/>
-  </p:transition>
-</p:sld>
-</file>
-
-<file path=ppt/slides/slide9.xml><?xml version="1.0" encoding="utf-8"?>
-<p:sld xmlns:a="http://schemas.openxmlformats.org/drawingml/2006/main" xmlns:r="http://schemas.openxmlformats.org/officeDocument/2006/relationships" xmlns:p="http://schemas.openxmlformats.org/presentationml/2006/main">
-  <p:cSld name="Slide 9">
-    <p:spTree>
-      <p:nvGrpSpPr>
-        <p:cNvPr id="1" name=""/>
-        <p:cNvGrpSpPr/>
-        <p:nvPr/>
-      </p:nvGrpSpPr>
-      <p:grpSpPr>
-        <a:xfrm>
-          <a:off x="0" y="0"/>
-          <a:ext cx="0" cy="0"/>
-          <a:chOff x="0" y="0"/>
-          <a:chExt cx="0" cy="0"/>
-        </a:xfrm>
-      </p:grpSpPr>
-      <p:sp>
-        <p:nvSpPr>
-          <p:cNvPr id="2" name="Text 0"/>
-          <p:cNvSpPr/>
-          <p:nvPr>
-            <p:ph idx="100" type="body" hasCustomPrompt="1"/>
-          </p:nvPr>
-        </p:nvSpPr>
-        <p:spPr>
-          <a:xfrm>
-            <a:off x="640080" y="457200"/>
-            <a:ext cx="8229600" cy="274320"/>
-          </a:xfrm>
-          <a:prstGeom prst="rect">
-            <a:avLst/>
-          </a:prstGeom>
-          <a:noFill/>
-          <a:ln/>
-        </p:spPr>
-        <p:txBody>
-          <a:bodyPr wrap="square" lIns="0" tIns="0" rIns="0" bIns="0" rtlCol="0" anchor="t"/>
-          <a:lstStyle/>
-          <a:p>
-            <a:pPr algn="l" indent="0" marL="0">
-              <a:buNone/>
-            </a:pPr>
-            <a:r>
-              <a:rPr lang="en-US" sz="1200" b="1" spc="300" kern="0" dirty="0">
-                <a:solidFill>
-                  <a:schemeClr val="accent1"/>
-                </a:solidFill>
-              </a:rPr>
-              <a:t>8  ·  DIAGNÓSTICO Y CONTROL</a:t>
-            </a:r>
-            <a:endParaRPr lang="en-US" sz="1200" dirty="0"/>
-          </a:p>
-        </p:txBody>
-      </p:sp>
-      <p:sp>
-        <p:nvSpPr>
-          <p:cNvPr id="3" name="Text 0"/>
-          <p:cNvSpPr/>
-          <p:nvPr>
-            <p:ph idx="101" type="title" hasCustomPrompt="1"/>
-          </p:nvPr>
-        </p:nvSpPr>
-        <p:spPr>
-          <a:xfrm>
-            <a:off x="640080" y="777240"/>
-            <a:ext cx="10908792" cy="594360"/>
-          </a:xfrm>
-          <a:prstGeom prst="rect">
-            <a:avLst/>
-          </a:prstGeom>
-          <a:noFill/>
-          <a:ln/>
-        </p:spPr>
-        <p:txBody>
-          <a:bodyPr wrap="square" lIns="0" tIns="0" rIns="0" bIns="0" rtlCol="0" anchor="t"/>
-          <a:lstStyle/>
-          <a:p>
-            <a:pPr algn="l" indent="0" marL="0">
-              <a:buNone/>
-            </a:pPr>
-            <a:r>
-              <a:rPr lang="en-US" sz="3200" b="1" dirty="0">
-                <a:solidFill>
-                  <a:schemeClr val="tx1"/>
-                </a:solidFill>
-              </a:rPr>
-              <a:t>El semáforo ICA y la alerta no compensatoria</a:t>
-            </a:r>
-            <a:endParaRPr lang="en-US" sz="3200" dirty="0"/>
-          </a:p>
-        </p:txBody>
-      </p:sp>
-      <p:sp>
-        <p:nvSpPr>
-          <p:cNvPr id="4" name="Text 2"/>
-          <p:cNvSpPr txBox="1"/>
-          <p:nvPr/>
-        </p:nvSpPr>
-        <p:spPr>
-          <a:xfrm>
-            <a:off x="640080" y="1371600"/>
-            <a:ext cx="10908792" cy="365760"/>
-          </a:xfrm>
-          <a:prstGeom prst="rect">
-            <a:avLst/>
-          </a:prstGeom>
-          <a:noFill/>
-          <a:ln/>
-        </p:spPr>
-        <p:txBody>
-          <a:bodyPr wrap="square" lIns="0" tIns="0" rIns="0" bIns="0" rtlCol="0" anchor="t"/>
-          <a:lstStyle/>
-          <a:p>
-            <a:pPr indent="0" marL="0">
-              <a:buNone/>
-            </a:pPr>
-            <a:r>
-              <a:rPr lang="en-US" sz="1600" dirty="0">
-                <a:solidFill>
-                  <a:schemeClr val="tx2"/>
-                </a:solidFill>
-              </a:rPr>
-              <a:t>Umbrales de capacidad e interrupción automática del encaje</a:t>
-            </a:r>
-            <a:endParaRPr lang="en-US" sz="1600" dirty="0"/>
-          </a:p>
-        </p:txBody>
-      </p:sp>
-      <p:sp>
-        <p:nvSpPr>
-          <p:cNvPr id="5" name="Nivel ALTA"/>
-          <p:cNvSpPr/>
-          <p:nvPr/>
-        </p:nvSpPr>
-        <p:spPr>
-          <a:xfrm>
-            <a:off x="640080" y="1965960"/>
-            <a:ext cx="3474720" cy="2697480"/>
-          </a:xfrm>
-          <a:prstGeom prst="roundRect">
-            <a:avLst>
-              <a:gd name="adj" fmla="val 3390"/>
-            </a:avLst>
-          </a:prstGeom>
-          <a:solidFill>
-            <a:schemeClr val="bg2"/>
-          </a:solidFill>
-          <a:ln/>
-        </p:spPr>
-        <p:txBody>
-          <a:bodyPr/>
-          <a:p/>
-        </p:txBody>
-      </p:sp>
-      <p:sp>
-        <p:nvSpPr>
-          <p:cNvPr id="6" name="Luz semáforo"/>
-          <p:cNvSpPr/>
-          <p:nvPr/>
-        </p:nvSpPr>
-        <p:spPr>
-          <a:xfrm>
-            <a:off x="914400" y="2240280"/>
-            <a:ext cx="237744" cy="237744"/>
-          </a:xfrm>
-          <a:prstGeom prst="ellipse">
-            <a:avLst/>
-          </a:prstGeom>
-          <a:solidFill>
-            <a:srgbClr val="2E7D5B"/>
-          </a:solidFill>
-          <a:ln/>
-        </p:spPr>
-        <p:txBody>
-          <a:bodyPr/>
-          <a:p/>
-        </p:txBody>
-      </p:sp>
-      <p:sp>
-        <p:nvSpPr>
-          <p:cNvPr id="7" name="Text 5"/>
-          <p:cNvSpPr txBox="1"/>
-          <p:nvPr/>
-        </p:nvSpPr>
-        <p:spPr>
-          <a:xfrm>
-            <a:off x="1280160" y="2221992"/>
-            <a:ext cx="2286000" cy="274320"/>
-          </a:xfrm>
-          <a:prstGeom prst="rect">
-            <a:avLst/>
-          </a:prstGeom>
-          <a:noFill/>
-          <a:ln/>
-        </p:spPr>
-        <p:txBody>
-          <a:bodyPr wrap="square" lIns="0" tIns="0" rIns="0" bIns="0" rtlCol="0" anchor="ctr"/>
-          <a:lstStyle/>
-          <a:p>
-            <a:pPr indent="0" marL="0">
-              <a:buNone/>
-            </a:pPr>
-            <a:r>
-              <a:rPr lang="en-US" sz="1300" b="1" spc="200" kern="0" dirty="0">
-                <a:solidFill>
-                  <a:schemeClr val="tx1"/>
-                </a:solidFill>
-              </a:rPr>
-              <a:t>ALTA</a:t>
-            </a:r>
-            <a:endParaRPr lang="en-US" sz="1300" dirty="0"/>
-          </a:p>
-        </p:txBody>
-      </p:sp>
-      <p:sp>
-        <p:nvSpPr>
-          <p:cNvPr id="8" name="Text 6"/>
-          <p:cNvSpPr txBox="1"/>
-          <p:nvPr/>
-        </p:nvSpPr>
-        <p:spPr>
-          <a:xfrm>
-            <a:off x="914400" y="2606040"/>
-            <a:ext cx="2926080" cy="731520"/>
-          </a:xfrm>
-          <a:prstGeom prst="rect">
-            <a:avLst/>
-          </a:prstGeom>
-          <a:noFill/>
-          <a:ln/>
-        </p:spPr>
-        <p:txBody>
-          <a:bodyPr wrap="square" lIns="0" tIns="0" rIns="0" bIns="0" rtlCol="0" anchor="t"/>
-          <a:lstStyle/>
-          <a:p>
-            <a:pPr indent="0" marL="0">
-              <a:buNone/>
-            </a:pPr>
-            <a:r>
-              <a:rPr lang="en-US" sz="4200" b="1" dirty="0">
-                <a:solidFill>
-                  <a:schemeClr val="accent2"/>
-                </a:solidFill>
-                <a:latin typeface="+mj-lt" pitchFamily="34" charset="0"/>
-                <a:ea typeface="+mj-lt" pitchFamily="34" charset="-122"/>
-                <a:cs typeface="+mj-lt" pitchFamily="34" charset="-120"/>
-              </a:rPr>
-              <a:t>≥ 60</a:t>
-            </a:r>
-            <a:endParaRPr lang="en-US" sz="4200" dirty="0"/>
-          </a:p>
-        </p:txBody>
-      </p:sp>
-      <p:sp>
-        <p:nvSpPr>
-          <p:cNvPr id="9" name="Text 7"/>
-          <p:cNvSpPr txBox="1"/>
-          <p:nvPr/>
-        </p:nvSpPr>
-        <p:spPr>
-          <a:xfrm>
-            <a:off x="914400" y="3337560"/>
-            <a:ext cx="2926080" cy="320040"/>
-          </a:xfrm>
-          <a:prstGeom prst="rect">
-            <a:avLst/>
-          </a:prstGeom>
-          <a:noFill/>
-          <a:ln/>
-        </p:spPr>
-        <p:txBody>
-          <a:bodyPr wrap="square" lIns="0" tIns="0" rIns="0" bIns="0" rtlCol="0" anchor="t"/>
-          <a:lstStyle/>
-          <a:p>
-            <a:pPr indent="0" marL="0">
-              <a:buNone/>
-            </a:pPr>
-            <a:r>
-              <a:rPr lang="en-US" sz="1600" b="1" dirty="0">
-                <a:solidFill>
-                  <a:schemeClr val="tx1"/>
-                </a:solidFill>
-              </a:rPr>
-              <a:t>Mucho margen de acogida</a:t>
-            </a:r>
-            <a:endParaRPr lang="en-US" sz="1600" dirty="0"/>
-          </a:p>
-        </p:txBody>
-      </p:sp>
-      <p:sp>
-        <p:nvSpPr>
-          <p:cNvPr id="10" name="Text 8"/>
-          <p:cNvSpPr txBox="1"/>
-          <p:nvPr/>
-        </p:nvSpPr>
-        <p:spPr>
-          <a:xfrm>
-            <a:off x="914400" y="3703320"/>
-            <a:ext cx="2926080" cy="868680"/>
-          </a:xfrm>
-          <a:prstGeom prst="rect">
-            <a:avLst/>
-          </a:prstGeom>
-          <a:noFill/>
-          <a:ln/>
-        </p:spPr>
-        <p:txBody>
-          <a:bodyPr wrap="square" lIns="0" tIns="0" rIns="0" bIns="0" rtlCol="0" anchor="t"/>
-          <a:lstStyle/>
-          <a:p>
-            <a:pPr indent="0" marL="0">
-              <a:buNone/>
-            </a:pPr>
-            <a:r>
-              <a:rPr lang="en-US" sz="1400" dirty="0">
-                <a:solidFill>
-                  <a:schemeClr val="tx2"/>
-                </a:solidFill>
-              </a:rPr>
-              <a:t>Absorbe población de inmediato sin comprometer colegios ni consultorios. Ej.: Robledo 66,7 y Buitrago 62,5.</a:t>
-            </a:r>
-            <a:endParaRPr lang="en-US" sz="1400" dirty="0"/>
-          </a:p>
-        </p:txBody>
-      </p:sp>
-      <p:sp>
-        <p:nvSpPr>
-          <p:cNvPr id="11" name="Nivel MEDIA"/>
-          <p:cNvSpPr/>
-          <p:nvPr/>
-        </p:nvSpPr>
-        <p:spPr>
-          <a:xfrm>
-            <a:off x="4357116" y="1965960"/>
-            <a:ext cx="3474720" cy="2697480"/>
-          </a:xfrm>
-          <a:prstGeom prst="roundRect">
-            <a:avLst>
-              <a:gd name="adj" fmla="val 3390"/>
-            </a:avLst>
-          </a:prstGeom>
-          <a:solidFill>
-            <a:schemeClr val="bg2"/>
-          </a:solidFill>
-          <a:ln/>
-        </p:spPr>
-        <p:txBody>
-          <a:bodyPr/>
-          <a:p/>
-        </p:txBody>
-      </p:sp>
-      <p:sp>
-        <p:nvSpPr>
-          <p:cNvPr id="12" name="Luz semáforo"/>
-          <p:cNvSpPr/>
-          <p:nvPr/>
-        </p:nvSpPr>
-        <p:spPr>
-          <a:xfrm>
-            <a:off x="4631436" y="2240280"/>
-            <a:ext cx="237744" cy="237744"/>
-          </a:xfrm>
-          <a:prstGeom prst="ellipse">
-            <a:avLst/>
-          </a:prstGeom>
-          <a:solidFill>
-            <a:srgbClr val="C4820A"/>
-          </a:solidFill>
-          <a:ln/>
-        </p:spPr>
-        <p:txBody>
-          <a:bodyPr/>
-          <a:p/>
-        </p:txBody>
-      </p:sp>
-      <p:sp>
-        <p:nvSpPr>
-          <p:cNvPr id="13" name="Text 11"/>
-          <p:cNvSpPr txBox="1"/>
-          <p:nvPr/>
-        </p:nvSpPr>
-        <p:spPr>
-          <a:xfrm>
-            <a:off x="4997196" y="2221992"/>
-            <a:ext cx="2286000" cy="274320"/>
-          </a:xfrm>
-          <a:prstGeom prst="rect">
-            <a:avLst/>
-          </a:prstGeom>
-          <a:noFill/>
-          <a:ln/>
-        </p:spPr>
-        <p:txBody>
-          <a:bodyPr wrap="square" lIns="0" tIns="0" rIns="0" bIns="0" rtlCol="0" anchor="ctr"/>
-          <a:lstStyle/>
-          <a:p>
-            <a:pPr indent="0" marL="0">
-              <a:buNone/>
-            </a:pPr>
-            <a:r>
-              <a:rPr lang="en-US" sz="1300" b="1" spc="200" kern="0" dirty="0">
-                <a:solidFill>
-                  <a:schemeClr val="tx1"/>
-                </a:solidFill>
-              </a:rPr>
-              <a:t>MEDIA</a:t>
-            </a:r>
-            <a:endParaRPr lang="en-US" sz="1300" dirty="0"/>
-          </a:p>
-        </p:txBody>
-      </p:sp>
-      <p:sp>
-        <p:nvSpPr>
-          <p:cNvPr id="14" name="Text 12"/>
-          <p:cNvSpPr txBox="1"/>
-          <p:nvPr/>
-        </p:nvSpPr>
-        <p:spPr>
-          <a:xfrm>
-            <a:off x="4631436" y="2606040"/>
-            <a:ext cx="2926080" cy="731520"/>
-          </a:xfrm>
-          <a:prstGeom prst="rect">
-            <a:avLst/>
-          </a:prstGeom>
-          <a:noFill/>
-          <a:ln/>
-        </p:spPr>
-        <p:txBody>
-          <a:bodyPr wrap="square" lIns="0" tIns="0" rIns="0" bIns="0" rtlCol="0" anchor="t"/>
-          <a:lstStyle/>
-          <a:p>
-            <a:pPr indent="0" marL="0">
-              <a:buNone/>
-            </a:pPr>
-            <a:r>
-              <a:rPr lang="en-US" sz="4200" b="1" dirty="0">
-                <a:solidFill>
-                  <a:schemeClr val="accent3"/>
-                </a:solidFill>
-                <a:latin typeface="+mj-lt" pitchFamily="34" charset="0"/>
-                <a:ea typeface="+mj-lt" pitchFamily="34" charset="-122"/>
-                <a:cs typeface="+mj-lt" pitchFamily="34" charset="-120"/>
-              </a:rPr>
-              <a:t>40–59</a:t>
-            </a:r>
-            <a:endParaRPr lang="en-US" sz="4200" dirty="0"/>
-          </a:p>
-        </p:txBody>
-      </p:sp>
-      <p:sp>
-        <p:nvSpPr>
-          <p:cNvPr id="15" name="Text 13"/>
-          <p:cNvSpPr txBox="1"/>
-          <p:nvPr/>
-        </p:nvSpPr>
-        <p:spPr>
-          <a:xfrm>
-            <a:off x="4631436" y="3337560"/>
-            <a:ext cx="2926080" cy="320040"/>
-          </a:xfrm>
-          <a:prstGeom prst="rect">
-            <a:avLst/>
-          </a:prstGeom>
-          <a:noFill/>
-          <a:ln/>
-        </p:spPr>
-        <p:txBody>
-          <a:bodyPr wrap="square" lIns="0" tIns="0" rIns="0" bIns="0" rtlCol="0" anchor="t"/>
-          <a:lstStyle/>
-          <a:p>
-            <a:pPr indent="0" marL="0">
-              <a:buNone/>
-            </a:pPr>
-            <a:r>
-              <a:rPr lang="en-US" sz="1600" b="1" dirty="0">
-                <a:solidFill>
-                  <a:schemeClr val="tx1"/>
-                </a:solidFill>
-              </a:rPr>
-              <a:t>Margen justo, condicionado</a:t>
-            </a:r>
-            <a:endParaRPr lang="en-US" sz="1600" dirty="0"/>
-          </a:p>
-        </p:txBody>
-      </p:sp>
-      <p:sp>
-        <p:nvSpPr>
-          <p:cNvPr id="16" name="Text 14"/>
-          <p:cNvSpPr txBox="1"/>
-          <p:nvPr/>
-        </p:nvSpPr>
-        <p:spPr>
-          <a:xfrm>
-            <a:off x="4631436" y="3703320"/>
-            <a:ext cx="2926080" cy="868680"/>
-          </a:xfrm>
-          <a:prstGeom prst="rect">
-            <a:avLst/>
-          </a:prstGeom>
-          <a:noFill/>
-          <a:ln/>
-        </p:spPr>
-        <p:txBody>
-          <a:bodyPr wrap="square" lIns="0" tIns="0" rIns="0" bIns="0" rtlCol="0" anchor="t"/>
-          <a:lstStyle/>
-          <a:p>
-            <a:pPr indent="0" marL="0">
-              <a:buNone/>
-            </a:pPr>
-            <a:r>
-              <a:rPr lang="en-US" sz="1400" dirty="0">
-                <a:solidFill>
-                  <a:schemeClr val="tx2"/>
-                </a:solidFill>
-              </a:rPr>
-              <a:t>Admite nuevos vecinos si se acompaña de inversiones puntuales en refuerzo de servicios.</a:t>
-            </a:r>
-            <a:endParaRPr lang="en-US" sz="1400" dirty="0"/>
-          </a:p>
-        </p:txBody>
-      </p:sp>
-      <p:sp>
-        <p:nvSpPr>
-          <p:cNvPr id="17" name="Nivel BAJA"/>
-          <p:cNvSpPr/>
-          <p:nvPr/>
-        </p:nvSpPr>
-        <p:spPr>
-          <a:xfrm>
-            <a:off x="8074152" y="1965960"/>
-            <a:ext cx="3474720" cy="2697480"/>
-          </a:xfrm>
-          <a:prstGeom prst="roundRect">
-            <a:avLst>
-              <a:gd name="adj" fmla="val 3390"/>
-            </a:avLst>
-          </a:prstGeom>
-          <a:solidFill>
-            <a:schemeClr val="bg2"/>
-          </a:solidFill>
-          <a:ln/>
-        </p:spPr>
-        <p:txBody>
-          <a:bodyPr/>
-          <a:p/>
-        </p:txBody>
-      </p:sp>
-      <p:sp>
-        <p:nvSpPr>
-          <p:cNvPr id="18" name="Luz semáforo"/>
-          <p:cNvSpPr/>
-          <p:nvPr/>
-        </p:nvSpPr>
-        <p:spPr>
-          <a:xfrm>
-            <a:off x="8348472" y="2240280"/>
-            <a:ext cx="237744" cy="237744"/>
-          </a:xfrm>
-          <a:prstGeom prst="ellipse">
-            <a:avLst/>
-          </a:prstGeom>
-          <a:solidFill>
-            <a:srgbClr val="C0263F"/>
-          </a:solidFill>
-          <a:ln/>
-        </p:spPr>
-        <p:txBody>
-          <a:bodyPr/>
-          <a:p/>
-        </p:txBody>
-      </p:sp>
-      <p:sp>
-        <p:nvSpPr>
-          <p:cNvPr id="19" name="Text 17"/>
-          <p:cNvSpPr txBox="1"/>
-          <p:nvPr/>
-        </p:nvSpPr>
-        <p:spPr>
-          <a:xfrm>
-            <a:off x="8714232" y="2221992"/>
-            <a:ext cx="2286000" cy="274320"/>
-          </a:xfrm>
-          <a:prstGeom prst="rect">
-            <a:avLst/>
-          </a:prstGeom>
-          <a:noFill/>
-          <a:ln/>
-        </p:spPr>
-        <p:txBody>
-          <a:bodyPr wrap="square" lIns="0" tIns="0" rIns="0" bIns="0" rtlCol="0" anchor="ctr"/>
-          <a:lstStyle/>
-          <a:p>
-            <a:pPr indent="0" marL="0">
-              <a:buNone/>
-            </a:pPr>
-            <a:r>
-              <a:rPr lang="en-US" sz="1300" b="1" spc="200" kern="0" dirty="0">
-                <a:solidFill>
-                  <a:schemeClr val="tx1"/>
-                </a:solidFill>
-              </a:rPr>
-              <a:t>BAJA</a:t>
-            </a:r>
-            <a:endParaRPr lang="en-US" sz="1300" dirty="0"/>
-          </a:p>
-        </p:txBody>
-      </p:sp>
-      <p:sp>
-        <p:nvSpPr>
-          <p:cNvPr id="20" name="Text 18"/>
-          <p:cNvSpPr txBox="1"/>
-          <p:nvPr/>
-        </p:nvSpPr>
-        <p:spPr>
-          <a:xfrm>
-            <a:off x="8348472" y="2606040"/>
-            <a:ext cx="2926080" cy="731520"/>
-          </a:xfrm>
-          <a:prstGeom prst="rect">
-            <a:avLst/>
-          </a:prstGeom>
-          <a:noFill/>
-          <a:ln/>
-        </p:spPr>
-        <p:txBody>
-          <a:bodyPr wrap="square" lIns="0" tIns="0" rIns="0" bIns="0" rtlCol="0" anchor="t"/>
-          <a:lstStyle/>
-          <a:p>
-            <a:pPr indent="0" marL="0">
-              <a:buNone/>
-            </a:pPr>
-            <a:r>
-              <a:rPr lang="en-US" sz="4200" b="1" dirty="0">
-                <a:solidFill>
-                  <a:schemeClr val="accent1"/>
-                </a:solidFill>
-                <a:latin typeface="+mj-lt" pitchFamily="34" charset="0"/>
-                <a:ea typeface="+mj-lt" pitchFamily="34" charset="-122"/>
-                <a:cs typeface="+mj-lt" pitchFamily="34" charset="-120"/>
-              </a:rPr>
-              <a:t>&lt; 40</a:t>
-            </a:r>
-            <a:endParaRPr lang="en-US" sz="4200" dirty="0"/>
-          </a:p>
-        </p:txBody>
-      </p:sp>
-      <p:sp>
-        <p:nvSpPr>
-          <p:cNvPr id="21" name="Text 19"/>
-          <p:cNvSpPr txBox="1"/>
-          <p:nvPr/>
-        </p:nvSpPr>
-        <p:spPr>
-          <a:xfrm>
-            <a:off x="8348472" y="3337560"/>
-            <a:ext cx="2926080" cy="320040"/>
-          </a:xfrm>
-          <a:prstGeom prst="rect">
-            <a:avLst/>
-          </a:prstGeom>
-          <a:noFill/>
-          <a:ln/>
-        </p:spPr>
-        <p:txBody>
-          <a:bodyPr wrap="square" lIns="0" tIns="0" rIns="0" bIns="0" rtlCol="0" anchor="t"/>
-          <a:lstStyle/>
-          <a:p>
-            <a:pPr indent="0" marL="0">
-              <a:buNone/>
-            </a:pPr>
-            <a:r>
-              <a:rPr lang="en-US" sz="1600" b="1" dirty="0">
-                <a:solidFill>
-                  <a:schemeClr val="tx1"/>
-                </a:solidFill>
-              </a:rPr>
-              <a:t>Sin margen: saturación</a:t>
-            </a:r>
-            <a:endParaRPr lang="en-US" sz="1600" dirty="0"/>
-          </a:p>
-        </p:txBody>
-      </p:sp>
-      <p:sp>
-        <p:nvSpPr>
-          <p:cNvPr id="22" name="Text 20"/>
-          <p:cNvSpPr txBox="1"/>
-          <p:nvPr/>
-        </p:nvSpPr>
-        <p:spPr>
-          <a:xfrm>
-            <a:off x="8348472" y="3703320"/>
-            <a:ext cx="2926080" cy="868680"/>
-          </a:xfrm>
-          <a:prstGeom prst="rect">
-            <a:avLst/>
-          </a:prstGeom>
-          <a:noFill/>
-          <a:ln/>
-        </p:spPr>
-        <p:txBody>
-          <a:bodyPr wrap="square" lIns="0" tIns="0" rIns="0" bIns="0" rtlCol="0" anchor="t"/>
-          <a:lstStyle/>
-          <a:p>
-            <a:pPr indent="0" marL="0">
-              <a:buNone/>
-            </a:pPr>
-            <a:r>
-              <a:rPr lang="en-US" sz="1400" dirty="0">
-                <a:solidFill>
-                  <a:schemeClr val="tx2"/>
-                </a:solidFill>
-              </a:rPr>
-              <a:t>Servicios esenciales en situación crítica: más vecinos provocan el colapso dotacional.</a:t>
-            </a:r>
-            <a:endParaRPr lang="en-US" sz="1400" dirty="0"/>
-          </a:p>
-        </p:txBody>
-      </p:sp>
-      <p:sp>
-        <p:nvSpPr>
-          <p:cNvPr id="23" name="Alerta S"/>
-          <p:cNvSpPr/>
-          <p:nvPr/>
-        </p:nvSpPr>
-        <p:spPr>
-          <a:xfrm>
-            <a:off x="640080" y="4846320"/>
-            <a:ext cx="10908792" cy="1325880"/>
-          </a:xfrm>
-          <a:prstGeom prst="roundRect">
-            <a:avLst>
-              <a:gd name="adj" fmla="val 6897"/>
-            </a:avLst>
-          </a:prstGeom>
-          <a:solidFill>
-            <a:schemeClr val="tx1"/>
-          </a:solidFill>
-          <a:ln/>
-        </p:spPr>
-        <p:txBody>
-          <a:bodyPr/>
-          <a:p/>
-        </p:txBody>
-      </p:sp>
-      <p:sp>
-        <p:nvSpPr>
-          <p:cNvPr id="24" name="Text 22"/>
-          <p:cNvSpPr txBox="1"/>
-          <p:nvPr/>
-        </p:nvSpPr>
-        <p:spPr>
-          <a:xfrm>
-            <a:off x="914400" y="4983480"/>
-            <a:ext cx="6400800" cy="256032"/>
-          </a:xfrm>
-          <a:prstGeom prst="rect">
-            <a:avLst/>
-          </a:prstGeom>
-          <a:noFill/>
-          <a:ln/>
-        </p:spPr>
-        <p:txBody>
-          <a:bodyPr wrap="square" lIns="0" tIns="0" rIns="0" bIns="0" rtlCol="0" anchor="t"/>
-          <a:lstStyle/>
-          <a:p>
-            <a:pPr indent="0" marL="0">
-              <a:buNone/>
-            </a:pPr>
-            <a:r>
-              <a:rPr lang="en-US" sz="1200" b="1" spc="200" kern="0" dirty="0">
-                <a:solidFill>
-                  <a:schemeClr val="accent6"/>
-                </a:solidFill>
-              </a:rPr>
-              <a:t>ALERTA S  ·  NO COMPENSATORIA</a:t>
-            </a:r>
-            <a:endParaRPr lang="en-US" sz="1200" dirty="0"/>
-          </a:p>
-        </p:txBody>
-      </p:sp>
-      <p:sp>
-        <p:nvSpPr>
-          <p:cNvPr id="25" name="Text 23"/>
-          <p:cNvSpPr txBox="1"/>
-          <p:nvPr/>
-        </p:nvSpPr>
-        <p:spPr>
-          <a:xfrm>
-            <a:off x="914400" y="5285232"/>
-            <a:ext cx="6949440" cy="822960"/>
-          </a:xfrm>
-          <a:prstGeom prst="rect">
-            <a:avLst/>
-          </a:prstGeom>
-          <a:noFill/>
-          <a:ln/>
-        </p:spPr>
-        <p:txBody>
-          <a:bodyPr wrap="square" lIns="0" tIns="0" rIns="0" bIns="0" rtlCol="0" anchor="t"/>
-          <a:lstStyle/>
-          <a:p>
-            <a:pPr indent="0" marL="0">
-              <a:buNone/>
-            </a:pPr>
-            <a:r>
-              <a:rPr lang="en-US" sz="1400" dirty="0">
-                <a:solidFill>
-                  <a:schemeClr val="bg1"/>
-                </a:solidFill>
-              </a:rPr>
-              <a:t>Se activa con más de 1.500 hab/médico o una ocupación escolar superior al 95%. El ICA total se trunca por debajo de 40 y el encaje máximo para cualquier ciudadano queda en 39, aunque la vivienda sea barata o sobren zonas verdes.</a:t>
-            </a:r>
-            <a:endParaRPr lang="en-US" sz="1400" dirty="0"/>
-          </a:p>
-        </p:txBody>
-      </p:sp>
-      <p:sp>
-        <p:nvSpPr>
-          <p:cNvPr id="26" name="Text 24"/>
-          <p:cNvSpPr txBox="1"/>
-          <p:nvPr/>
-        </p:nvSpPr>
-        <p:spPr>
-          <a:xfrm>
-            <a:off x="8229600" y="5029200"/>
-            <a:ext cx="3108960" cy="1051560"/>
-          </a:xfrm>
-          <a:prstGeom prst="rect">
-            <a:avLst/>
-          </a:prstGeom>
-          <a:noFill/>
-          <a:ln/>
-        </p:spPr>
-        <p:txBody>
-          <a:bodyPr wrap="square" lIns="0" tIns="0" rIns="0" bIns="0" rtlCol="0" anchor="t"/>
-          <a:lstStyle/>
-          <a:p>
-            <a:pPr indent="0" marL="0">
-              <a:buNone/>
-            </a:pPr>
-            <a:r>
-              <a:rPr lang="en-US" sz="1800" b="1" dirty="0">
-                <a:solidFill>
-                  <a:schemeClr val="bg1"/>
-                </a:solidFill>
-                <a:latin typeface="+mj-lt" pitchFamily="34" charset="0"/>
-                <a:ea typeface="+mj-lt" pitchFamily="34" charset="-122"/>
-                <a:cs typeface="+mj-lt" pitchFamily="34" charset="-120"/>
-              </a:rPr>
-              <a:t>Cercedilla</a:t>
-            </a:r>
-            <a:endParaRPr lang="en-US" sz="1800" dirty="0"/>
-          </a:p>
-          <a:p>
-            <a:pPr indent="0" marL="0">
-              <a:buNone/>
-            </a:pPr>
-            <a:r>
-              <a:rPr lang="en-US" sz="1400" dirty="0">
-                <a:solidFill>
-                  <a:schemeClr val="bg2"/>
-                </a:solidFill>
-              </a:rPr>
-              <a:t>Puntuación teórica de 34,61, clasificada con alerta S: la red asistencial no admite más presión.</a:t>
-            </a:r>
-            <a:endParaRPr lang="en-US" sz="1800" dirty="0"/>
-          </a:p>
-        </p:txBody>
-      </p:sp>
-      <p:sp>
-        <p:nvSpPr>
-          <p:cNvPr id="25" name="Slide Number Placeholder 0"/>
-          <p:cNvSpPr>
-            <a:spLocks noGrp="1"/>
-          </p:cNvSpPr>
-          <p:nvPr>
-            <p:ph type="sldNum" sz="quarter" idx="4294967295"/>
-          </p:nvPr>
-        </p:nvSpPr>
-        <p:spPr>
-          <a:xfrm>
-            <a:off x="10634472" y="6400800"/>
-            <a:ext cx="914400" cy="274320"/>
-          </a:xfrm>
-          <a:prstGeom prst="rect">
-            <a:avLst/>
-          </a:prstGeom>
-          <a:extLst>
-            <a:ext uri="{C572A759-6A51-4108-AA02-DFA0A04FC94B}">
-              <ma14:wrappingTextBoxFlag xmlns:ma14="http://schemas.microsoft.com/office/mac/drawingml/2011/main" val="0"/>
-            </a:ext>
-          </a:extLst>
-        </p:spPr>
-        <p:txBody>
-          <a:bodyPr lIns="0" tIns="0" rIns="0" bIns="0"/>
-          <a:lstStyle>
-            <a:lvl1pPr>
-              <a:defRPr sz="1000">
-                <a:solidFill>
-                  <a:schemeClr val="tx2"/>
-                </a:solidFill>
-              </a:defRPr>
-            </a:lvl1pPr>
-          </a:lstStyle>
-          <a:p>
-            <a:r>
-              <a:rPr sz="1000">
-                <a:solidFill>
-                  <a:srgbClr val="94A3B8"/>
-                </a:solidFill>
-                <a:latin typeface="Segoe UI"/>
-              </a:rPr>
-              <a:t>10</a:t>
             </a:r>
           </a:p>
         </p:txBody>

</xml_diff>

<commit_message>
docs(presentacion): integra despliegue Oracle 23ai Cloud, conector MCP y capa 155/179 municipios
</commit_message>
<xml_diff>
--- a/presentacion_datathon_oficial.pptx
+++ b/presentacion_datathon_oficial.pptx
@@ -9882,7 +9882,7 @@
               </a:defRPr>
             </a:pPr>
             <a:r>
-              <a:t>Cobertura regional en Git (¡Ya implementada!)</a:t>
+              <a:t>Oracle Cloud 23ai y Agente IA con MCP (¡Desplegado!)</a:t>
             </a:r>
           </a:p>
           <a:p>
@@ -9898,7 +9898,7 @@
               </a:defRPr>
             </a:pPr>
             <a:r>
-              <a:t>Capa real de 155 municipios &lt; 50k hab. (997.059 hab., 0 nulos) y 179 municipios de la CAM ya ingestada con datos 100% oficiales (pipeline_179.py) y lista para Oracle 23ai.</a:t>
+              <a:t>Desplegado en Oracle Autonomous Database 23ai (Región Madrid eu-madrid-1, mTLS) con APEX y conector estándar MCP (apex-mcp) para interacción con agentes de IA. Capa real de 155 municipios (&lt; 50k hab., 997.059 personas) con 0 nulos.</a:t>
             </a:r>
           </a:p>
         </p:txBody>
@@ -10397,9 +10397,9 @@
           <a:lstStyle/>
           <a:p>
             <a:pPr>
-              <a:defRPr sz="1100" b="1">
-                <a:solidFill>
-                  <a:srgbClr val="1E293B"/>
+              <a:defRPr sz="1300" b="1">
+                <a:solidFill>
+                  <a:srgbClr val="C8102E"/>
                 </a:solidFill>
                 <a:latin typeface="Segoe UI"/>
               </a:defRPr>
@@ -10440,6 +10440,12 @@
               </a:defRPr>
             </a:pPr>
             <a:r>
+              <a:rPr sz="1000">
+                <a:solidFill>
+                  <a:srgbClr val="475569"/>
+                </a:solidFill>
+                <a:latin typeface="Segoe UI"/>
+              </a:rPr>
               <a:t>Con 20 municipios, el deep learning causaría un severo overfitting. Empleamos modelos regularizados, validación GroupKFold por comarca y árboles exportados a ONNX con tolerancia &lt; 1e-6.</a:t>
             </a:r>
           </a:p>
@@ -10492,21 +10498,17 @@
           <a:bodyPr wrap="square" lIns="0" tIns="0" rIns="0" bIns="0" rtlCol="0" anchor="t"/>
           <a:lstStyle/>
           <a:p>
-            <a:pPr indent="0" marL="0">
-              <a:buNone/>
-            </a:pPr>
-            <a:r>
-              <a:rPr lang="en-US" sz="1800" b="1" dirty="0">
-                <a:solidFill>
-                  <a:schemeClr val="accent1"/>
-                </a:solidFill>
-                <a:latin typeface="+mj-lt" pitchFamily="34" charset="0"/>
-                <a:ea typeface="+mj-lt" pitchFamily="34" charset="-122"/>
-                <a:cs typeface="+mj-lt" pitchFamily="34" charset="-120"/>
-              </a:rPr>
-              <a:t>¿Qué no habéis validado?</a:t>
-            </a:r>
-            <a:endParaRPr lang="en-US" sz="1800" dirty="0"/>
+            <a:pPr>
+              <a:defRPr sz="1300" b="1">
+                <a:solidFill>
+                  <a:srgbClr val="C8102E"/>
+                </a:solidFill>
+                <a:latin typeface="Segoe UI"/>
+              </a:defRPr>
+            </a:pPr>
+            <a:r>
+              <a:t>¿Cómo se conecta con Oracle y qué agentes soporta?</a:t>
+            </a:r>
           </a:p>
         </p:txBody>
       </p:sp>
@@ -10531,18 +10533,23 @@
           <a:bodyPr wrap="square" lIns="0" tIns="0" rIns="0" bIns="0" rtlCol="0" anchor="t"/>
           <a:lstStyle/>
           <a:p>
-            <a:pPr indent="0" marL="0">
-              <a:buNone/>
-            </a:pPr>
-            <a:r>
-              <a:rPr lang="en-US" sz="1500" dirty="0">
-                <a:solidFill>
-                  <a:schemeClr val="tx2"/>
-                </a:solidFill>
-              </a:rPr>
-              <a:t>Que el índice anticipe por sí solo el crecimiento espontáneo (ρ = 0,10). No lo afirmamos: mide capacidad dotacional objetiva.</a:t>
-            </a:r>
-            <a:endParaRPr lang="en-US" sz="1500" dirty="0"/>
+            <a:pPr>
+              <a:defRPr sz="950">
+                <a:solidFill>
+                  <a:srgbClr val="475569"/>
+                </a:solidFill>
+                <a:latin typeface="Segoe UI"/>
+              </a:defRPr>
+            </a:pPr>
+            <a:r>
+              <a:rPr sz="1000">
+                <a:solidFill>
+                  <a:srgbClr val="475569"/>
+                </a:solidFill>
+                <a:latin typeface="Segoe UI"/>
+              </a:rPr>
+              <a:t>Conexión mTLS con Oracle Wallet a la región Madrid (eu-madrid-1), esquema WKSP_DATATHON y servidor estándar MCP (apex-mcp) para que agentes inteligentes ejecuten consultas y rankings en tiempo real.</a:t>
+            </a:r>
           </a:p>
         </p:txBody>
       </p:sp>
@@ -16258,18 +16265,15 @@
           <a:bodyPr wrap="square" lIns="0" tIns="0" rIns="0" bIns="0" rtlCol="0" anchor="t"/>
           <a:lstStyle/>
           <a:p>
-            <a:pPr indent="0" marL="0">
-              <a:buNone/>
-            </a:pPr>
-            <a:r>
-              <a:rPr lang="en-US" sz="1600" dirty="0">
-                <a:solidFill>
-                  <a:schemeClr val="tx2"/>
-                </a:solidFill>
-              </a:rPr>
-              <a:t>Python y Oracle como caminos paralelos, con garantía de privacidad (RGPD)</a:t>
-            </a:r>
-            <a:endParaRPr lang="en-US" sz="1600" dirty="0"/>
+            <a:r>
+              <a:rPr sz="1100">
+                <a:solidFill>
+                  <a:srgbClr val="64748B"/>
+                </a:solidFill>
+                <a:latin typeface="Segoe UI"/>
+              </a:rPr>
+              <a:t>Python y Oracle 23ai Cloud como caminos paralelos, con garantía de privacidad (RGPD)</a:t>
+            </a:r>
           </a:p>
         </p:txBody>
       </p:sp>
@@ -16330,6 +16334,10 @@
           </a:solidFill>
           <a:ln/>
         </p:spPr>
+        <p:txBody>
+          <a:bodyPr/>
+          <a:p/>
+        </p:txBody>
       </p:sp>
       <p:sp>
         <p:nvSpPr>
@@ -16350,6 +16358,10 @@
           </a:solidFill>
           <a:ln/>
         </p:spPr>
+        <p:txBody>
+          <a:bodyPr/>
+          <a:p/>
+        </p:txBody>
       </p:sp>
       <p:pic>
         <p:nvPicPr>
@@ -16446,6 +16458,10 @@
           </a:solidFill>
           <a:ln/>
         </p:spPr>
+        <p:txBody>
+          <a:bodyPr/>
+          <a:p/>
+        </p:txBody>
       </p:sp>
       <p:sp>
         <p:nvSpPr>
@@ -16466,6 +16482,10 @@
           </a:solidFill>
           <a:ln/>
         </p:spPr>
+        <p:txBody>
+          <a:bodyPr/>
+          <a:p/>
+        </p:txBody>
       </p:sp>
       <p:pic>
         <p:nvPicPr>
@@ -16562,6 +16582,10 @@
           </a:solidFill>
           <a:ln/>
         </p:spPr>
+        <p:txBody>
+          <a:bodyPr/>
+          <a:p/>
+        </p:txBody>
       </p:sp>
       <p:sp>
         <p:nvSpPr>
@@ -16582,6 +16606,10 @@
           </a:solidFill>
           <a:ln/>
         </p:spPr>
+        <p:txBody>
+          <a:bodyPr/>
+          <a:p/>
+        </p:txBody>
       </p:sp>
       <p:pic>
         <p:nvPicPr>
@@ -16678,6 +16706,10 @@
           </a:solidFill>
           <a:ln/>
         </p:spPr>
+        <p:txBody>
+          <a:bodyPr/>
+          <a:p/>
+        </p:txBody>
       </p:sp>
       <p:sp>
         <p:nvSpPr>
@@ -16698,6 +16730,10 @@
           </a:solidFill>
           <a:ln/>
         </p:spPr>
+        <p:txBody>
+          <a:bodyPr/>
+          <a:p/>
+        </p:txBody>
       </p:sp>
       <p:pic>
         <p:nvPicPr>
@@ -16794,6 +16830,10 @@
           </a:solidFill>
           <a:ln/>
         </p:spPr>
+        <p:txBody>
+          <a:bodyPr/>
+          <a:p/>
+        </p:txBody>
       </p:sp>
       <p:sp>
         <p:nvSpPr>
@@ -16814,6 +16854,10 @@
           </a:solidFill>
           <a:ln/>
         </p:spPr>
+        <p:txBody>
+          <a:bodyPr/>
+          <a:p/>
+        </p:txBody>
       </p:sp>
       <p:pic>
         <p:nvPicPr>
@@ -16910,6 +16954,10 @@
           </a:solidFill>
           <a:ln/>
         </p:spPr>
+        <p:txBody>
+          <a:bodyPr/>
+          <a:p/>
+        </p:txBody>
       </p:sp>
       <p:sp>
         <p:nvSpPr>
@@ -16930,6 +16978,10 @@
           </a:solidFill>
           <a:ln/>
         </p:spPr>
+        <p:txBody>
+          <a:bodyPr/>
+          <a:p/>
+        </p:txBody>
       </p:sp>
       <p:pic>
         <p:nvPicPr>
@@ -17098,6 +17150,10 @@
           </a:solidFill>
           <a:ln/>
         </p:spPr>
+        <p:txBody>
+          <a:bodyPr/>
+          <a:p/>
+        </p:txBody>
       </p:sp>
       <p:sp>
         <p:nvSpPr>
@@ -17209,6 +17265,10 @@
           </a:solidFill>
           <a:ln/>
         </p:spPr>
+        <p:txBody>
+          <a:bodyPr/>
+          <a:p/>
+        </p:txBody>
       </p:sp>
       <p:sp>
         <p:nvSpPr>
@@ -17233,30 +17293,33 @@
           <a:p>
             <a:pPr indent="0" marL="0">
               <a:buNone/>
-            </a:pPr>
-            <a:r>
-              <a:rPr lang="en-US" sz="1600" b="1" dirty="0">
-                <a:solidFill>
-                  <a:schemeClr val="tx1"/>
-                </a:solidFill>
-              </a:rPr>
-              <a:t>Oracle APEX</a:t>
+              <a:defRPr sz="1200" b="1">
+                <a:solidFill>
+                  <a:srgbClr val="1E293B"/>
+                </a:solidFill>
+                <a:latin typeface="Segoe UI"/>
+              </a:defRPr>
+            </a:pPr>
+            <a:r>
+              <a:t>Oracle APEX 23ai</a:t>
             </a:r>
             <a:endParaRPr lang="en-US" sz="1600" dirty="0"/>
           </a:p>
           <a:p>
-            <a:pPr indent="0" marL="0">
-              <a:buNone/>
-            </a:pPr>
-            <a:r>
-              <a:rPr lang="en-US" sz="1400" dirty="0">
-                <a:solidFill>
-                  <a:schemeClr val="tx2"/>
-                </a:solidFill>
-              </a:rPr>
-              <a:t>Autónomo, sin llamar a Python</a:t>
-            </a:r>
-            <a:endParaRPr lang="en-US" sz="1600" dirty="0"/>
+            <a:pPr>
+              <a:spcBef>
+                <a:spcPts val="200"/>
+              </a:spcBef>
+              <a:defRPr sz="900">
+                <a:solidFill>
+                  <a:srgbClr val="475569"/>
+                </a:solidFill>
+                <a:latin typeface="Segoe UI"/>
+              </a:defRPr>
+            </a:pPr>
+            <a:r>
+              <a:t>Autonomous DB (Madrid eu-madrid-1) · WKSP_DATATHON</a:t>
+            </a:r>
           </a:p>
         </p:txBody>
       </p:sp>
@@ -17317,6 +17380,10 @@
           </a:solidFill>
           <a:ln/>
         </p:spPr>
+        <p:txBody>
+          <a:bodyPr/>
+          <a:p/>
+        </p:txBody>
       </p:sp>
       <p:sp>
         <p:nvSpPr>
@@ -17337,6 +17404,10 @@
           </a:solidFill>
           <a:ln/>
         </p:spPr>
+        <p:txBody>
+          <a:bodyPr/>
+          <a:p/>
+        </p:txBody>
       </p:sp>
       <p:pic>
         <p:nvPicPr>
@@ -17419,18 +17490,15 @@
           <a:bodyPr wrap="square" lIns="0" tIns="0" rIns="0" bIns="0" rtlCol="0" anchor="t"/>
           <a:lstStyle/>
           <a:p>
-            <a:pPr indent="0" marL="0">
-              <a:buNone/>
-            </a:pPr>
-            <a:r>
-              <a:rPr lang="en-US" sz="1400" dirty="0">
-                <a:solidFill>
-                  <a:schemeClr val="bg2"/>
-                </a:solidFill>
-              </a:rPr>
-              <a:t>Oracle no guarda ningún dato personal, solo reglas de ponderación (cada hijo suma 0,05 a educación). Los datos del ciudadano son parámetros de sesión y nunca se escriben en disco.</a:t>
-            </a:r>
-            <a:endParaRPr lang="en-US" sz="1400" dirty="0"/>
+            <a:r>
+              <a:rPr sz="950">
+                <a:solidFill>
+                  <a:srgbClr val="CBD5E1"/>
+                </a:solidFill>
+                <a:latin typeface="Segoe UI"/>
+              </a:rPr>
+              <a:t>Oracle no guarda ningún dato personal: solo reglas en WKSP_DATATHON (cada hijo suma 0,05 a educación). Los datos del ciudadano son parámetros volátiles de sesión y nunca se escriben en disco (RGPD).</a:t>
+            </a:r>
           </a:p>
         </p:txBody>
       </p:sp>
@@ -19964,7 +20032,7 @@
               <a:spcBef>
                 <a:spcPts val="200"/>
               </a:spcBef>
-              <a:defRPr sz="900">
+              <a:defRPr sz="850">
                 <a:solidFill>
                   <a:srgbClr val="64748B"/>
                 </a:solidFill>
@@ -19972,7 +20040,7 @@
               </a:defRPr>
             </a:pPr>
             <a:r>
-              <a:t>http://localhost:8088/index.html  ·  mapa/mapa.html</a:t>
+              <a:t>http://localhost:8088/index.html · Backend Oracle 23ai (eu-madrid-1)</a:t>
             </a:r>
           </a:p>
         </p:txBody>
@@ -20223,7 +20291,7 @@
               </a:defRPr>
             </a:pPr>
             <a:r>
-              <a:t>data/validated/municipios_panel_validado.csv · panel_menores_50k_real.csv</a:t>
+              <a:t>municipios_panel_validado.csv · Esquema Oracle WKSP_DATATHON</a:t>
             </a:r>
           </a:p>
         </p:txBody>
@@ -20300,7 +20368,7 @@
                 </a:solidFill>
                 <a:latin typeface="Segoe UI"/>
               </a:rPr>
-              <a:t>Cobertura comarcal y regional: </a:t>
+              <a:t>Cobertura regional oficial: </a:t>
             </a:r>
             <a:r>
               <a:rPr sz="950">
@@ -20309,7 +20377,7 @@
                 </a:solidFill>
                 <a:latin typeface="Segoe UI"/>
               </a:rPr>
-              <a:t>20 municipios piloto (92 vars) + Capa real de 155 municipios &lt; 50k (997.059 hab.) con 0 nulos.</a:t>
+              <a:t>20 piloto (92 vars) + 155 municipios &lt; 50k (997.059 hab.) con 0 nulos.</a:t>
             </a:r>
           </a:p>
           <a:p>
@@ -20334,7 +20402,7 @@
                 </a:solidFill>
                 <a:latin typeface="Segoe UI"/>
               </a:rPr>
-              <a:t>Ingesta oficial y 0 nulos: </a:t>
+              <a:t>Despliegue Cloud en Madrid: </a:t>
             </a:r>
             <a:r>
               <a:rPr sz="950">
@@ -20343,7 +20411,7 @@
                 </a:solidFill>
                 <a:latin typeface="Segoe UI"/>
               </a:rPr>
-              <a:t>Pipeline automatizado (pipeline_179.py) cruzando INE, Catastro y CKAN sin datos sintéticos.</a:t>
+              <a:t>Oracle Autonomous Database 23ai (eu-madrid-1) y Workspace APEX DATATHON.</a:t>
             </a:r>
           </a:p>
           <a:p>
@@ -20368,7 +20436,7 @@
                 </a:solidFill>
                 <a:latin typeface="Segoe UI"/>
               </a:rPr>
-              <a:t>Garantía anti-overfitting: </a:t>
+              <a:t>Agente IA y Anti-overfitting: </a:t>
             </a:r>
             <a:r>
               <a:rPr sz="950">
@@ -20377,7 +20445,7 @@
                 </a:solidFill>
                 <a:latin typeface="Segoe UI"/>
               </a:rPr>
-              <a:t>73 tests continuos en verde (fugas L1 a L7) y validación espacial GroupKFold por comarca.</a:t>
+              <a:t>Conector MCP (apex-mcp) para consultas inteligentes y 73 tests continuos en verde.</a:t>
             </a:r>
           </a:p>
         </p:txBody>

</xml_diff>

<commit_message>
docs(presentacion): visibiliza Oracle Autonomous 23ai Cloud y Oracle Wallet mTLS en slides 4, 7, 13 y 14
</commit_message>
<xml_diff>
--- a/presentacion_datathon_oficial.pptx
+++ b/presentacion_datathon_oficial.pptx
@@ -9874,7 +9874,7 @@
           <a:lstStyle/>
           <a:p>
             <a:pPr>
-              <a:defRPr sz="1200" b="1">
+              <a:defRPr sz="1700" b="1">
                 <a:solidFill>
                   <a:srgbClr val="FFFFFF"/>
                 </a:solidFill>
@@ -9882,15 +9882,12 @@
               </a:defRPr>
             </a:pPr>
             <a:r>
-              <a:t>Oracle Cloud 23ai y Agente IA con MCP (¡Desplegado!)</a:t>
+              <a:t>Oracle 23ai Cloud, Wallet mTLS y Agente IA con MCP (¡Desplegado!)</a:t>
             </a:r>
           </a:p>
           <a:p>
             <a:pPr>
-              <a:spcBef>
-                <a:spcPts val="200"/>
-              </a:spcBef>
-              <a:defRPr sz="1000">
+              <a:defRPr sz="1300">
                 <a:solidFill>
                   <a:srgbClr val="CBD5E1"/>
                 </a:solidFill>
@@ -9898,7 +9895,7 @@
               </a:defRPr>
             </a:pPr>
             <a:r>
-              <a:t>Desplegado en Oracle Autonomous Database 23ai (Región Madrid eu-madrid-1, mTLS) con APEX y conector estándar MCP (apex-mcp) para interacción con agentes de IA. Capa real de 155 municipios (&lt; 50k hab., 997.059 personas) con 0 nulos.</a:t>
+              <a:t>Desplegado en producción en Oracle Autonomous Database 23ai (Región Madrid eu-madrid-1) con autenticación mTLS por Oracle Wallet (cwallet.sso/ewallet.p12), Workspace APEX DATATHON y servidor MCP (apex-mcp) para interacción con agentes de IA. Capa real de 155 municipios (&lt; 50k hab., 997.059 personas) con 0 nulos.</a:t>
             </a:r>
           </a:p>
         </p:txBody>
@@ -10499,15 +10496,15 @@
           <a:lstStyle/>
           <a:p>
             <a:pPr>
-              <a:defRPr sz="1300" b="1">
-                <a:solidFill>
-                  <a:srgbClr val="C8102E"/>
+              <a:defRPr sz="1700" b="1">
+                <a:solidFill>
+                  <a:srgbClr val="C53030"/>
                 </a:solidFill>
                 <a:latin typeface="Segoe UI"/>
               </a:defRPr>
             </a:pPr>
             <a:r>
-              <a:t>¿Cómo se conecta con Oracle y qué agentes soporta?</a:t>
+              <a:t>¿Cómo funciona la Wallet de Oracle y qué agentes IA soporta?</a:t>
             </a:r>
           </a:p>
         </p:txBody>
@@ -10534,7 +10531,7 @@
           <a:lstStyle/>
           <a:p>
             <a:pPr>
-              <a:defRPr sz="950">
+              <a:defRPr sz="1300">
                 <a:solidFill>
                   <a:srgbClr val="475569"/>
                 </a:solidFill>
@@ -10542,13 +10539,7 @@
               </a:defRPr>
             </a:pPr>
             <a:r>
-              <a:rPr sz="1000">
-                <a:solidFill>
-                  <a:srgbClr val="475569"/>
-                </a:solidFill>
-                <a:latin typeface="Segoe UI"/>
-              </a:rPr>
-              <a:t>Conexión mTLS con Oracle Wallet a la región Madrid (eu-madrid-1), esquema WKSP_DATATHON y servidor estándar MCP (apex-mcp) para que agentes inteligentes ejecuten consultas y rankings en tiempo real.</a:t>
+              <a:t>Conexión cifrada mTLS mediante Oracle Client Wallet (cwallet.sso, ewallet.p12, válidos hasta 2031) a Oracle Autonomous 23ai en Madrid (eu-madrid-1). Aloja el esquema WKSP_DATATHON y expone un servidor estándar MCP (apex-mcp en opencode.json) para que agentes autónomos de IA consulten los 155 municipios en lenguaje natural.</a:t>
             </a:r>
           </a:p>
         </p:txBody>
@@ -16044,14 +16035,16 @@
           <a:bodyPr wrap="square" lIns="0" tIns="0" rIns="0" bIns="0" rtlCol="0" anchor="t"/>
           <a:lstStyle/>
           <a:p>
-            <a:r>
-              <a:rPr sz="950">
-                <a:solidFill>
-                  <a:srgbClr val="475569"/>
+            <a:pPr>
+              <a:defRPr sz="1100">
+                <a:solidFill>
+                  <a:srgbClr val="64748B"/>
                 </a:solidFill>
                 <a:latin typeface="Segoe UI"/>
-              </a:rPr>
-              <a:t>Piloto: 20 municipios (92 vars) · Cobertura regional en Git: 155 municipios &lt; 50k hab. (997.059 hab., 0 nulos) y 179 CAM (pipeline_179.py).</a:t>
+              </a:defRPr>
+            </a:pPr>
+            <a:r>
+              <a:t>Piloto: 20 municipios (92 vars) · Cobertura regional en Git: 155 municipios &lt; 50k hab. (997.059 hab., 0 nulos) y 179 CAM (pipeline_179.py) listos para Oracle 23ai Cloud vía Wallet mTLS.</a:t>
             </a:r>
           </a:p>
         </p:txBody>
@@ -17293,32 +17286,42 @@
           <a:p>
             <a:pPr indent="0" marL="0">
               <a:buNone/>
-              <a:defRPr sz="1200" b="1">
-                <a:solidFill>
-                  <a:srgbClr val="1E293B"/>
+              <a:defRPr sz="1300" b="1">
+                <a:solidFill>
+                  <a:srgbClr val="0F172A"/>
                 </a:solidFill>
                 <a:latin typeface="Segoe UI"/>
               </a:defRPr>
             </a:pPr>
             <a:r>
-              <a:t>Oracle APEX 23ai</a:t>
+              <a:t>Oracle APEX 23ai Cloud</a:t>
             </a:r>
             <a:endParaRPr lang="en-US" sz="1600" dirty="0"/>
           </a:p>
           <a:p>
             <a:pPr>
-              <a:spcBef>
-                <a:spcPts val="200"/>
-              </a:spcBef>
-              <a:defRPr sz="900">
-                <a:solidFill>
-                  <a:srgbClr val="475569"/>
+              <a:defRPr sz="950" b="1">
+                <a:solidFill>
+                  <a:srgbClr val="C53030"/>
                 </a:solidFill>
                 <a:latin typeface="Segoe UI"/>
               </a:defRPr>
             </a:pPr>
             <a:r>
-              <a:t>Autonomous DB (Madrid eu-madrid-1) · WKSP_DATATHON</a:t>
+              <a:t>Autonomous DB (eu-madrid-1) · Wallet mTLS</a:t>
+            </a:r>
+          </a:p>
+          <a:p>
+            <a:pPr>
+              <a:defRPr sz="900">
+                <a:solidFill>
+                  <a:srgbClr val="64748B"/>
+                </a:solidFill>
+                <a:latin typeface="Segoe UI"/>
+              </a:defRPr>
+            </a:pPr>
+            <a:r>
+              <a:t>Esquema: WKSP_DATATHON</a:t>
             </a:r>
           </a:p>
         </p:txBody>
@@ -17346,14 +17349,15 @@
           <a:p>
             <a:pPr indent="0" marL="0">
               <a:buNone/>
-            </a:pPr>
-            <a:r>
-              <a:rPr lang="en-US" sz="1400" dirty="0">
-                <a:solidFill>
-                  <a:schemeClr val="tx2"/>
-                </a:solidFill>
-              </a:rPr>
-              <a:t>Los tests comprueban que ambos producen los mismos pesos y rankings.</a:t>
+              <a:defRPr sz="1100">
+                <a:solidFill>
+                  <a:srgbClr val="475569"/>
+                </a:solidFill>
+                <a:latin typeface="Segoe UI"/>
+              </a:defRPr>
+            </a:pPr>
+            <a:r>
+              <a:t>Los tests comprueban paridad matemática exacta: Python (CSV) y Oracle 23ai (vía Wallet) producen los mismos rankings.</a:t>
             </a:r>
             <a:endParaRPr lang="en-US" sz="1400" dirty="0"/>
           </a:p>
@@ -17490,14 +17494,16 @@
           <a:bodyPr wrap="square" lIns="0" tIns="0" rIns="0" bIns="0" rtlCol="0" anchor="t"/>
           <a:lstStyle/>
           <a:p>
-            <a:r>
-              <a:rPr sz="950">
+            <a:pPr>
+              <a:defRPr sz="1050">
                 <a:solidFill>
                   <a:srgbClr val="CBD5E1"/>
                 </a:solidFill>
                 <a:latin typeface="Segoe UI"/>
-              </a:rPr>
-              <a:t>Oracle no guarda ningún dato personal: solo reglas en WKSP_DATATHON (cada hijo suma 0,05 a educación). Los datos del ciudadano son parámetros volátiles de sesión y nunca se escriben en disco (RGPD).</a:t>
+              </a:defRPr>
+            </a:pPr>
+            <a:r>
+              <a:t>Seguridad mTLS y privacidad estricta: Conexión cifrada mediante Oracle Client Wallet (cwallet.sso / ewallet.p12). Oracle no guarda ningún dato personal del ciudadano en disco (RGPD): solo reglas de ponderación en WKSP_DATATHON. Los datos del usuario son parámetros volátiles de sesión.</a:t>
             </a:r>
           </a:p>
         </p:txBody>
@@ -20016,9 +20022,9 @@
           <a:lstStyle/>
           <a:p>
             <a:pPr>
-              <a:defRPr sz="1200" b="1">
-                <a:solidFill>
-                  <a:srgbClr val="1E40AF"/>
+              <a:defRPr sz="1400" b="1">
+                <a:solidFill>
+                  <a:srgbClr val="1E3A8A"/>
                 </a:solidFill>
                 <a:latin typeface="Segoe UI"/>
               </a:defRPr>
@@ -20029,10 +20035,7 @@
           </a:p>
           <a:p>
             <a:pPr>
-              <a:spcBef>
-                <a:spcPts val="200"/>
-              </a:spcBef>
-              <a:defRPr sz="850">
+              <a:defRPr sz="1000">
                 <a:solidFill>
                   <a:srgbClr val="64748B"/>
                 </a:solidFill>
@@ -20040,7 +20043,7 @@
               </a:defRPr>
             </a:pPr>
             <a:r>
-              <a:t>http://localhost:8088/index.html · Backend Oracle 23ai (eu-madrid-1)</a:t>
+              <a:t>http://localhost:8088/index.html · Backend Oracle 23ai Cloud (eu-madrid-1)</a:t>
             </a:r>
           </a:p>
         </p:txBody>
@@ -20267,9 +20270,9 @@
           <a:lstStyle/>
           <a:p>
             <a:pPr>
-              <a:defRPr sz="1200" b="1">
-                <a:solidFill>
-                  <a:srgbClr val="166534"/>
+              <a:defRPr sz="1400" b="1">
+                <a:solidFill>
+                  <a:srgbClr val="134E4A"/>
                 </a:solidFill>
                 <a:latin typeface="Segoe UI"/>
               </a:defRPr>
@@ -20280,18 +20283,15 @@
           </a:p>
           <a:p>
             <a:pPr>
-              <a:spcBef>
-                <a:spcPts val="200"/>
-              </a:spcBef>
-              <a:defRPr sz="850">
-                <a:solidFill>
-                  <a:srgbClr val="64748B"/>
+              <a:defRPr sz="1000" b="1">
+                <a:solidFill>
+                  <a:srgbClr val="C53030"/>
                 </a:solidFill>
                 <a:latin typeface="Consolas"/>
               </a:defRPr>
             </a:pPr>
             <a:r>
-              <a:t>municipios_panel_validado.csv · Esquema Oracle WKSP_DATATHON</a:t>
+              <a:t>municipios_panel_validado.csv · Oracle Wallet mTLS · WKSP_DATATHON</a:t>
             </a:r>
           </a:p>
         </p:txBody>
@@ -20351,101 +20351,41 @@
               <a:spcBef>
                 <a:spcPts val="0"/>
               </a:spcBef>
-            </a:pPr>
-            <a:r>
-              <a:rPr sz="950" b="1">
-                <a:solidFill>
-                  <a:srgbClr val="166534"/>
+              <a:defRPr sz="1200">
+                <a:solidFill>
+                  <a:srgbClr val="0F172A"/>
                 </a:solidFill>
                 <a:latin typeface="Segoe UI"/>
-              </a:rPr>
-              <a:t>• </a:t>
-            </a:r>
-            <a:r>
-              <a:rPr sz="950" b="1">
-                <a:solidFill>
-                  <a:srgbClr val="1E293B"/>
+              </a:defRPr>
+            </a:pPr>
+            <a:r>
+              <a:t>• Cobertura regional oficial: 20 piloto (92 vars) + 155 municipios &lt; 50k (997.059 hab.) con 0 nulos.</a:t>
+            </a:r>
+          </a:p>
+          <a:p>
+            <a:pPr>
+              <a:defRPr sz="1200" b="1">
+                <a:solidFill>
+                  <a:srgbClr val="0F172A"/>
                 </a:solidFill>
                 <a:latin typeface="Segoe UI"/>
-              </a:rPr>
-              <a:t>Cobertura regional oficial: </a:t>
-            </a:r>
-            <a:r>
-              <a:rPr sz="950">
-                <a:solidFill>
-                  <a:srgbClr val="475569"/>
+              </a:defRPr>
+            </a:pPr>
+            <a:r>
+              <a:t>• Despliegue Oracle 23ai Cloud: Base de datos Autonomous (eu-madrid-1), autenticación mTLS vía Oracle Wallet (cwallet.sso) y APEX DATATHON.</a:t>
+            </a:r>
+          </a:p>
+          <a:p>
+            <a:pPr>
+              <a:defRPr sz="1200">
+                <a:solidFill>
+                  <a:srgbClr val="0F172A"/>
                 </a:solidFill>
                 <a:latin typeface="Segoe UI"/>
-              </a:rPr>
-              <a:t>20 piloto (92 vars) + 155 municipios &lt; 50k (997.059 hab.) con 0 nulos.</a:t>
-            </a:r>
-          </a:p>
-          <a:p>
-            <a:pPr>
-              <a:spcBef>
-                <a:spcPts val="300"/>
-              </a:spcBef>
-            </a:pPr>
-            <a:r>
-              <a:rPr sz="950" b="1">
-                <a:solidFill>
-                  <a:srgbClr val="166534"/>
-                </a:solidFill>
-                <a:latin typeface="Segoe UI"/>
-              </a:rPr>
-              <a:t>• </a:t>
-            </a:r>
-            <a:r>
-              <a:rPr sz="950" b="1">
-                <a:solidFill>
-                  <a:srgbClr val="1E293B"/>
-                </a:solidFill>
-                <a:latin typeface="Segoe UI"/>
-              </a:rPr>
-              <a:t>Despliegue Cloud en Madrid: </a:t>
-            </a:r>
-            <a:r>
-              <a:rPr sz="950">
-                <a:solidFill>
-                  <a:srgbClr val="475569"/>
-                </a:solidFill>
-                <a:latin typeface="Segoe UI"/>
-              </a:rPr>
-              <a:t>Oracle Autonomous Database 23ai (eu-madrid-1) y Workspace APEX DATATHON.</a:t>
-            </a:r>
-          </a:p>
-          <a:p>
-            <a:pPr>
-              <a:spcBef>
-                <a:spcPts val="300"/>
-              </a:spcBef>
-            </a:pPr>
-            <a:r>
-              <a:rPr sz="950" b="1">
-                <a:solidFill>
-                  <a:srgbClr val="166534"/>
-                </a:solidFill>
-                <a:latin typeface="Segoe UI"/>
-              </a:rPr>
-              <a:t>• </a:t>
-            </a:r>
-            <a:r>
-              <a:rPr sz="950" b="1">
-                <a:solidFill>
-                  <a:srgbClr val="1E293B"/>
-                </a:solidFill>
-                <a:latin typeface="Segoe UI"/>
-              </a:rPr>
-              <a:t>Agente IA y Anti-overfitting: </a:t>
-            </a:r>
-            <a:r>
-              <a:rPr sz="950">
-                <a:solidFill>
-                  <a:srgbClr val="475569"/>
-                </a:solidFill>
-                <a:latin typeface="Segoe UI"/>
-              </a:rPr>
-              <a:t>Conector MCP (apex-mcp) para consultas inteligentes y 73 tests continuos en verde.</a:t>
+              </a:defRPr>
+            </a:pPr>
+            <a:r>
+              <a:t>• Agente IA con MCP (apex-mcp): Servidor MCP conectado por Wallet para que asistentes de IA consulten los 155 municipios en tiempo real.</a:t>
             </a:r>
           </a:p>
         </p:txBody>

</xml_diff>